<commit_message>
Sort components chart by completeness and drive its numbers from the chart data
- chart workbook sorts rows by fact/plan descending with formulas
- fact | plan | % labels are cell-linked data labels inside the chart
- percent turns green at 90% and above, amber below, automatically
- removed the five manual text columns

Co-Authored-By: Claude Sonnet 5.5 <noreply@anthropic.com>
Claude-Session: https://claude.ai/code/session_01NEsYnofsV4CojKrpDNMyGk
</commit_message>
<xml_diff>
--- a/digital_twin_resources.pptx
+++ b/digital_twin_resources.pptx
@@ -590,9 +590,9 @@
           <c:layoutTarget val="inner"/>
           <c:xMode val="edge"/>
           <c:yMode val="edge"/>
-          <c:x val="0.46"/>
+          <c:x val="0.3458"/>
           <c:y val="0"/>
-          <c:w val="0.52"/>
+          <c:w val="0.6442"/>
           <c:h val="1"/>
         </c:manualLayout>
       </c:layout>
@@ -605,7 +605,7 @@
           <c:order val="0"/>
           <c:tx>
             <c:strRef>
-              <c:f>Лист1!$B$1</c:f>
+              <c:f>Лист1!$N$1</c:f>
               <c:strCache>
                 <c:ptCount val="1"/>
                 <c:pt idx="0">
@@ -625,11 +625,11 @@
           <c:invertIfNegative val="0"/>
           <c:cat>
             <c:strRef>
-              <c:f>Лист1!$A$2:$A$8</c:f>
+              <c:f>Лист1!$M$2:$M$8</c:f>
               <c:strCache>
                 <c:ptCount val="7"/>
                 <c:pt idx="0">
-                  <c:v>Мотивационный профиль</c:v>
+                  <c:v>Правовая обвязка</c:v>
                 </c:pt>
                 <c:pt idx="1">
                   <c:v>Агент ЦД</c:v>
@@ -638,28 +638,28 @@
                   <c:v>Память и контекст</c:v>
                 </c:pt>
                 <c:pt idx="3">
+                  <c:v>Foundation Model</c:v>
+                </c:pt>
+                <c:pt idx="4">
+                  <c:v>Бизнес-тестирование</c:v>
+                </c:pt>
+                <c:pt idx="5">
+                  <c:v>Мотивационный профиль</c:v>
+                </c:pt>
+                <c:pt idx="6">
                   <c:v>Поставка данных</c:v>
-                </c:pt>
-                <c:pt idx="4">
-                  <c:v>Foundation Model</c:v>
-                </c:pt>
-                <c:pt idx="5">
-                  <c:v>Бизнес-тестирование</c:v>
-                </c:pt>
-                <c:pt idx="6">
-                  <c:v>Правовая обвязка</c:v>
                 </c:pt>
               </c:strCache>
             </c:strRef>
           </c:cat>
           <c:val>
             <c:numRef>
-              <c:f>Лист1!$B$2:$B$8</c:f>
+              <c:f>Лист1!$N$2:$N$8</c:f>
               <c:numCache>
                 <c:formatCode>General</c:formatCode>
                 <c:ptCount val="7"/>
                 <c:pt idx="0">
-                  <c:v>9</c:v>
+                  <c:v>3</c:v>
                 </c:pt>
                 <c:pt idx="1">
                   <c:v>20</c:v>
@@ -668,32 +668,27 @@
                   <c:v>29</c:v>
                 </c:pt>
                 <c:pt idx="3">
+                  <c:v>34</c:v>
+                </c:pt>
+                <c:pt idx="4">
+                  <c:v>7</c:v>
+                </c:pt>
+                <c:pt idx="5">
+                  <c:v>9</c:v>
+                </c:pt>
+                <c:pt idx="6">
                   <c:v>16</c:v>
-                </c:pt>
-                <c:pt idx="4">
-                  <c:v>34</c:v>
-                </c:pt>
-                <c:pt idx="5">
-                  <c:v>7</c:v>
-                </c:pt>
-                <c:pt idx="6">
-                  <c:v>3</c:v>
                 </c:pt>
               </c:numCache>
             </c:numRef>
           </c:val>
-          <c:extLst>
-            <c:ext xmlns:c16="http://schemas.microsoft.com/office/drawing/2014/chart" uri="{C3380CC4-5D6E-409C-BE32-E72D297353CC}">
-              <c16:uniqueId val="{00000000-B77F-944F-9DC8-A94FF971215C}"/>
-            </c:ext>
-          </c:extLst>
         </c:ser>
         <c:ser>
           <c:idx val="1"/>
           <c:order val="1"/>
           <c:tx>
             <c:strRef>
-              <c:f>Лист1!$C$1</c:f>
+              <c:f>Лист1!$O$1</c:f>
               <c:strCache>
                 <c:ptCount val="1"/>
                 <c:pt idx="0">
@@ -718,11 +713,11 @@
           <c:invertIfNegative val="0"/>
           <c:cat>
             <c:strRef>
-              <c:f>Лист1!$A$2:$A$8</c:f>
+              <c:f>Лист1!$M$2:$M$8</c:f>
               <c:strCache>
                 <c:ptCount val="7"/>
                 <c:pt idx="0">
-                  <c:v>Мотивационный профиль</c:v>
+                  <c:v>Правовая обвязка</c:v>
                 </c:pt>
                 <c:pt idx="1">
                   <c:v>Агент ЦД</c:v>
@@ -731,28 +726,28 @@
                   <c:v>Память и контекст</c:v>
                 </c:pt>
                 <c:pt idx="3">
+                  <c:v>Foundation Model</c:v>
+                </c:pt>
+                <c:pt idx="4">
+                  <c:v>Бизнес-тестирование</c:v>
+                </c:pt>
+                <c:pt idx="5">
+                  <c:v>Мотивационный профиль</c:v>
+                </c:pt>
+                <c:pt idx="6">
                   <c:v>Поставка данных</c:v>
-                </c:pt>
-                <c:pt idx="4">
-                  <c:v>Foundation Model</c:v>
-                </c:pt>
-                <c:pt idx="5">
-                  <c:v>Бизнес-тестирование</c:v>
-                </c:pt>
-                <c:pt idx="6">
-                  <c:v>Правовая обвязка</c:v>
                 </c:pt>
               </c:strCache>
             </c:strRef>
           </c:cat>
           <c:val>
             <c:numRef>
-              <c:f>Лист1!$C$2:$C$8</c:f>
+              <c:f>Лист1!$O$2:$O$8</c:f>
               <c:numCache>
                 <c:formatCode>General</c:formatCode>
                 <c:ptCount val="7"/>
                 <c:pt idx="0">
-                  <c:v>2</c:v>
+                  <c:v>0</c:v>
                 </c:pt>
                 <c:pt idx="1">
                   <c:v>1</c:v>
@@ -761,25 +756,1717 @@
                   <c:v>2</c:v>
                 </c:pt>
                 <c:pt idx="3">
+                  <c:v>3</c:v>
+                </c:pt>
+                <c:pt idx="4">
+                  <c:v>1</c:v>
+                </c:pt>
+                <c:pt idx="5">
+                  <c:v>2</c:v>
+                </c:pt>
+                <c:pt idx="6">
                   <c:v>4</c:v>
-                </c:pt>
-                <c:pt idx="4">
-                  <c:v>3</c:v>
-                </c:pt>
-                <c:pt idx="5">
-                  <c:v>1</c:v>
-                </c:pt>
-                <c:pt idx="6">
-                  <c:v>0</c:v>
                 </c:pt>
               </c:numCache>
             </c:numRef>
           </c:val>
-          <c:extLst>
-            <c:ext xmlns:c16="http://schemas.microsoft.com/office/drawing/2014/chart" uri="{C3380CC4-5D6E-409C-BE32-E72D297353CC}">
-              <c16:uniqueId val="{00000001-B77F-944F-9DC8-A94FF971215C}"/>
-            </c:ext>
-          </c:extLst>
+        </c:ser>
+        <c:ser>
+          <c:idx val="2"/>
+          <c:order val="2"/>
+          <c:tx>
+            <c:strRef>
+              <c:f>Лист1!$R$1</c:f>
+              <c:strCache>
+                <c:ptCount val="1"/>
+                <c:pt idx="0">
+                  <c:v>Отступ (служебный)</c:v>
+                </c:pt>
+              </c:strCache>
+            </c:strRef>
+          </c:tx>
+          <c:spPr>
+            <a:noFill/>
+            <a:ln>
+              <a:noFill/>
+            </a:ln>
+          </c:spPr>
+          <c:invertIfNegative val="0"/>
+          <c:cat>
+            <c:strRef>
+              <c:f>Лист1!$M$2:$M$8</c:f>
+              <c:strCache>
+                <c:ptCount val="7"/>
+                <c:pt idx="0">
+                  <c:v>Правовая обвязка</c:v>
+                </c:pt>
+                <c:pt idx="1">
+                  <c:v>Агент ЦД</c:v>
+                </c:pt>
+                <c:pt idx="2">
+                  <c:v>Память и контекст</c:v>
+                </c:pt>
+                <c:pt idx="3">
+                  <c:v>Foundation Model</c:v>
+                </c:pt>
+                <c:pt idx="4">
+                  <c:v>Бизнес-тестирование</c:v>
+                </c:pt>
+                <c:pt idx="5">
+                  <c:v>Мотивационный профиль</c:v>
+                </c:pt>
+                <c:pt idx="6">
+                  <c:v>Поставка данных</c:v>
+                </c:pt>
+              </c:strCache>
+            </c:strRef>
+          </c:cat>
+          <c:val>
+            <c:numRef>
+              <c:f>Лист1!$R$2:$R$8</c:f>
+              <c:numCache>
+                <c:formatCode>General</c:formatCode>
+                <c:ptCount val="7"/>
+                <c:pt idx="0">
+                  <c:v>35.480000000000004</c:v>
+                </c:pt>
+                <c:pt idx="1">
+                  <c:v>17.480000000000004</c:v>
+                </c:pt>
+                <c:pt idx="2">
+                  <c:v>7.480000000000004</c:v>
+                </c:pt>
+                <c:pt idx="3">
+                  <c:v>1.480000000000004</c:v>
+                </c:pt>
+                <c:pt idx="4">
+                  <c:v>30.480000000000004</c:v>
+                </c:pt>
+                <c:pt idx="5">
+                  <c:v>27.480000000000004</c:v>
+                </c:pt>
+                <c:pt idx="6">
+                  <c:v>18.480000000000004</c:v>
+                </c:pt>
+              </c:numCache>
+            </c:numRef>
+          </c:val>
+        </c:ser>
+        <c:ser>
+          <c:idx val="3"/>
+          <c:order val="3"/>
+          <c:tx>
+            <c:strRef>
+              <c:f>Лист1!$S$1</c:f>
+              <c:strCache>
+                <c:ptCount val="1"/>
+                <c:pt idx="0">
+                  <c:v>Ширина подписи 1</c:v>
+                </c:pt>
+              </c:strCache>
+            </c:strRef>
+          </c:tx>
+          <c:spPr>
+            <a:noFill/>
+            <a:ln>
+              <a:noFill/>
+            </a:ln>
+          </c:spPr>
+          <c:invertIfNegative val="0"/>
+          <c:dLbls>
+            <c:dLbl>
+              <c:idx val="0"/>
+              <c:layout/>
+              <c:tx>
+                <c:strRef>
+                  <c:f>Лист1!$T$2</c:f>
+                  <c:strCache>
+                    <c:ptCount val="1"/>
+                    <c:pt idx="0">
+                      <c:v>3</c:v>
+                    </c:pt>
+                  </c:strCache>
+                </c:strRef>
+              </c:tx>
+              <c:spPr>
+                <a:noFill/>
+                <a:ln>
+                  <a:noFill/>
+                </a:ln>
+              </c:spPr>
+              <c:txPr>
+                <a:bodyPr wrap="none" lIns="0" tIns="0" rIns="0" bIns="0" anchor="ctr"/>
+                <a:lstStyle/>
+                <a:p>
+                  <a:pPr>
+                    <a:defRPr sz="1050" b="1">
+                      <a:solidFill>
+                        <a:schemeClr val="accent3"/>
+                      </a:solidFill>
+                    </a:defRPr>
+                  </a:pPr>
+                  <a:endParaRPr lang="ru-RU"/>
+                </a:p>
+              </c:txPr>
+              <c:dLblPos val="ctr"/>
+              <c:showLegendKey val="0"/>
+              <c:showVal val="1"/>
+              <c:showCatName val="0"/>
+              <c:showSerName val="0"/>
+              <c:showPercent val="0"/>
+              <c:showBubbleSize val="0"/>
+            </c:dLbl>
+            <c:dLbl>
+              <c:idx val="1"/>
+              <c:layout/>
+              <c:tx>
+                <c:strRef>
+                  <c:f>Лист1!$T$3</c:f>
+                  <c:strCache>
+                    <c:ptCount val="1"/>
+                    <c:pt idx="0">
+                      <c:v>20</c:v>
+                    </c:pt>
+                  </c:strCache>
+                </c:strRef>
+              </c:tx>
+              <c:spPr>
+                <a:noFill/>
+                <a:ln>
+                  <a:noFill/>
+                </a:ln>
+              </c:spPr>
+              <c:txPr>
+                <a:bodyPr wrap="none" lIns="0" tIns="0" rIns="0" bIns="0" anchor="ctr"/>
+                <a:lstStyle/>
+                <a:p>
+                  <a:pPr>
+                    <a:defRPr sz="1050" b="1">
+                      <a:solidFill>
+                        <a:schemeClr val="accent3"/>
+                      </a:solidFill>
+                    </a:defRPr>
+                  </a:pPr>
+                  <a:endParaRPr lang="ru-RU"/>
+                </a:p>
+              </c:txPr>
+              <c:dLblPos val="ctr"/>
+              <c:showLegendKey val="0"/>
+              <c:showVal val="1"/>
+              <c:showCatName val="0"/>
+              <c:showSerName val="0"/>
+              <c:showPercent val="0"/>
+              <c:showBubbleSize val="0"/>
+            </c:dLbl>
+            <c:dLbl>
+              <c:idx val="2"/>
+              <c:layout/>
+              <c:tx>
+                <c:strRef>
+                  <c:f>Лист1!$T$4</c:f>
+                  <c:strCache>
+                    <c:ptCount val="1"/>
+                    <c:pt idx="0">
+                      <c:v>29</c:v>
+                    </c:pt>
+                  </c:strCache>
+                </c:strRef>
+              </c:tx>
+              <c:spPr>
+                <a:noFill/>
+                <a:ln>
+                  <a:noFill/>
+                </a:ln>
+              </c:spPr>
+              <c:txPr>
+                <a:bodyPr wrap="none" lIns="0" tIns="0" rIns="0" bIns="0" anchor="ctr"/>
+                <a:lstStyle/>
+                <a:p>
+                  <a:pPr>
+                    <a:defRPr sz="1050" b="1">
+                      <a:solidFill>
+                        <a:schemeClr val="accent3"/>
+                      </a:solidFill>
+                    </a:defRPr>
+                  </a:pPr>
+                  <a:endParaRPr lang="ru-RU"/>
+                </a:p>
+              </c:txPr>
+              <c:dLblPos val="ctr"/>
+              <c:showLegendKey val="0"/>
+              <c:showVal val="1"/>
+              <c:showCatName val="0"/>
+              <c:showSerName val="0"/>
+              <c:showPercent val="0"/>
+              <c:showBubbleSize val="0"/>
+            </c:dLbl>
+            <c:dLbl>
+              <c:idx val="3"/>
+              <c:layout/>
+              <c:tx>
+                <c:strRef>
+                  <c:f>Лист1!$T$5</c:f>
+                  <c:strCache>
+                    <c:ptCount val="1"/>
+                    <c:pt idx="0">
+                      <c:v>34</c:v>
+                    </c:pt>
+                  </c:strCache>
+                </c:strRef>
+              </c:tx>
+              <c:spPr>
+                <a:noFill/>
+                <a:ln>
+                  <a:noFill/>
+                </a:ln>
+              </c:spPr>
+              <c:txPr>
+                <a:bodyPr wrap="none" lIns="0" tIns="0" rIns="0" bIns="0" anchor="ctr"/>
+                <a:lstStyle/>
+                <a:p>
+                  <a:pPr>
+                    <a:defRPr sz="1050" b="1">
+                      <a:solidFill>
+                        <a:schemeClr val="accent3"/>
+                      </a:solidFill>
+                    </a:defRPr>
+                  </a:pPr>
+                  <a:endParaRPr lang="ru-RU"/>
+                </a:p>
+              </c:txPr>
+              <c:dLblPos val="ctr"/>
+              <c:showLegendKey val="0"/>
+              <c:showVal val="1"/>
+              <c:showCatName val="0"/>
+              <c:showSerName val="0"/>
+              <c:showPercent val="0"/>
+              <c:showBubbleSize val="0"/>
+            </c:dLbl>
+            <c:dLbl>
+              <c:idx val="4"/>
+              <c:layout/>
+              <c:tx>
+                <c:strRef>
+                  <c:f>Лист1!$T$6</c:f>
+                  <c:strCache>
+                    <c:ptCount val="1"/>
+                    <c:pt idx="0">
+                      <c:v>7</c:v>
+                    </c:pt>
+                  </c:strCache>
+                </c:strRef>
+              </c:tx>
+              <c:spPr>
+                <a:noFill/>
+                <a:ln>
+                  <a:noFill/>
+                </a:ln>
+              </c:spPr>
+              <c:txPr>
+                <a:bodyPr wrap="none" lIns="0" tIns="0" rIns="0" bIns="0" anchor="ctr"/>
+                <a:lstStyle/>
+                <a:p>
+                  <a:pPr>
+                    <a:defRPr sz="1050" b="1">
+                      <a:solidFill>
+                        <a:schemeClr val="accent3"/>
+                      </a:solidFill>
+                    </a:defRPr>
+                  </a:pPr>
+                  <a:endParaRPr lang="ru-RU"/>
+                </a:p>
+              </c:txPr>
+              <c:dLblPos val="ctr"/>
+              <c:showLegendKey val="0"/>
+              <c:showVal val="1"/>
+              <c:showCatName val="0"/>
+              <c:showSerName val="0"/>
+              <c:showPercent val="0"/>
+              <c:showBubbleSize val="0"/>
+            </c:dLbl>
+            <c:dLbl>
+              <c:idx val="5"/>
+              <c:layout/>
+              <c:tx>
+                <c:strRef>
+                  <c:f>Лист1!$T$7</c:f>
+                  <c:strCache>
+                    <c:ptCount val="1"/>
+                    <c:pt idx="0">
+                      <c:v>9</c:v>
+                    </c:pt>
+                  </c:strCache>
+                </c:strRef>
+              </c:tx>
+              <c:spPr>
+                <a:noFill/>
+                <a:ln>
+                  <a:noFill/>
+                </a:ln>
+              </c:spPr>
+              <c:txPr>
+                <a:bodyPr wrap="none" lIns="0" tIns="0" rIns="0" bIns="0" anchor="ctr"/>
+                <a:lstStyle/>
+                <a:p>
+                  <a:pPr>
+                    <a:defRPr sz="1050" b="1">
+                      <a:solidFill>
+                        <a:schemeClr val="accent3"/>
+                      </a:solidFill>
+                    </a:defRPr>
+                  </a:pPr>
+                  <a:endParaRPr lang="ru-RU"/>
+                </a:p>
+              </c:txPr>
+              <c:dLblPos val="ctr"/>
+              <c:showLegendKey val="0"/>
+              <c:showVal val="1"/>
+              <c:showCatName val="0"/>
+              <c:showSerName val="0"/>
+              <c:showPercent val="0"/>
+              <c:showBubbleSize val="0"/>
+            </c:dLbl>
+            <c:dLbl>
+              <c:idx val="6"/>
+              <c:layout/>
+              <c:tx>
+                <c:strRef>
+                  <c:f>Лист1!$T$8</c:f>
+                  <c:strCache>
+                    <c:ptCount val="1"/>
+                    <c:pt idx="0">
+                      <c:v>16</c:v>
+                    </c:pt>
+                  </c:strCache>
+                </c:strRef>
+              </c:tx>
+              <c:spPr>
+                <a:noFill/>
+                <a:ln>
+                  <a:noFill/>
+                </a:ln>
+              </c:spPr>
+              <c:txPr>
+                <a:bodyPr wrap="none" lIns="0" tIns="0" rIns="0" bIns="0" anchor="ctr"/>
+                <a:lstStyle/>
+                <a:p>
+                  <a:pPr>
+                    <a:defRPr sz="1050" b="1">
+                      <a:solidFill>
+                        <a:schemeClr val="accent3"/>
+                      </a:solidFill>
+                    </a:defRPr>
+                  </a:pPr>
+                  <a:endParaRPr lang="ru-RU"/>
+                </a:p>
+              </c:txPr>
+              <c:dLblPos val="ctr"/>
+              <c:showLegendKey val="0"/>
+              <c:showVal val="1"/>
+              <c:showCatName val="0"/>
+              <c:showSerName val="0"/>
+              <c:showPercent val="0"/>
+              <c:showBubbleSize val="0"/>
+            </c:dLbl>
+            <c:spPr>
+              <a:noFill/>
+              <a:ln>
+                <a:noFill/>
+              </a:ln>
+            </c:spPr>
+            <c:txPr>
+              <a:bodyPr wrap="none" lIns="0" tIns="0" rIns="0" bIns="0" anchor="ctr"/>
+              <a:lstStyle/>
+              <a:p>
+                <a:pPr>
+                  <a:defRPr sz="1050" b="1">
+                    <a:solidFill>
+                      <a:schemeClr val="accent3"/>
+                    </a:solidFill>
+                  </a:defRPr>
+                </a:pPr>
+                <a:endParaRPr lang="ru-RU"/>
+              </a:p>
+            </c:txPr>
+            <c:dLblPos val="ctr"/>
+            <c:showLegendKey val="0"/>
+            <c:showVal val="1"/>
+            <c:showCatName val="0"/>
+            <c:showSerName val="0"/>
+            <c:showPercent val="0"/>
+            <c:showBubbleSize val="0"/>
+          </c:dLbls>
+          <c:cat>
+            <c:strRef>
+              <c:f>Лист1!$M$2:$M$8</c:f>
+              <c:strCache>
+                <c:ptCount val="7"/>
+                <c:pt idx="0">
+                  <c:v>Правовая обвязка</c:v>
+                </c:pt>
+                <c:pt idx="1">
+                  <c:v>Агент ЦД</c:v>
+                </c:pt>
+                <c:pt idx="2">
+                  <c:v>Память и контекст</c:v>
+                </c:pt>
+                <c:pt idx="3">
+                  <c:v>Foundation Model</c:v>
+                </c:pt>
+                <c:pt idx="4">
+                  <c:v>Бизнес-тестирование</c:v>
+                </c:pt>
+                <c:pt idx="5">
+                  <c:v>Мотивационный профиль</c:v>
+                </c:pt>
+                <c:pt idx="6">
+                  <c:v>Поставка данных</c:v>
+                </c:pt>
+              </c:strCache>
+            </c:strRef>
+          </c:cat>
+          <c:val>
+            <c:numRef>
+              <c:f>Лист1!$S$2:$S$8</c:f>
+              <c:numCache>
+                <c:formatCode>General</c:formatCode>
+                <c:ptCount val="7"/>
+                <c:pt idx="0">
+                  <c:v>4.4399999999999995</c:v>
+                </c:pt>
+                <c:pt idx="1">
+                  <c:v>4.4399999999999995</c:v>
+                </c:pt>
+                <c:pt idx="2">
+                  <c:v>4.4399999999999995</c:v>
+                </c:pt>
+                <c:pt idx="3">
+                  <c:v>4.4399999999999995</c:v>
+                </c:pt>
+                <c:pt idx="4">
+                  <c:v>4.4399999999999995</c:v>
+                </c:pt>
+                <c:pt idx="5">
+                  <c:v>4.4399999999999995</c:v>
+                </c:pt>
+                <c:pt idx="6">
+                  <c:v>4.4399999999999995</c:v>
+                </c:pt>
+              </c:numCache>
+            </c:numRef>
+          </c:val>
+        </c:ser>
+        <c:ser>
+          <c:idx val="4"/>
+          <c:order val="4"/>
+          <c:tx>
+            <c:strRef>
+              <c:f>Лист1!$U$1</c:f>
+              <c:strCache>
+                <c:ptCount val="1"/>
+                <c:pt idx="0">
+                  <c:v>Ширина подписи 2</c:v>
+                </c:pt>
+              </c:strCache>
+            </c:strRef>
+          </c:tx>
+          <c:spPr>
+            <a:noFill/>
+            <a:ln>
+              <a:noFill/>
+            </a:ln>
+          </c:spPr>
+          <c:invertIfNegative val="0"/>
+          <c:dLbls>
+            <c:dLbl>
+              <c:idx val="0"/>
+              <c:layout/>
+              <c:tx>
+                <c:strRef>
+                  <c:f>Лист1!$V$2</c:f>
+                  <c:strCache>
+                    <c:ptCount val="1"/>
+                    <c:pt idx="0">
+                      <c:v>| 3</c:v>
+                    </c:pt>
+                  </c:strCache>
+                </c:strRef>
+              </c:tx>
+              <c:spPr>
+                <a:noFill/>
+                <a:ln>
+                  <a:noFill/>
+                </a:ln>
+              </c:spPr>
+              <c:txPr>
+                <a:bodyPr wrap="none" lIns="0" tIns="0" rIns="0" bIns="0" anchor="ctr"/>
+                <a:lstStyle/>
+                <a:p>
+                  <a:pPr>
+                    <a:defRPr sz="1050" b="1">
+                      <a:solidFill>
+                        <a:srgbClr val="7B8794"/>
+                      </a:solidFill>
+                    </a:defRPr>
+                  </a:pPr>
+                  <a:endParaRPr lang="ru-RU"/>
+                </a:p>
+              </c:txPr>
+              <c:dLblPos val="ctr"/>
+              <c:showLegendKey val="0"/>
+              <c:showVal val="1"/>
+              <c:showCatName val="0"/>
+              <c:showSerName val="0"/>
+              <c:showPercent val="0"/>
+              <c:showBubbleSize val="0"/>
+            </c:dLbl>
+            <c:dLbl>
+              <c:idx val="1"/>
+              <c:layout/>
+              <c:tx>
+                <c:strRef>
+                  <c:f>Лист1!$V$3</c:f>
+                  <c:strCache>
+                    <c:ptCount val="1"/>
+                    <c:pt idx="0">
+                      <c:v>| 21</c:v>
+                    </c:pt>
+                  </c:strCache>
+                </c:strRef>
+              </c:tx>
+              <c:spPr>
+                <a:noFill/>
+                <a:ln>
+                  <a:noFill/>
+                </a:ln>
+              </c:spPr>
+              <c:txPr>
+                <a:bodyPr wrap="none" lIns="0" tIns="0" rIns="0" bIns="0" anchor="ctr"/>
+                <a:lstStyle/>
+                <a:p>
+                  <a:pPr>
+                    <a:defRPr sz="1050" b="1">
+                      <a:solidFill>
+                        <a:srgbClr val="7B8794"/>
+                      </a:solidFill>
+                    </a:defRPr>
+                  </a:pPr>
+                  <a:endParaRPr lang="ru-RU"/>
+                </a:p>
+              </c:txPr>
+              <c:dLblPos val="ctr"/>
+              <c:showLegendKey val="0"/>
+              <c:showVal val="1"/>
+              <c:showCatName val="0"/>
+              <c:showSerName val="0"/>
+              <c:showPercent val="0"/>
+              <c:showBubbleSize val="0"/>
+            </c:dLbl>
+            <c:dLbl>
+              <c:idx val="2"/>
+              <c:layout/>
+              <c:tx>
+                <c:strRef>
+                  <c:f>Лист1!$V$4</c:f>
+                  <c:strCache>
+                    <c:ptCount val="1"/>
+                    <c:pt idx="0">
+                      <c:v>| 31</c:v>
+                    </c:pt>
+                  </c:strCache>
+                </c:strRef>
+              </c:tx>
+              <c:spPr>
+                <a:noFill/>
+                <a:ln>
+                  <a:noFill/>
+                </a:ln>
+              </c:spPr>
+              <c:txPr>
+                <a:bodyPr wrap="none" lIns="0" tIns="0" rIns="0" bIns="0" anchor="ctr"/>
+                <a:lstStyle/>
+                <a:p>
+                  <a:pPr>
+                    <a:defRPr sz="1050" b="1">
+                      <a:solidFill>
+                        <a:srgbClr val="7B8794"/>
+                      </a:solidFill>
+                    </a:defRPr>
+                  </a:pPr>
+                  <a:endParaRPr lang="ru-RU"/>
+                </a:p>
+              </c:txPr>
+              <c:dLblPos val="ctr"/>
+              <c:showLegendKey val="0"/>
+              <c:showVal val="1"/>
+              <c:showCatName val="0"/>
+              <c:showSerName val="0"/>
+              <c:showPercent val="0"/>
+              <c:showBubbleSize val="0"/>
+            </c:dLbl>
+            <c:dLbl>
+              <c:idx val="3"/>
+              <c:layout/>
+              <c:tx>
+                <c:strRef>
+                  <c:f>Лист1!$V$5</c:f>
+                  <c:strCache>
+                    <c:ptCount val="1"/>
+                    <c:pt idx="0">
+                      <c:v>| 37</c:v>
+                    </c:pt>
+                  </c:strCache>
+                </c:strRef>
+              </c:tx>
+              <c:spPr>
+                <a:noFill/>
+                <a:ln>
+                  <a:noFill/>
+                </a:ln>
+              </c:spPr>
+              <c:txPr>
+                <a:bodyPr wrap="none" lIns="0" tIns="0" rIns="0" bIns="0" anchor="ctr"/>
+                <a:lstStyle/>
+                <a:p>
+                  <a:pPr>
+                    <a:defRPr sz="1050" b="1">
+                      <a:solidFill>
+                        <a:srgbClr val="7B8794"/>
+                      </a:solidFill>
+                    </a:defRPr>
+                  </a:pPr>
+                  <a:endParaRPr lang="ru-RU"/>
+                </a:p>
+              </c:txPr>
+              <c:dLblPos val="ctr"/>
+              <c:showLegendKey val="0"/>
+              <c:showVal val="1"/>
+              <c:showCatName val="0"/>
+              <c:showSerName val="0"/>
+              <c:showPercent val="0"/>
+              <c:showBubbleSize val="0"/>
+            </c:dLbl>
+            <c:dLbl>
+              <c:idx val="4"/>
+              <c:layout/>
+              <c:tx>
+                <c:strRef>
+                  <c:f>Лист1!$V$6</c:f>
+                  <c:strCache>
+                    <c:ptCount val="1"/>
+                    <c:pt idx="0">
+                      <c:v>| 8</c:v>
+                    </c:pt>
+                  </c:strCache>
+                </c:strRef>
+              </c:tx>
+              <c:spPr>
+                <a:noFill/>
+                <a:ln>
+                  <a:noFill/>
+                </a:ln>
+              </c:spPr>
+              <c:txPr>
+                <a:bodyPr wrap="none" lIns="0" tIns="0" rIns="0" bIns="0" anchor="ctr"/>
+                <a:lstStyle/>
+                <a:p>
+                  <a:pPr>
+                    <a:defRPr sz="1050" b="1">
+                      <a:solidFill>
+                        <a:srgbClr val="7B8794"/>
+                      </a:solidFill>
+                    </a:defRPr>
+                  </a:pPr>
+                  <a:endParaRPr lang="ru-RU"/>
+                </a:p>
+              </c:txPr>
+              <c:dLblPos val="ctr"/>
+              <c:showLegendKey val="0"/>
+              <c:showVal val="1"/>
+              <c:showCatName val="0"/>
+              <c:showSerName val="0"/>
+              <c:showPercent val="0"/>
+              <c:showBubbleSize val="0"/>
+            </c:dLbl>
+            <c:dLbl>
+              <c:idx val="5"/>
+              <c:layout/>
+              <c:tx>
+                <c:strRef>
+                  <c:f>Лист1!$V$7</c:f>
+                  <c:strCache>
+                    <c:ptCount val="1"/>
+                    <c:pt idx="0">
+                      <c:v>| 11</c:v>
+                    </c:pt>
+                  </c:strCache>
+                </c:strRef>
+              </c:tx>
+              <c:spPr>
+                <a:noFill/>
+                <a:ln>
+                  <a:noFill/>
+                </a:ln>
+              </c:spPr>
+              <c:txPr>
+                <a:bodyPr wrap="none" lIns="0" tIns="0" rIns="0" bIns="0" anchor="ctr"/>
+                <a:lstStyle/>
+                <a:p>
+                  <a:pPr>
+                    <a:defRPr sz="1050" b="1">
+                      <a:solidFill>
+                        <a:srgbClr val="7B8794"/>
+                      </a:solidFill>
+                    </a:defRPr>
+                  </a:pPr>
+                  <a:endParaRPr lang="ru-RU"/>
+                </a:p>
+              </c:txPr>
+              <c:dLblPos val="ctr"/>
+              <c:showLegendKey val="0"/>
+              <c:showVal val="1"/>
+              <c:showCatName val="0"/>
+              <c:showSerName val="0"/>
+              <c:showPercent val="0"/>
+              <c:showBubbleSize val="0"/>
+            </c:dLbl>
+            <c:dLbl>
+              <c:idx val="6"/>
+              <c:layout/>
+              <c:tx>
+                <c:strRef>
+                  <c:f>Лист1!$V$8</c:f>
+                  <c:strCache>
+                    <c:ptCount val="1"/>
+                    <c:pt idx="0">
+                      <c:v>| 20</c:v>
+                    </c:pt>
+                  </c:strCache>
+                </c:strRef>
+              </c:tx>
+              <c:spPr>
+                <a:noFill/>
+                <a:ln>
+                  <a:noFill/>
+                </a:ln>
+              </c:spPr>
+              <c:txPr>
+                <a:bodyPr wrap="none" lIns="0" tIns="0" rIns="0" bIns="0" anchor="ctr"/>
+                <a:lstStyle/>
+                <a:p>
+                  <a:pPr>
+                    <a:defRPr sz="1050" b="1">
+                      <a:solidFill>
+                        <a:srgbClr val="7B8794"/>
+                      </a:solidFill>
+                    </a:defRPr>
+                  </a:pPr>
+                  <a:endParaRPr lang="ru-RU"/>
+                </a:p>
+              </c:txPr>
+              <c:dLblPos val="ctr"/>
+              <c:showLegendKey val="0"/>
+              <c:showVal val="1"/>
+              <c:showCatName val="0"/>
+              <c:showSerName val="0"/>
+              <c:showPercent val="0"/>
+              <c:showBubbleSize val="0"/>
+            </c:dLbl>
+            <c:spPr>
+              <a:noFill/>
+              <a:ln>
+                <a:noFill/>
+              </a:ln>
+            </c:spPr>
+            <c:txPr>
+              <a:bodyPr wrap="none" lIns="0" tIns="0" rIns="0" bIns="0" anchor="ctr"/>
+              <a:lstStyle/>
+              <a:p>
+                <a:pPr>
+                  <a:defRPr sz="1050" b="1">
+                    <a:solidFill>
+                      <a:srgbClr val="7B8794"/>
+                    </a:solidFill>
+                  </a:defRPr>
+                </a:pPr>
+                <a:endParaRPr lang="ru-RU"/>
+              </a:p>
+            </c:txPr>
+            <c:dLblPos val="ctr"/>
+            <c:showLegendKey val="0"/>
+            <c:showVal val="1"/>
+            <c:showCatName val="0"/>
+            <c:showSerName val="0"/>
+            <c:showPercent val="0"/>
+            <c:showBubbleSize val="0"/>
+          </c:dLbls>
+          <c:cat>
+            <c:strRef>
+              <c:f>Лист1!$M$2:$M$8</c:f>
+              <c:strCache>
+                <c:ptCount val="7"/>
+                <c:pt idx="0">
+                  <c:v>Правовая обвязка</c:v>
+                </c:pt>
+                <c:pt idx="1">
+                  <c:v>Агент ЦД</c:v>
+                </c:pt>
+                <c:pt idx="2">
+                  <c:v>Память и контекст</c:v>
+                </c:pt>
+                <c:pt idx="3">
+                  <c:v>Foundation Model</c:v>
+                </c:pt>
+                <c:pt idx="4">
+                  <c:v>Бизнес-тестирование</c:v>
+                </c:pt>
+                <c:pt idx="5">
+                  <c:v>Мотивационный профиль</c:v>
+                </c:pt>
+                <c:pt idx="6">
+                  <c:v>Поставка данных</c:v>
+                </c:pt>
+              </c:strCache>
+            </c:strRef>
+          </c:cat>
+          <c:val>
+            <c:numRef>
+              <c:f>Лист1!$U$2:$U$8</c:f>
+              <c:numCache>
+                <c:formatCode>General</c:formatCode>
+                <c:ptCount val="7"/>
+                <c:pt idx="0">
+                  <c:v>6.66</c:v>
+                </c:pt>
+                <c:pt idx="1">
+                  <c:v>6.66</c:v>
+                </c:pt>
+                <c:pt idx="2">
+                  <c:v>6.66</c:v>
+                </c:pt>
+                <c:pt idx="3">
+                  <c:v>6.66</c:v>
+                </c:pt>
+                <c:pt idx="4">
+                  <c:v>6.66</c:v>
+                </c:pt>
+                <c:pt idx="5">
+                  <c:v>6.66</c:v>
+                </c:pt>
+                <c:pt idx="6">
+                  <c:v>6.66</c:v>
+                </c:pt>
+              </c:numCache>
+            </c:numRef>
+          </c:val>
+        </c:ser>
+        <c:ser>
+          <c:idx val="5"/>
+          <c:order val="5"/>
+          <c:tx>
+            <c:strRef>
+              <c:f>Лист1!$W$1</c:f>
+              <c:strCache>
+                <c:ptCount val="1"/>
+                <c:pt idx="0">
+                  <c:v>Ширина подписи 3 (от 90%)</c:v>
+                </c:pt>
+              </c:strCache>
+            </c:strRef>
+          </c:tx>
+          <c:spPr>
+            <a:noFill/>
+            <a:ln>
+              <a:noFill/>
+            </a:ln>
+          </c:spPr>
+          <c:invertIfNegative val="0"/>
+          <c:dLbls>
+            <c:dLbl>
+              <c:idx val="0"/>
+              <c:layout/>
+              <c:tx>
+                <c:strRef>
+                  <c:f>Лист1!$X$2</c:f>
+                  <c:strCache>
+                    <c:ptCount val="1"/>
+                    <c:pt idx="0">
+                      <c:v>| 100%</c:v>
+                    </c:pt>
+                  </c:strCache>
+                </c:strRef>
+              </c:tx>
+              <c:spPr>
+                <a:noFill/>
+                <a:ln>
+                  <a:noFill/>
+                </a:ln>
+              </c:spPr>
+              <c:txPr>
+                <a:bodyPr wrap="none" lIns="0" tIns="0" rIns="0" bIns="0" anchor="ctr"/>
+                <a:lstStyle/>
+                <a:p>
+                  <a:pPr>
+                    <a:defRPr sz="1050" b="1">
+                      <a:solidFill>
+                        <a:schemeClr val="accent4"/>
+                      </a:solidFill>
+                    </a:defRPr>
+                  </a:pPr>
+                  <a:endParaRPr lang="ru-RU"/>
+                </a:p>
+              </c:txPr>
+              <c:dLblPos val="ctr"/>
+              <c:showLegendKey val="0"/>
+              <c:showVal val="1"/>
+              <c:showCatName val="0"/>
+              <c:showSerName val="0"/>
+              <c:showPercent val="0"/>
+              <c:showBubbleSize val="0"/>
+            </c:dLbl>
+            <c:dLbl>
+              <c:idx val="1"/>
+              <c:layout/>
+              <c:tx>
+                <c:strRef>
+                  <c:f>Лист1!$X$3</c:f>
+                  <c:strCache>
+                    <c:ptCount val="1"/>
+                    <c:pt idx="0">
+                      <c:v>| 95,2%</c:v>
+                    </c:pt>
+                  </c:strCache>
+                </c:strRef>
+              </c:tx>
+              <c:spPr>
+                <a:noFill/>
+                <a:ln>
+                  <a:noFill/>
+                </a:ln>
+              </c:spPr>
+              <c:txPr>
+                <a:bodyPr wrap="none" lIns="0" tIns="0" rIns="0" bIns="0" anchor="ctr"/>
+                <a:lstStyle/>
+                <a:p>
+                  <a:pPr>
+                    <a:defRPr sz="1050" b="1">
+                      <a:solidFill>
+                        <a:schemeClr val="accent4"/>
+                      </a:solidFill>
+                    </a:defRPr>
+                  </a:pPr>
+                  <a:endParaRPr lang="ru-RU"/>
+                </a:p>
+              </c:txPr>
+              <c:dLblPos val="ctr"/>
+              <c:showLegendKey val="0"/>
+              <c:showVal val="1"/>
+              <c:showCatName val="0"/>
+              <c:showSerName val="0"/>
+              <c:showPercent val="0"/>
+              <c:showBubbleSize val="0"/>
+            </c:dLbl>
+            <c:dLbl>
+              <c:idx val="2"/>
+              <c:layout/>
+              <c:tx>
+                <c:strRef>
+                  <c:f>Лист1!$X$4</c:f>
+                  <c:strCache>
+                    <c:ptCount val="1"/>
+                    <c:pt idx="0">
+                      <c:v>| 93,5%</c:v>
+                    </c:pt>
+                  </c:strCache>
+                </c:strRef>
+              </c:tx>
+              <c:spPr>
+                <a:noFill/>
+                <a:ln>
+                  <a:noFill/>
+                </a:ln>
+              </c:spPr>
+              <c:txPr>
+                <a:bodyPr wrap="none" lIns="0" tIns="0" rIns="0" bIns="0" anchor="ctr"/>
+                <a:lstStyle/>
+                <a:p>
+                  <a:pPr>
+                    <a:defRPr sz="1050" b="1">
+                      <a:solidFill>
+                        <a:schemeClr val="accent4"/>
+                      </a:solidFill>
+                    </a:defRPr>
+                  </a:pPr>
+                  <a:endParaRPr lang="ru-RU"/>
+                </a:p>
+              </c:txPr>
+              <c:dLblPos val="ctr"/>
+              <c:showLegendKey val="0"/>
+              <c:showVal val="1"/>
+              <c:showCatName val="0"/>
+              <c:showSerName val="0"/>
+              <c:showPercent val="0"/>
+              <c:showBubbleSize val="0"/>
+            </c:dLbl>
+            <c:dLbl>
+              <c:idx val="3"/>
+              <c:layout/>
+              <c:tx>
+                <c:strRef>
+                  <c:f>Лист1!$X$5</c:f>
+                  <c:strCache>
+                    <c:ptCount val="1"/>
+                    <c:pt idx="0">
+                      <c:v>| 91,9%</c:v>
+                    </c:pt>
+                  </c:strCache>
+                </c:strRef>
+              </c:tx>
+              <c:spPr>
+                <a:noFill/>
+                <a:ln>
+                  <a:noFill/>
+                </a:ln>
+              </c:spPr>
+              <c:txPr>
+                <a:bodyPr wrap="none" lIns="0" tIns="0" rIns="0" bIns="0" anchor="ctr"/>
+                <a:lstStyle/>
+                <a:p>
+                  <a:pPr>
+                    <a:defRPr sz="1050" b="1">
+                      <a:solidFill>
+                        <a:schemeClr val="accent4"/>
+                      </a:solidFill>
+                    </a:defRPr>
+                  </a:pPr>
+                  <a:endParaRPr lang="ru-RU"/>
+                </a:p>
+              </c:txPr>
+              <c:dLblPos val="ctr"/>
+              <c:showLegendKey val="0"/>
+              <c:showVal val="1"/>
+              <c:showCatName val="0"/>
+              <c:showSerName val="0"/>
+              <c:showPercent val="0"/>
+              <c:showBubbleSize val="0"/>
+            </c:dLbl>
+            <c:dLbl>
+              <c:idx val="4"/>
+              <c:layout/>
+              <c:tx>
+                <c:strRef>
+                  <c:f>Лист1!$X$6</c:f>
+                  <c:strCache>
+                    <c:ptCount val="1"/>
+                    <c:pt idx="0">
+                      <c:v> </c:v>
+                    </c:pt>
+                  </c:strCache>
+                </c:strRef>
+              </c:tx>
+              <c:spPr>
+                <a:noFill/>
+                <a:ln>
+                  <a:noFill/>
+                </a:ln>
+              </c:spPr>
+              <c:txPr>
+                <a:bodyPr wrap="none" lIns="0" tIns="0" rIns="0" bIns="0" anchor="ctr"/>
+                <a:lstStyle/>
+                <a:p>
+                  <a:pPr>
+                    <a:defRPr sz="1050" b="1">
+                      <a:solidFill>
+                        <a:schemeClr val="accent4"/>
+                      </a:solidFill>
+                    </a:defRPr>
+                  </a:pPr>
+                  <a:endParaRPr lang="ru-RU"/>
+                </a:p>
+              </c:txPr>
+              <c:dLblPos val="ctr"/>
+              <c:showLegendKey val="0"/>
+              <c:showVal val="1"/>
+              <c:showCatName val="0"/>
+              <c:showSerName val="0"/>
+              <c:showPercent val="0"/>
+              <c:showBubbleSize val="0"/>
+            </c:dLbl>
+            <c:dLbl>
+              <c:idx val="5"/>
+              <c:layout/>
+              <c:tx>
+                <c:strRef>
+                  <c:f>Лист1!$X$7</c:f>
+                  <c:strCache>
+                    <c:ptCount val="1"/>
+                    <c:pt idx="0">
+                      <c:v> </c:v>
+                    </c:pt>
+                  </c:strCache>
+                </c:strRef>
+              </c:tx>
+              <c:spPr>
+                <a:noFill/>
+                <a:ln>
+                  <a:noFill/>
+                </a:ln>
+              </c:spPr>
+              <c:txPr>
+                <a:bodyPr wrap="none" lIns="0" tIns="0" rIns="0" bIns="0" anchor="ctr"/>
+                <a:lstStyle/>
+                <a:p>
+                  <a:pPr>
+                    <a:defRPr sz="1050" b="1">
+                      <a:solidFill>
+                        <a:schemeClr val="accent4"/>
+                      </a:solidFill>
+                    </a:defRPr>
+                  </a:pPr>
+                  <a:endParaRPr lang="ru-RU"/>
+                </a:p>
+              </c:txPr>
+              <c:dLblPos val="ctr"/>
+              <c:showLegendKey val="0"/>
+              <c:showVal val="1"/>
+              <c:showCatName val="0"/>
+              <c:showSerName val="0"/>
+              <c:showPercent val="0"/>
+              <c:showBubbleSize val="0"/>
+            </c:dLbl>
+            <c:dLbl>
+              <c:idx val="6"/>
+              <c:layout/>
+              <c:tx>
+                <c:strRef>
+                  <c:f>Лист1!$X$8</c:f>
+                  <c:strCache>
+                    <c:ptCount val="1"/>
+                    <c:pt idx="0">
+                      <c:v> </c:v>
+                    </c:pt>
+                  </c:strCache>
+                </c:strRef>
+              </c:tx>
+              <c:spPr>
+                <a:noFill/>
+                <a:ln>
+                  <a:noFill/>
+                </a:ln>
+              </c:spPr>
+              <c:txPr>
+                <a:bodyPr wrap="none" lIns="0" tIns="0" rIns="0" bIns="0" anchor="ctr"/>
+                <a:lstStyle/>
+                <a:p>
+                  <a:pPr>
+                    <a:defRPr sz="1050" b="1">
+                      <a:solidFill>
+                        <a:schemeClr val="accent4"/>
+                      </a:solidFill>
+                    </a:defRPr>
+                  </a:pPr>
+                  <a:endParaRPr lang="ru-RU"/>
+                </a:p>
+              </c:txPr>
+              <c:dLblPos val="ctr"/>
+              <c:showLegendKey val="0"/>
+              <c:showVal val="1"/>
+              <c:showCatName val="0"/>
+              <c:showSerName val="0"/>
+              <c:showPercent val="0"/>
+              <c:showBubbleSize val="0"/>
+            </c:dLbl>
+            <c:spPr>
+              <a:noFill/>
+              <a:ln>
+                <a:noFill/>
+              </a:ln>
+            </c:spPr>
+            <c:txPr>
+              <a:bodyPr wrap="none" lIns="0" tIns="0" rIns="0" bIns="0" anchor="ctr"/>
+              <a:lstStyle/>
+              <a:p>
+                <a:pPr>
+                  <a:defRPr sz="1050" b="1">
+                    <a:solidFill>
+                      <a:schemeClr val="accent4"/>
+                    </a:solidFill>
+                  </a:defRPr>
+                </a:pPr>
+                <a:endParaRPr lang="ru-RU"/>
+              </a:p>
+            </c:txPr>
+            <c:dLblPos val="ctr"/>
+            <c:showLegendKey val="0"/>
+            <c:showVal val="1"/>
+            <c:showCatName val="0"/>
+            <c:showSerName val="0"/>
+            <c:showPercent val="0"/>
+            <c:showBubbleSize val="0"/>
+          </c:dLbls>
+          <c:cat>
+            <c:strRef>
+              <c:f>Лист1!$M$2:$M$8</c:f>
+              <c:strCache>
+                <c:ptCount val="7"/>
+                <c:pt idx="0">
+                  <c:v>Правовая обвязка</c:v>
+                </c:pt>
+                <c:pt idx="1">
+                  <c:v>Агент ЦД</c:v>
+                </c:pt>
+                <c:pt idx="2">
+                  <c:v>Память и контекст</c:v>
+                </c:pt>
+                <c:pt idx="3">
+                  <c:v>Foundation Model</c:v>
+                </c:pt>
+                <c:pt idx="4">
+                  <c:v>Бизнес-тестирование</c:v>
+                </c:pt>
+                <c:pt idx="5">
+                  <c:v>Мотивационный профиль</c:v>
+                </c:pt>
+                <c:pt idx="6">
+                  <c:v>Поставка данных</c:v>
+                </c:pt>
+              </c:strCache>
+            </c:strRef>
+          </c:cat>
+          <c:val>
+            <c:numRef>
+              <c:f>Лист1!$W$2:$W$8</c:f>
+              <c:numCache>
+                <c:formatCode>General</c:formatCode>
+                <c:ptCount val="7"/>
+                <c:pt idx="0">
+                  <c:v>11.84</c:v>
+                </c:pt>
+                <c:pt idx="1">
+                  <c:v>11.84</c:v>
+                </c:pt>
+                <c:pt idx="2">
+                  <c:v>11.84</c:v>
+                </c:pt>
+                <c:pt idx="3">
+                  <c:v>11.84</c:v>
+                </c:pt>
+                <c:pt idx="4">
+                  <c:v>0</c:v>
+                </c:pt>
+                <c:pt idx="5">
+                  <c:v>0</c:v>
+                </c:pt>
+                <c:pt idx="6">
+                  <c:v>0</c:v>
+                </c:pt>
+              </c:numCache>
+            </c:numRef>
+          </c:val>
+        </c:ser>
+        <c:ser>
+          <c:idx val="6"/>
+          <c:order val="6"/>
+          <c:tx>
+            <c:strRef>
+              <c:f>Лист1!$Y$1</c:f>
+              <c:strCache>
+                <c:ptCount val="1"/>
+                <c:pt idx="0">
+                  <c:v>Ширина подписи 3 (ниже 90%)</c:v>
+                </c:pt>
+              </c:strCache>
+            </c:strRef>
+          </c:tx>
+          <c:spPr>
+            <a:noFill/>
+            <a:ln>
+              <a:noFill/>
+            </a:ln>
+          </c:spPr>
+          <c:invertIfNegative val="0"/>
+          <c:dLbls>
+            <c:dLbl>
+              <c:idx val="0"/>
+              <c:layout/>
+              <c:tx>
+                <c:strRef>
+                  <c:f>Лист1!$Z$2</c:f>
+                  <c:strCache>
+                    <c:ptCount val="1"/>
+                    <c:pt idx="0">
+                      <c:v> </c:v>
+                    </c:pt>
+                  </c:strCache>
+                </c:strRef>
+              </c:tx>
+              <c:spPr>
+                <a:noFill/>
+                <a:ln>
+                  <a:noFill/>
+                </a:ln>
+              </c:spPr>
+              <c:txPr>
+                <a:bodyPr wrap="none" lIns="0" tIns="0" rIns="0" bIns="0" anchor="ctr"/>
+                <a:lstStyle/>
+                <a:p>
+                  <a:pPr>
+                    <a:defRPr sz="1050" b="1">
+                      <a:solidFill>
+                        <a:srgbClr val="B76E00"/>
+                      </a:solidFill>
+                    </a:defRPr>
+                  </a:pPr>
+                  <a:endParaRPr lang="ru-RU"/>
+                </a:p>
+              </c:txPr>
+              <c:dLblPos val="ctr"/>
+              <c:showLegendKey val="0"/>
+              <c:showVal val="1"/>
+              <c:showCatName val="0"/>
+              <c:showSerName val="0"/>
+              <c:showPercent val="0"/>
+              <c:showBubbleSize val="0"/>
+            </c:dLbl>
+            <c:dLbl>
+              <c:idx val="1"/>
+              <c:layout/>
+              <c:tx>
+                <c:strRef>
+                  <c:f>Лист1!$Z$3</c:f>
+                  <c:strCache>
+                    <c:ptCount val="1"/>
+                    <c:pt idx="0">
+                      <c:v> </c:v>
+                    </c:pt>
+                  </c:strCache>
+                </c:strRef>
+              </c:tx>
+              <c:spPr>
+                <a:noFill/>
+                <a:ln>
+                  <a:noFill/>
+                </a:ln>
+              </c:spPr>
+              <c:txPr>
+                <a:bodyPr wrap="none" lIns="0" tIns="0" rIns="0" bIns="0" anchor="ctr"/>
+                <a:lstStyle/>
+                <a:p>
+                  <a:pPr>
+                    <a:defRPr sz="1050" b="1">
+                      <a:solidFill>
+                        <a:srgbClr val="B76E00"/>
+                      </a:solidFill>
+                    </a:defRPr>
+                  </a:pPr>
+                  <a:endParaRPr lang="ru-RU"/>
+                </a:p>
+              </c:txPr>
+              <c:dLblPos val="ctr"/>
+              <c:showLegendKey val="0"/>
+              <c:showVal val="1"/>
+              <c:showCatName val="0"/>
+              <c:showSerName val="0"/>
+              <c:showPercent val="0"/>
+              <c:showBubbleSize val="0"/>
+            </c:dLbl>
+            <c:dLbl>
+              <c:idx val="2"/>
+              <c:layout/>
+              <c:tx>
+                <c:strRef>
+                  <c:f>Лист1!$Z$4</c:f>
+                  <c:strCache>
+                    <c:ptCount val="1"/>
+                    <c:pt idx="0">
+                      <c:v> </c:v>
+                    </c:pt>
+                  </c:strCache>
+                </c:strRef>
+              </c:tx>
+              <c:spPr>
+                <a:noFill/>
+                <a:ln>
+                  <a:noFill/>
+                </a:ln>
+              </c:spPr>
+              <c:txPr>
+                <a:bodyPr wrap="none" lIns="0" tIns="0" rIns="0" bIns="0" anchor="ctr"/>
+                <a:lstStyle/>
+                <a:p>
+                  <a:pPr>
+                    <a:defRPr sz="1050" b="1">
+                      <a:solidFill>
+                        <a:srgbClr val="B76E00"/>
+                      </a:solidFill>
+                    </a:defRPr>
+                  </a:pPr>
+                  <a:endParaRPr lang="ru-RU"/>
+                </a:p>
+              </c:txPr>
+              <c:dLblPos val="ctr"/>
+              <c:showLegendKey val="0"/>
+              <c:showVal val="1"/>
+              <c:showCatName val="0"/>
+              <c:showSerName val="0"/>
+              <c:showPercent val="0"/>
+              <c:showBubbleSize val="0"/>
+            </c:dLbl>
+            <c:dLbl>
+              <c:idx val="3"/>
+              <c:layout/>
+              <c:tx>
+                <c:strRef>
+                  <c:f>Лист1!$Z$5</c:f>
+                  <c:strCache>
+                    <c:ptCount val="1"/>
+                    <c:pt idx="0">
+                      <c:v> </c:v>
+                    </c:pt>
+                  </c:strCache>
+                </c:strRef>
+              </c:tx>
+              <c:spPr>
+                <a:noFill/>
+                <a:ln>
+                  <a:noFill/>
+                </a:ln>
+              </c:spPr>
+              <c:txPr>
+                <a:bodyPr wrap="none" lIns="0" tIns="0" rIns="0" bIns="0" anchor="ctr"/>
+                <a:lstStyle/>
+                <a:p>
+                  <a:pPr>
+                    <a:defRPr sz="1050" b="1">
+                      <a:solidFill>
+                        <a:srgbClr val="B76E00"/>
+                      </a:solidFill>
+                    </a:defRPr>
+                  </a:pPr>
+                  <a:endParaRPr lang="ru-RU"/>
+                </a:p>
+              </c:txPr>
+              <c:dLblPos val="ctr"/>
+              <c:showLegendKey val="0"/>
+              <c:showVal val="1"/>
+              <c:showCatName val="0"/>
+              <c:showSerName val="0"/>
+              <c:showPercent val="0"/>
+              <c:showBubbleSize val="0"/>
+            </c:dLbl>
+            <c:dLbl>
+              <c:idx val="4"/>
+              <c:layout/>
+              <c:tx>
+                <c:strRef>
+                  <c:f>Лист1!$Z$6</c:f>
+                  <c:strCache>
+                    <c:ptCount val="1"/>
+                    <c:pt idx="0">
+                      <c:v>| 87,5%</c:v>
+                    </c:pt>
+                  </c:strCache>
+                </c:strRef>
+              </c:tx>
+              <c:spPr>
+                <a:noFill/>
+                <a:ln>
+                  <a:noFill/>
+                </a:ln>
+              </c:spPr>
+              <c:txPr>
+                <a:bodyPr wrap="none" lIns="0" tIns="0" rIns="0" bIns="0" anchor="ctr"/>
+                <a:lstStyle/>
+                <a:p>
+                  <a:pPr>
+                    <a:defRPr sz="1050" b="1">
+                      <a:solidFill>
+                        <a:srgbClr val="B76E00"/>
+                      </a:solidFill>
+                    </a:defRPr>
+                  </a:pPr>
+                  <a:endParaRPr lang="ru-RU"/>
+                </a:p>
+              </c:txPr>
+              <c:dLblPos val="ctr"/>
+              <c:showLegendKey val="0"/>
+              <c:showVal val="1"/>
+              <c:showCatName val="0"/>
+              <c:showSerName val="0"/>
+              <c:showPercent val="0"/>
+              <c:showBubbleSize val="0"/>
+            </c:dLbl>
+            <c:dLbl>
+              <c:idx val="5"/>
+              <c:layout/>
+              <c:tx>
+                <c:strRef>
+                  <c:f>Лист1!$Z$7</c:f>
+                  <c:strCache>
+                    <c:ptCount val="1"/>
+                    <c:pt idx="0">
+                      <c:v>| 81,8%</c:v>
+                    </c:pt>
+                  </c:strCache>
+                </c:strRef>
+              </c:tx>
+              <c:spPr>
+                <a:noFill/>
+                <a:ln>
+                  <a:noFill/>
+                </a:ln>
+              </c:spPr>
+              <c:txPr>
+                <a:bodyPr wrap="none" lIns="0" tIns="0" rIns="0" bIns="0" anchor="ctr"/>
+                <a:lstStyle/>
+                <a:p>
+                  <a:pPr>
+                    <a:defRPr sz="1050" b="1">
+                      <a:solidFill>
+                        <a:srgbClr val="B76E00"/>
+                      </a:solidFill>
+                    </a:defRPr>
+                  </a:pPr>
+                  <a:endParaRPr lang="ru-RU"/>
+                </a:p>
+              </c:txPr>
+              <c:dLblPos val="ctr"/>
+              <c:showLegendKey val="0"/>
+              <c:showVal val="1"/>
+              <c:showCatName val="0"/>
+              <c:showSerName val="0"/>
+              <c:showPercent val="0"/>
+              <c:showBubbleSize val="0"/>
+            </c:dLbl>
+            <c:dLbl>
+              <c:idx val="6"/>
+              <c:layout/>
+              <c:tx>
+                <c:strRef>
+                  <c:f>Лист1!$Z$8</c:f>
+                  <c:strCache>
+                    <c:ptCount val="1"/>
+                    <c:pt idx="0">
+                      <c:v>| 80%</c:v>
+                    </c:pt>
+                  </c:strCache>
+                </c:strRef>
+              </c:tx>
+              <c:spPr>
+                <a:noFill/>
+                <a:ln>
+                  <a:noFill/>
+                </a:ln>
+              </c:spPr>
+              <c:txPr>
+                <a:bodyPr wrap="none" lIns="0" tIns="0" rIns="0" bIns="0" anchor="ctr"/>
+                <a:lstStyle/>
+                <a:p>
+                  <a:pPr>
+                    <a:defRPr sz="1050" b="1">
+                      <a:solidFill>
+                        <a:srgbClr val="B76E00"/>
+                      </a:solidFill>
+                    </a:defRPr>
+                  </a:pPr>
+                  <a:endParaRPr lang="ru-RU"/>
+                </a:p>
+              </c:txPr>
+              <c:dLblPos val="ctr"/>
+              <c:showLegendKey val="0"/>
+              <c:showVal val="1"/>
+              <c:showCatName val="0"/>
+              <c:showSerName val="0"/>
+              <c:showPercent val="0"/>
+              <c:showBubbleSize val="0"/>
+            </c:dLbl>
+            <c:spPr>
+              <a:noFill/>
+              <a:ln>
+                <a:noFill/>
+              </a:ln>
+            </c:spPr>
+            <c:txPr>
+              <a:bodyPr wrap="none" lIns="0" tIns="0" rIns="0" bIns="0" anchor="ctr"/>
+              <a:lstStyle/>
+              <a:p>
+                <a:pPr>
+                  <a:defRPr sz="1050" b="1">
+                    <a:solidFill>
+                      <a:srgbClr val="B76E00"/>
+                    </a:solidFill>
+                  </a:defRPr>
+                </a:pPr>
+                <a:endParaRPr lang="ru-RU"/>
+              </a:p>
+            </c:txPr>
+            <c:dLblPos val="ctr"/>
+            <c:showLegendKey val="0"/>
+            <c:showVal val="1"/>
+            <c:showCatName val="0"/>
+            <c:showSerName val="0"/>
+            <c:showPercent val="0"/>
+            <c:showBubbleSize val="0"/>
+          </c:dLbls>
+          <c:cat>
+            <c:strRef>
+              <c:f>Лист1!$M$2:$M$8</c:f>
+              <c:strCache>
+                <c:ptCount val="7"/>
+                <c:pt idx="0">
+                  <c:v>Правовая обвязка</c:v>
+                </c:pt>
+                <c:pt idx="1">
+                  <c:v>Агент ЦД</c:v>
+                </c:pt>
+                <c:pt idx="2">
+                  <c:v>Память и контекст</c:v>
+                </c:pt>
+                <c:pt idx="3">
+                  <c:v>Foundation Model</c:v>
+                </c:pt>
+                <c:pt idx="4">
+                  <c:v>Бизнес-тестирование</c:v>
+                </c:pt>
+                <c:pt idx="5">
+                  <c:v>Мотивационный профиль</c:v>
+                </c:pt>
+                <c:pt idx="6">
+                  <c:v>Поставка данных</c:v>
+                </c:pt>
+              </c:strCache>
+            </c:strRef>
+          </c:cat>
+          <c:val>
+            <c:numRef>
+              <c:f>Лист1!$Y$2:$Y$8</c:f>
+              <c:numCache>
+                <c:formatCode>General</c:formatCode>
+                <c:ptCount val="7"/>
+                <c:pt idx="0">
+                  <c:v>0</c:v>
+                </c:pt>
+                <c:pt idx="1">
+                  <c:v>0</c:v>
+                </c:pt>
+                <c:pt idx="2">
+                  <c:v>0</c:v>
+                </c:pt>
+                <c:pt idx="3">
+                  <c:v>0</c:v>
+                </c:pt>
+                <c:pt idx="4">
+                  <c:v>11.84</c:v>
+                </c:pt>
+                <c:pt idx="5">
+                  <c:v>11.84</c:v>
+                </c:pt>
+                <c:pt idx="6">
+                  <c:v>11.84</c:v>
+                </c:pt>
+              </c:numCache>
+            </c:numRef>
+          </c:val>
         </c:ser>
         <c:dLbls>
           <c:showLegendKey val="0"/>
@@ -797,7 +2484,7 @@
       <c:catAx>
         <c:axId val="1009633471"/>
         <c:scaling>
-          <c:orientation val="minMax"/>
+          <c:orientation val="maxMin"/>
         </c:scaling>
         <c:delete val="0"/>
         <c:axPos val="l"/>
@@ -4210,7 +5897,7 @@
       </p:graphicFrame>
       <p:grpSp>
         <p:nvGrpSpPr>
-          <p:cNvPr id="133" name="Summary"/>
+          <p:cNvPr id="128" name="Summary"/>
           <p:cNvGrpSpPr/>
           <p:nvPr/>
         </p:nvGrpSpPr>
@@ -4507,7 +6194,7 @@
       </p:sp>
       <p:grpSp>
         <p:nvGrpSpPr>
-          <p:cNvPr id="134" name="KPI: Всего на программе"/>
+          <p:cNvPr id="129" name="KPI: Всего на программе"/>
           <p:cNvGrpSpPr/>
           <p:nvPr/>
         </p:nvGrpSpPr>
@@ -4693,7 +6380,7 @@
       </p:grpSp>
       <p:grpSp>
         <p:nvGrpSpPr>
-          <p:cNvPr id="135" name="График: Укомплектованность"/>
+          <p:cNvPr id="130" name="График: Укомплектованность"/>
           <p:cNvGrpSpPr/>
           <p:nvPr/>
         </p:nvGrpSpPr>
@@ -5000,7 +6687,7 @@
       </p:grpSp>
       <p:grpSp>
         <p:nvGrpSpPr>
-          <p:cNvPr id="136" name="График: Структура компетенций"/>
+          <p:cNvPr id="131" name="График: Структура компетенций"/>
           <p:cNvGrpSpPr/>
           <p:nvPr/>
         </p:nvGrpSpPr>
@@ -5540,7 +7227,7 @@
       </p:grpSp>
       <p:grpSp>
         <p:nvGrpSpPr>
-          <p:cNvPr id="137" name="График: Обеспеченность компонентов"/>
+          <p:cNvPr id="132" name="График: Обеспеченность компонентов"/>
           <p:cNvGrpSpPr/>
           <p:nvPr/>
         </p:nvGrpSpPr>
@@ -5655,7 +7342,7 @@
           </p:nvGraphicFramePr>
           <p:xfrm>
             <a:off x="7114032" y="1792224"/>
-            <a:ext cx="3304002" cy="1152144"/>
+            <a:ext cx="4547586" cy="1152144"/>
           </p:xfrm>
           <a:graphic>
             <a:graphicData uri="http://schemas.openxmlformats.org/drawingml/2006/chart">
@@ -5663,947 +7350,6 @@
             </a:graphicData>
           </a:graphic>
         </p:graphicFrame>
-        <p:sp>
-          <p:nvSpPr>
-            <p:cNvPr id="128" name="Числа: факт"/>
-            <p:cNvSpPr txBox="1"/>
-            <p:nvPr/>
-          </p:nvSpPr>
-          <p:spPr>
-            <a:xfrm>
-              <a:off x="10436322" y="1792224"/>
-              <a:ext cx="237744" cy="1152144"/>
-            </a:xfrm>
-            <a:prstGeom prst="rect">
-              <a:avLst/>
-            </a:prstGeom>
-            <a:noFill/>
-          </p:spPr>
-          <p:txBody>
-            <a:bodyPr wrap="square" lIns="0" tIns="0" rIns="0" bIns="0" anchor="t">
-              <a:noAutofit/>
-            </a:bodyPr>
-            <a:lstStyle/>
-            <a:p>
-              <a:pPr marL="0" indent="0" algn="r">
-                <a:lnSpc>
-                  <a:spcPts val="1296"/>
-                </a:lnSpc>
-                <a:spcBef>
-                  <a:spcPts val="0"/>
-                </a:spcBef>
-                <a:spcAft>
-                  <a:spcPts val="0"/>
-                </a:spcAft>
-                <a:buNone/>
-              </a:pPr>
-              <a:r>
-                <a:rPr lang="ru-RU" sz="1050" b="1" dirty="0">
-                  <a:solidFill>
-                    <a:schemeClr val="accent3"/>
-                  </a:solidFill>
-                </a:rPr>
-                <a:t>3</a:t>
-              </a:r>
-            </a:p>
-            <a:p>
-              <a:pPr marL="0" indent="0" algn="r">
-                <a:lnSpc>
-                  <a:spcPts val="1296"/>
-                </a:lnSpc>
-                <a:spcBef>
-                  <a:spcPts val="0"/>
-                </a:spcBef>
-                <a:spcAft>
-                  <a:spcPts val="0"/>
-                </a:spcAft>
-                <a:buNone/>
-              </a:pPr>
-              <a:r>
-                <a:rPr lang="ru-RU" sz="1050" b="1" dirty="0">
-                  <a:solidFill>
-                    <a:schemeClr val="accent3"/>
-                  </a:solidFill>
-                </a:rPr>
-                <a:t>7</a:t>
-              </a:r>
-            </a:p>
-            <a:p>
-              <a:pPr marL="0" indent="0" algn="r">
-                <a:lnSpc>
-                  <a:spcPts val="1296"/>
-                </a:lnSpc>
-                <a:spcBef>
-                  <a:spcPts val="0"/>
-                </a:spcBef>
-                <a:spcAft>
-                  <a:spcPts val="0"/>
-                </a:spcAft>
-                <a:buNone/>
-              </a:pPr>
-              <a:r>
-                <a:rPr lang="ru-RU" sz="1050" b="1" dirty="0">
-                  <a:solidFill>
-                    <a:schemeClr val="accent3"/>
-                  </a:solidFill>
-                </a:rPr>
-                <a:t>34</a:t>
-              </a:r>
-            </a:p>
-            <a:p>
-              <a:pPr marL="0" indent="0" algn="r">
-                <a:lnSpc>
-                  <a:spcPts val="1296"/>
-                </a:lnSpc>
-                <a:spcBef>
-                  <a:spcPts val="0"/>
-                </a:spcBef>
-                <a:spcAft>
-                  <a:spcPts val="0"/>
-                </a:spcAft>
-                <a:buNone/>
-              </a:pPr>
-              <a:r>
-                <a:rPr lang="ru-RU" sz="1050" b="1" dirty="0">
-                  <a:solidFill>
-                    <a:schemeClr val="accent3"/>
-                  </a:solidFill>
-                </a:rPr>
-                <a:t>16</a:t>
-              </a:r>
-            </a:p>
-            <a:p>
-              <a:pPr marL="0" indent="0" algn="r">
-                <a:lnSpc>
-                  <a:spcPts val="1296"/>
-                </a:lnSpc>
-                <a:spcBef>
-                  <a:spcPts val="0"/>
-                </a:spcBef>
-                <a:spcAft>
-                  <a:spcPts val="0"/>
-                </a:spcAft>
-                <a:buNone/>
-              </a:pPr>
-              <a:r>
-                <a:rPr lang="ru-RU" sz="1050" b="1" dirty="0">
-                  <a:solidFill>
-                    <a:schemeClr val="accent3"/>
-                  </a:solidFill>
-                </a:rPr>
-                <a:t>29</a:t>
-              </a:r>
-            </a:p>
-            <a:p>
-              <a:pPr marL="0" indent="0" algn="r">
-                <a:lnSpc>
-                  <a:spcPts val="1296"/>
-                </a:lnSpc>
-                <a:spcBef>
-                  <a:spcPts val="0"/>
-                </a:spcBef>
-                <a:spcAft>
-                  <a:spcPts val="0"/>
-                </a:spcAft>
-                <a:buNone/>
-              </a:pPr>
-              <a:r>
-                <a:rPr lang="ru-RU" sz="1050" b="1" dirty="0">
-                  <a:solidFill>
-                    <a:schemeClr val="accent3"/>
-                  </a:solidFill>
-                </a:rPr>
-                <a:t>20</a:t>
-              </a:r>
-            </a:p>
-            <a:p>
-              <a:pPr marL="0" indent="0" algn="r">
-                <a:lnSpc>
-                  <a:spcPts val="1296"/>
-                </a:lnSpc>
-                <a:spcBef>
-                  <a:spcPts val="0"/>
-                </a:spcBef>
-                <a:spcAft>
-                  <a:spcPts val="0"/>
-                </a:spcAft>
-                <a:buNone/>
-              </a:pPr>
-              <a:r>
-                <a:rPr lang="ru-RU" sz="1050" b="1" dirty="0">
-                  <a:solidFill>
-                    <a:schemeClr val="accent3"/>
-                  </a:solidFill>
-                </a:rPr>
-                <a:t>9</a:t>
-              </a:r>
-            </a:p>
-          </p:txBody>
-        </p:sp>
-        <p:sp>
-          <p:nvSpPr>
-            <p:cNvPr id="129" name="Числа: разделитель 1"/>
-            <p:cNvSpPr txBox="1"/>
-            <p:nvPr/>
-          </p:nvSpPr>
-          <p:spPr>
-            <a:xfrm>
-              <a:off x="10701498" y="1792224"/>
-              <a:ext cx="82296" cy="1152144"/>
-            </a:xfrm>
-            <a:prstGeom prst="rect">
-              <a:avLst/>
-            </a:prstGeom>
-            <a:noFill/>
-          </p:spPr>
-          <p:txBody>
-            <a:bodyPr wrap="square" lIns="0" tIns="0" rIns="0" bIns="0" anchor="t">
-              <a:noAutofit/>
-            </a:bodyPr>
-            <a:lstStyle/>
-            <a:p>
-              <a:pPr marL="0" indent="0" algn="ctr">
-                <a:lnSpc>
-                  <a:spcPts val="1296"/>
-                </a:lnSpc>
-                <a:spcBef>
-                  <a:spcPts val="0"/>
-                </a:spcBef>
-                <a:spcAft>
-                  <a:spcPts val="0"/>
-                </a:spcAft>
-                <a:buNone/>
-              </a:pPr>
-              <a:r>
-                <a:rPr lang="ru-RU" sz="1000" b="0" dirty="0">
-                  <a:solidFill>
-                    <a:srgbClr val="C5D2D8"/>
-                  </a:solidFill>
-                </a:rPr>
-                <a:t>|</a:t>
-              </a:r>
-            </a:p>
-            <a:p>
-              <a:pPr marL="0" indent="0" algn="ctr">
-                <a:lnSpc>
-                  <a:spcPts val="1296"/>
-                </a:lnSpc>
-                <a:spcBef>
-                  <a:spcPts val="0"/>
-                </a:spcBef>
-                <a:spcAft>
-                  <a:spcPts val="0"/>
-                </a:spcAft>
-                <a:buNone/>
-              </a:pPr>
-              <a:r>
-                <a:rPr lang="ru-RU" sz="1000" b="0" dirty="0">
-                  <a:solidFill>
-                    <a:srgbClr val="C5D2D8"/>
-                  </a:solidFill>
-                </a:rPr>
-                <a:t>|</a:t>
-              </a:r>
-            </a:p>
-            <a:p>
-              <a:pPr marL="0" indent="0" algn="ctr">
-                <a:lnSpc>
-                  <a:spcPts val="1296"/>
-                </a:lnSpc>
-                <a:spcBef>
-                  <a:spcPts val="0"/>
-                </a:spcBef>
-                <a:spcAft>
-                  <a:spcPts val="0"/>
-                </a:spcAft>
-                <a:buNone/>
-              </a:pPr>
-              <a:r>
-                <a:rPr lang="ru-RU" sz="1000" b="0" dirty="0">
-                  <a:solidFill>
-                    <a:srgbClr val="C5D2D8"/>
-                  </a:solidFill>
-                </a:rPr>
-                <a:t>|</a:t>
-              </a:r>
-            </a:p>
-            <a:p>
-              <a:pPr marL="0" indent="0" algn="ctr">
-                <a:lnSpc>
-                  <a:spcPts val="1296"/>
-                </a:lnSpc>
-                <a:spcBef>
-                  <a:spcPts val="0"/>
-                </a:spcBef>
-                <a:spcAft>
-                  <a:spcPts val="0"/>
-                </a:spcAft>
-                <a:buNone/>
-              </a:pPr>
-              <a:r>
-                <a:rPr lang="ru-RU" sz="1000" b="0" dirty="0">
-                  <a:solidFill>
-                    <a:srgbClr val="C5D2D8"/>
-                  </a:solidFill>
-                </a:rPr>
-                <a:t>|</a:t>
-              </a:r>
-            </a:p>
-            <a:p>
-              <a:pPr marL="0" indent="0" algn="ctr">
-                <a:lnSpc>
-                  <a:spcPts val="1296"/>
-                </a:lnSpc>
-                <a:spcBef>
-                  <a:spcPts val="0"/>
-                </a:spcBef>
-                <a:spcAft>
-                  <a:spcPts val="0"/>
-                </a:spcAft>
-                <a:buNone/>
-              </a:pPr>
-              <a:r>
-                <a:rPr lang="ru-RU" sz="1000" b="0" dirty="0">
-                  <a:solidFill>
-                    <a:srgbClr val="C5D2D8"/>
-                  </a:solidFill>
-                </a:rPr>
-                <a:t>|</a:t>
-              </a:r>
-            </a:p>
-            <a:p>
-              <a:pPr marL="0" indent="0" algn="ctr">
-                <a:lnSpc>
-                  <a:spcPts val="1296"/>
-                </a:lnSpc>
-                <a:spcBef>
-                  <a:spcPts val="0"/>
-                </a:spcBef>
-                <a:spcAft>
-                  <a:spcPts val="0"/>
-                </a:spcAft>
-                <a:buNone/>
-              </a:pPr>
-              <a:r>
-                <a:rPr lang="ru-RU" sz="1000" b="0" dirty="0">
-                  <a:solidFill>
-                    <a:srgbClr val="C5D2D8"/>
-                  </a:solidFill>
-                </a:rPr>
-                <a:t>|</a:t>
-              </a:r>
-            </a:p>
-            <a:p>
-              <a:pPr marL="0" indent="0" algn="ctr">
-                <a:lnSpc>
-                  <a:spcPts val="1296"/>
-                </a:lnSpc>
-                <a:spcBef>
-                  <a:spcPts val="0"/>
-                </a:spcBef>
-                <a:spcAft>
-                  <a:spcPts val="0"/>
-                </a:spcAft>
-                <a:buNone/>
-              </a:pPr>
-              <a:r>
-                <a:rPr lang="ru-RU" sz="1000" b="0" dirty="0">
-                  <a:solidFill>
-                    <a:srgbClr val="C5D2D8"/>
-                  </a:solidFill>
-                </a:rPr>
-                <a:t>|</a:t>
-              </a:r>
-            </a:p>
-          </p:txBody>
-        </p:sp>
-        <p:sp>
-          <p:nvSpPr>
-            <p:cNvPr id="130" name="Числа: план (итого)"/>
-            <p:cNvSpPr txBox="1"/>
-            <p:nvPr/>
-          </p:nvSpPr>
-          <p:spPr>
-            <a:xfrm>
-              <a:off x="10811226" y="1792224"/>
-              <a:ext cx="237744" cy="1152144"/>
-            </a:xfrm>
-            <a:prstGeom prst="rect">
-              <a:avLst/>
-            </a:prstGeom>
-            <a:noFill/>
-          </p:spPr>
-          <p:txBody>
-            <a:bodyPr wrap="square" lIns="0" tIns="0" rIns="0" bIns="0" anchor="t">
-              <a:noAutofit/>
-            </a:bodyPr>
-            <a:lstStyle/>
-            <a:p>
-              <a:pPr marL="0" indent="0" algn="r">
-                <a:lnSpc>
-                  <a:spcPts val="1296"/>
-                </a:lnSpc>
-                <a:spcBef>
-                  <a:spcPts val="0"/>
-                </a:spcBef>
-                <a:spcAft>
-                  <a:spcPts val="0"/>
-                </a:spcAft>
-                <a:buNone/>
-              </a:pPr>
-              <a:r>
-                <a:rPr lang="ru-RU" sz="1050" b="1" dirty="0">
-                  <a:solidFill>
-                    <a:srgbClr val="7B8794"/>
-                  </a:solidFill>
-                </a:rPr>
-                <a:t>3</a:t>
-              </a:r>
-            </a:p>
-            <a:p>
-              <a:pPr marL="0" indent="0" algn="r">
-                <a:lnSpc>
-                  <a:spcPts val="1296"/>
-                </a:lnSpc>
-                <a:spcBef>
-                  <a:spcPts val="0"/>
-                </a:spcBef>
-                <a:spcAft>
-                  <a:spcPts val="0"/>
-                </a:spcAft>
-                <a:buNone/>
-              </a:pPr>
-              <a:r>
-                <a:rPr lang="ru-RU" sz="1050" b="1" dirty="0">
-                  <a:solidFill>
-                    <a:srgbClr val="7B8794"/>
-                  </a:solidFill>
-                </a:rPr>
-                <a:t>8</a:t>
-              </a:r>
-            </a:p>
-            <a:p>
-              <a:pPr marL="0" indent="0" algn="r">
-                <a:lnSpc>
-                  <a:spcPts val="1296"/>
-                </a:lnSpc>
-                <a:spcBef>
-                  <a:spcPts val="0"/>
-                </a:spcBef>
-                <a:spcAft>
-                  <a:spcPts val="0"/>
-                </a:spcAft>
-                <a:buNone/>
-              </a:pPr>
-              <a:r>
-                <a:rPr lang="ru-RU" sz="1050" b="1" dirty="0">
-                  <a:solidFill>
-                    <a:srgbClr val="7B8794"/>
-                  </a:solidFill>
-                </a:rPr>
-                <a:t>37</a:t>
-              </a:r>
-            </a:p>
-            <a:p>
-              <a:pPr marL="0" indent="0" algn="r">
-                <a:lnSpc>
-                  <a:spcPts val="1296"/>
-                </a:lnSpc>
-                <a:spcBef>
-                  <a:spcPts val="0"/>
-                </a:spcBef>
-                <a:spcAft>
-                  <a:spcPts val="0"/>
-                </a:spcAft>
-                <a:buNone/>
-              </a:pPr>
-              <a:r>
-                <a:rPr lang="ru-RU" sz="1050" b="1" dirty="0">
-                  <a:solidFill>
-                    <a:srgbClr val="7B8794"/>
-                  </a:solidFill>
-                </a:rPr>
-                <a:t>20</a:t>
-              </a:r>
-            </a:p>
-            <a:p>
-              <a:pPr marL="0" indent="0" algn="r">
-                <a:lnSpc>
-                  <a:spcPts val="1296"/>
-                </a:lnSpc>
-                <a:spcBef>
-                  <a:spcPts val="0"/>
-                </a:spcBef>
-                <a:spcAft>
-                  <a:spcPts val="0"/>
-                </a:spcAft>
-                <a:buNone/>
-              </a:pPr>
-              <a:r>
-                <a:rPr lang="ru-RU" sz="1050" b="1" dirty="0">
-                  <a:solidFill>
-                    <a:srgbClr val="7B8794"/>
-                  </a:solidFill>
-                </a:rPr>
-                <a:t>31</a:t>
-              </a:r>
-            </a:p>
-            <a:p>
-              <a:pPr marL="0" indent="0" algn="r">
-                <a:lnSpc>
-                  <a:spcPts val="1296"/>
-                </a:lnSpc>
-                <a:spcBef>
-                  <a:spcPts val="0"/>
-                </a:spcBef>
-                <a:spcAft>
-                  <a:spcPts val="0"/>
-                </a:spcAft>
-                <a:buNone/>
-              </a:pPr>
-              <a:r>
-                <a:rPr lang="ru-RU" sz="1050" b="1" dirty="0">
-                  <a:solidFill>
-                    <a:srgbClr val="7B8794"/>
-                  </a:solidFill>
-                </a:rPr>
-                <a:t>21</a:t>
-              </a:r>
-            </a:p>
-            <a:p>
-              <a:pPr marL="0" indent="0" algn="r">
-                <a:lnSpc>
-                  <a:spcPts val="1296"/>
-                </a:lnSpc>
-                <a:spcBef>
-                  <a:spcPts val="0"/>
-                </a:spcBef>
-                <a:spcAft>
-                  <a:spcPts val="0"/>
-                </a:spcAft>
-                <a:buNone/>
-              </a:pPr>
-              <a:r>
-                <a:rPr lang="ru-RU" sz="1050" b="1" dirty="0">
-                  <a:solidFill>
-                    <a:srgbClr val="7B8794"/>
-                  </a:solidFill>
-                </a:rPr>
-                <a:t>11</a:t>
-              </a:r>
-            </a:p>
-          </p:txBody>
-        </p:sp>
-        <p:sp>
-          <p:nvSpPr>
-            <p:cNvPr id="131" name="Числа: разделитель 2"/>
-            <p:cNvSpPr txBox="1"/>
-            <p:nvPr/>
-          </p:nvSpPr>
-          <p:spPr>
-            <a:xfrm>
-              <a:off x="11076402" y="1792224"/>
-              <a:ext cx="82296" cy="1152144"/>
-            </a:xfrm>
-            <a:prstGeom prst="rect">
-              <a:avLst/>
-            </a:prstGeom>
-            <a:noFill/>
-          </p:spPr>
-          <p:txBody>
-            <a:bodyPr wrap="square" lIns="0" tIns="0" rIns="0" bIns="0" anchor="t">
-              <a:noAutofit/>
-            </a:bodyPr>
-            <a:lstStyle/>
-            <a:p>
-              <a:pPr marL="0" indent="0" algn="ctr">
-                <a:lnSpc>
-                  <a:spcPts val="1296"/>
-                </a:lnSpc>
-                <a:spcBef>
-                  <a:spcPts val="0"/>
-                </a:spcBef>
-                <a:spcAft>
-                  <a:spcPts val="0"/>
-                </a:spcAft>
-                <a:buNone/>
-              </a:pPr>
-              <a:r>
-                <a:rPr lang="ru-RU" sz="1000" b="0" dirty="0">
-                  <a:solidFill>
-                    <a:srgbClr val="C5D2D8"/>
-                  </a:solidFill>
-                </a:rPr>
-                <a:t>|</a:t>
-              </a:r>
-            </a:p>
-            <a:p>
-              <a:pPr marL="0" indent="0" algn="ctr">
-                <a:lnSpc>
-                  <a:spcPts val="1296"/>
-                </a:lnSpc>
-                <a:spcBef>
-                  <a:spcPts val="0"/>
-                </a:spcBef>
-                <a:spcAft>
-                  <a:spcPts val="0"/>
-                </a:spcAft>
-                <a:buNone/>
-              </a:pPr>
-              <a:r>
-                <a:rPr lang="ru-RU" sz="1000" b="0" dirty="0">
-                  <a:solidFill>
-                    <a:srgbClr val="C5D2D8"/>
-                  </a:solidFill>
-                </a:rPr>
-                <a:t>|</a:t>
-              </a:r>
-            </a:p>
-            <a:p>
-              <a:pPr marL="0" indent="0" algn="ctr">
-                <a:lnSpc>
-                  <a:spcPts val="1296"/>
-                </a:lnSpc>
-                <a:spcBef>
-                  <a:spcPts val="0"/>
-                </a:spcBef>
-                <a:spcAft>
-                  <a:spcPts val="0"/>
-                </a:spcAft>
-                <a:buNone/>
-              </a:pPr>
-              <a:r>
-                <a:rPr lang="ru-RU" sz="1000" b="0" dirty="0">
-                  <a:solidFill>
-                    <a:srgbClr val="C5D2D8"/>
-                  </a:solidFill>
-                </a:rPr>
-                <a:t>|</a:t>
-              </a:r>
-            </a:p>
-            <a:p>
-              <a:pPr marL="0" indent="0" algn="ctr">
-                <a:lnSpc>
-                  <a:spcPts val="1296"/>
-                </a:lnSpc>
-                <a:spcBef>
-                  <a:spcPts val="0"/>
-                </a:spcBef>
-                <a:spcAft>
-                  <a:spcPts val="0"/>
-                </a:spcAft>
-                <a:buNone/>
-              </a:pPr>
-              <a:r>
-                <a:rPr lang="ru-RU" sz="1000" b="0" dirty="0">
-                  <a:solidFill>
-                    <a:srgbClr val="C5D2D8"/>
-                  </a:solidFill>
-                </a:rPr>
-                <a:t>|</a:t>
-              </a:r>
-            </a:p>
-            <a:p>
-              <a:pPr marL="0" indent="0" algn="ctr">
-                <a:lnSpc>
-                  <a:spcPts val="1296"/>
-                </a:lnSpc>
-                <a:spcBef>
-                  <a:spcPts val="0"/>
-                </a:spcBef>
-                <a:spcAft>
-                  <a:spcPts val="0"/>
-                </a:spcAft>
-                <a:buNone/>
-              </a:pPr>
-              <a:r>
-                <a:rPr lang="ru-RU" sz="1000" b="0" dirty="0">
-                  <a:solidFill>
-                    <a:srgbClr val="C5D2D8"/>
-                  </a:solidFill>
-                </a:rPr>
-                <a:t>|</a:t>
-              </a:r>
-            </a:p>
-            <a:p>
-              <a:pPr marL="0" indent="0" algn="ctr">
-                <a:lnSpc>
-                  <a:spcPts val="1296"/>
-                </a:lnSpc>
-                <a:spcBef>
-                  <a:spcPts val="0"/>
-                </a:spcBef>
-                <a:spcAft>
-                  <a:spcPts val="0"/>
-                </a:spcAft>
-                <a:buNone/>
-              </a:pPr>
-              <a:r>
-                <a:rPr lang="ru-RU" sz="1000" b="0" dirty="0">
-                  <a:solidFill>
-                    <a:srgbClr val="C5D2D8"/>
-                  </a:solidFill>
-                </a:rPr>
-                <a:t>|</a:t>
-              </a:r>
-            </a:p>
-            <a:p>
-              <a:pPr marL="0" indent="0" algn="ctr">
-                <a:lnSpc>
-                  <a:spcPts val="1296"/>
-                </a:lnSpc>
-                <a:spcBef>
-                  <a:spcPts val="0"/>
-                </a:spcBef>
-                <a:spcAft>
-                  <a:spcPts val="0"/>
-                </a:spcAft>
-                <a:buNone/>
-              </a:pPr>
-              <a:r>
-                <a:rPr lang="ru-RU" sz="1000" b="0" dirty="0">
-                  <a:solidFill>
-                    <a:srgbClr val="C5D2D8"/>
-                  </a:solidFill>
-                </a:rPr>
-                <a:t>|</a:t>
-              </a:r>
-            </a:p>
-          </p:txBody>
-        </p:sp>
-        <p:sp>
-          <p:nvSpPr>
-            <p:cNvPr id="132" name="Числа: % обеспеченности"/>
-            <p:cNvSpPr txBox="1"/>
-            <p:nvPr/>
-          </p:nvSpPr>
-          <p:spPr>
-            <a:xfrm>
-              <a:off x="11186130" y="1792224"/>
-              <a:ext cx="502920" cy="1152144"/>
-            </a:xfrm>
-            <a:prstGeom prst="rect">
-              <a:avLst/>
-            </a:prstGeom>
-            <a:noFill/>
-          </p:spPr>
-          <p:txBody>
-            <a:bodyPr wrap="square" lIns="0" tIns="0" rIns="0" bIns="0" anchor="t">
-              <a:noAutofit/>
-            </a:bodyPr>
-            <a:lstStyle/>
-            <a:p>
-              <a:pPr marL="0" indent="0" algn="l">
-                <a:lnSpc>
-                  <a:spcPts val="1296"/>
-                </a:lnSpc>
-                <a:spcBef>
-                  <a:spcPts val="0"/>
-                </a:spcBef>
-                <a:spcAft>
-                  <a:spcPts val="0"/>
-                </a:spcAft>
-                <a:buNone/>
-              </a:pPr>
-              <a:r>
-                <a:rPr lang="ru-RU" sz="1050" b="1" dirty="0">
-                  <a:solidFill>
-                    <a:schemeClr val="accent4"/>
-                  </a:solidFill>
-                </a:rPr>
-                <a:t>100</a:t>
-              </a:r>
-              <a:r>
-                <a:rPr lang="ru-RU" sz="800" b="1" dirty="0">
-                  <a:solidFill>
-                    <a:schemeClr val="accent4"/>
-                  </a:solidFill>
-                </a:rPr>
-                <a:t>%</a:t>
-              </a:r>
-            </a:p>
-            <a:p>
-              <a:pPr marL="0" indent="0" algn="l">
-                <a:lnSpc>
-                  <a:spcPts val="1296"/>
-                </a:lnSpc>
-                <a:spcBef>
-                  <a:spcPts val="0"/>
-                </a:spcBef>
-                <a:spcAft>
-                  <a:spcPts val="0"/>
-                </a:spcAft>
-                <a:buNone/>
-              </a:pPr>
-              <a:r>
-                <a:rPr lang="ru-RU" sz="1050" b="1" dirty="0">
-                  <a:solidFill>
-                    <a:srgbClr val="B76E00"/>
-                  </a:solidFill>
-                </a:rPr>
-                <a:t>87,5</a:t>
-              </a:r>
-              <a:r>
-                <a:rPr lang="ru-RU" sz="800" b="1" dirty="0">
-                  <a:solidFill>
-                    <a:srgbClr val="B76E00"/>
-                  </a:solidFill>
-                </a:rPr>
-                <a:t>%</a:t>
-              </a:r>
-            </a:p>
-            <a:p>
-              <a:pPr marL="0" indent="0" algn="l">
-                <a:lnSpc>
-                  <a:spcPts val="1296"/>
-                </a:lnSpc>
-                <a:spcBef>
-                  <a:spcPts val="0"/>
-                </a:spcBef>
-                <a:spcAft>
-                  <a:spcPts val="0"/>
-                </a:spcAft>
-                <a:buNone/>
-              </a:pPr>
-              <a:r>
-                <a:rPr lang="ru-RU" sz="1050" b="1" dirty="0">
-                  <a:solidFill>
-                    <a:schemeClr val="accent4"/>
-                  </a:solidFill>
-                </a:rPr>
-                <a:t>91,9</a:t>
-              </a:r>
-              <a:r>
-                <a:rPr lang="ru-RU" sz="800" b="1" dirty="0">
-                  <a:solidFill>
-                    <a:schemeClr val="accent4"/>
-                  </a:solidFill>
-                </a:rPr>
-                <a:t>%</a:t>
-              </a:r>
-            </a:p>
-            <a:p>
-              <a:pPr marL="0" indent="0" algn="l">
-                <a:lnSpc>
-                  <a:spcPts val="1296"/>
-                </a:lnSpc>
-                <a:spcBef>
-                  <a:spcPts val="0"/>
-                </a:spcBef>
-                <a:spcAft>
-                  <a:spcPts val="0"/>
-                </a:spcAft>
-                <a:buNone/>
-              </a:pPr>
-              <a:r>
-                <a:rPr lang="ru-RU" sz="1050" b="1" dirty="0">
-                  <a:solidFill>
-                    <a:srgbClr val="B76E00"/>
-                  </a:solidFill>
-                </a:rPr>
-                <a:t>80</a:t>
-              </a:r>
-              <a:r>
-                <a:rPr lang="ru-RU" sz="800" b="1" dirty="0">
-                  <a:solidFill>
-                    <a:srgbClr val="B76E00"/>
-                  </a:solidFill>
-                </a:rPr>
-                <a:t>%</a:t>
-              </a:r>
-            </a:p>
-            <a:p>
-              <a:pPr marL="0" indent="0" algn="l">
-                <a:lnSpc>
-                  <a:spcPts val="1296"/>
-                </a:lnSpc>
-                <a:spcBef>
-                  <a:spcPts val="0"/>
-                </a:spcBef>
-                <a:spcAft>
-                  <a:spcPts val="0"/>
-                </a:spcAft>
-                <a:buNone/>
-              </a:pPr>
-              <a:r>
-                <a:rPr lang="ru-RU" sz="1050" b="1" dirty="0">
-                  <a:solidFill>
-                    <a:schemeClr val="accent4"/>
-                  </a:solidFill>
-                </a:rPr>
-                <a:t>93,5</a:t>
-              </a:r>
-              <a:r>
-                <a:rPr lang="ru-RU" sz="800" b="1" dirty="0">
-                  <a:solidFill>
-                    <a:schemeClr val="accent4"/>
-                  </a:solidFill>
-                </a:rPr>
-                <a:t>%</a:t>
-              </a:r>
-            </a:p>
-            <a:p>
-              <a:pPr marL="0" indent="0" algn="l">
-                <a:lnSpc>
-                  <a:spcPts val="1296"/>
-                </a:lnSpc>
-                <a:spcBef>
-                  <a:spcPts val="0"/>
-                </a:spcBef>
-                <a:spcAft>
-                  <a:spcPts val="0"/>
-                </a:spcAft>
-                <a:buNone/>
-              </a:pPr>
-              <a:r>
-                <a:rPr lang="ru-RU" sz="1050" b="1" dirty="0">
-                  <a:solidFill>
-                    <a:schemeClr val="accent4"/>
-                  </a:solidFill>
-                </a:rPr>
-                <a:t>95,2</a:t>
-              </a:r>
-              <a:r>
-                <a:rPr lang="ru-RU" sz="800" b="1" dirty="0">
-                  <a:solidFill>
-                    <a:schemeClr val="accent4"/>
-                  </a:solidFill>
-                </a:rPr>
-                <a:t>%</a:t>
-              </a:r>
-            </a:p>
-            <a:p>
-              <a:pPr marL="0" indent="0" algn="l">
-                <a:lnSpc>
-                  <a:spcPts val="1296"/>
-                </a:lnSpc>
-                <a:spcBef>
-                  <a:spcPts val="0"/>
-                </a:spcBef>
-                <a:spcAft>
-                  <a:spcPts val="0"/>
-                </a:spcAft>
-                <a:buNone/>
-              </a:pPr>
-              <a:r>
-                <a:rPr lang="ru-RU" sz="1050" b="1" dirty="0">
-                  <a:solidFill>
-                    <a:srgbClr val="B76E00"/>
-                  </a:solidFill>
-                </a:rPr>
-                <a:t>82</a:t>
-              </a:r>
-              <a:r>
-                <a:rPr lang="ru-RU" sz="800" b="1" dirty="0">
-                  <a:solidFill>
-                    <a:srgbClr val="B76E00"/>
-                  </a:solidFill>
-                </a:rPr>
-                <a:t>%</a:t>
-              </a:r>
-            </a:p>
-          </p:txBody>
-        </p:sp>
       </p:grpSp>
     </p:spTree>
     <p:extLst>

</xml_diff>

<commit_message>
Cell-linked chart labels via Value From Cells; single input table A:C
- labels use c15 datalabelsRange so PowerPoint keeps them in sync with the data sheet
- plan is now typed in column C of the visible table; remainder is computed
- sorted block and label texts remain formula-driven

Co-Authored-By: Claude Sonnet 5.5 <noreply@anthropic.com>
Claude-Session: https://claude.ai/code/session_01NEsYnofsV4CojKrpDNMyGk
</commit_message>
<xml_diff>
--- a/digital_twin_resources.pptx
+++ b/digital_twin_resources.pptx
@@ -692,7 +692,7 @@
               <c:strCache>
                 <c:ptCount val="1"/>
                 <c:pt idx="0">
-                  <c:v>План, ПШЕ</c:v>
+                  <c:v>Остаток до плана, ПШЕ</c:v>
                 </c:pt>
               </c:strCache>
             </c:strRef>
@@ -876,17 +876,23 @@
           <c:dLbls>
             <c:dLbl>
               <c:idx val="0"/>
-              <c:layout/>
               <c:tx>
-                <c:strRef>
-                  <c:f>Лист1!$T$2</c:f>
-                  <c:strCache>
-                    <c:ptCount val="1"/>
-                    <c:pt idx="0">
-                      <c:v>3</c:v>
-                    </c:pt>
-                  </c:strCache>
-                </c:strRef>
+                <c:rich>
+                  <a:bodyPr wrap="none" lIns="0" tIns="0" rIns="0" bIns="0" anchor="ctr"/>
+                  <a:lstStyle/>
+                  <a:p>
+                    <a:fld id="{9B5E3B61-41DD-402F-8057-79B0D7EB43A9}" type="CELLRANGE">
+                      <a:rPr lang="ru-RU" sz="1050" b="1">
+                        <a:solidFill>
+                          <a:schemeClr val="accent3"/>
+                        </a:solidFill>
+                      </a:rPr>
+                      <a:pPr/>
+                      <a:t>[CELLRANGE]</a:t>
+                    </a:fld>
+                    <a:endParaRPr lang="ru-RU"/>
+                  </a:p>
+                </c:rich>
               </c:tx>
               <c:spPr>
                 <a:noFill/>
@@ -894,41 +900,39 @@
                   <a:noFill/>
                 </a:ln>
               </c:spPr>
-              <c:txPr>
-                <a:bodyPr wrap="none" lIns="0" tIns="0" rIns="0" bIns="0" anchor="ctr"/>
-                <a:lstStyle/>
-                <a:p>
-                  <a:pPr>
-                    <a:defRPr sz="1050" b="1">
-                      <a:solidFill>
-                        <a:schemeClr val="accent3"/>
-                      </a:solidFill>
-                    </a:defRPr>
-                  </a:pPr>
-                  <a:endParaRPr lang="ru-RU"/>
-                </a:p>
-              </c:txPr>
               <c:dLblPos val="ctr"/>
               <c:showLegendKey val="0"/>
-              <c:showVal val="1"/>
+              <c:showVal val="0"/>
               <c:showCatName val="0"/>
               <c:showSerName val="0"/>
               <c:showPercent val="0"/>
               <c:showBubbleSize val="0"/>
+              <c:extLst>
+                <c:ext xmlns:c15="http://schemas.microsoft.com/office/drawing/2012/chart" uri="{CE6537A1-D6FC-4f65-9D91-7224C49458BB}">
+                  <c15:dlblFieldTable/>
+                  <c15:showDataLabelsRange val="1"/>
+                </c:ext>
+              </c:extLst>
             </c:dLbl>
             <c:dLbl>
               <c:idx val="1"/>
-              <c:layout/>
               <c:tx>
-                <c:strRef>
-                  <c:f>Лист1!$T$3</c:f>
-                  <c:strCache>
-                    <c:ptCount val="1"/>
-                    <c:pt idx="0">
-                      <c:v>20</c:v>
-                    </c:pt>
-                  </c:strCache>
-                </c:strRef>
+                <c:rich>
+                  <a:bodyPr wrap="none" lIns="0" tIns="0" rIns="0" bIns="0" anchor="ctr"/>
+                  <a:lstStyle/>
+                  <a:p>
+                    <a:fld id="{D52364A3-85AC-4454-BDFA-BADDCC64101D}" type="CELLRANGE">
+                      <a:rPr lang="ru-RU" sz="1050" b="1">
+                        <a:solidFill>
+                          <a:schemeClr val="accent3"/>
+                        </a:solidFill>
+                      </a:rPr>
+                      <a:pPr/>
+                      <a:t>[CELLRANGE]</a:t>
+                    </a:fld>
+                    <a:endParaRPr lang="ru-RU"/>
+                  </a:p>
+                </c:rich>
               </c:tx>
               <c:spPr>
                 <a:noFill/>
@@ -936,41 +940,39 @@
                   <a:noFill/>
                 </a:ln>
               </c:spPr>
-              <c:txPr>
-                <a:bodyPr wrap="none" lIns="0" tIns="0" rIns="0" bIns="0" anchor="ctr"/>
-                <a:lstStyle/>
-                <a:p>
-                  <a:pPr>
-                    <a:defRPr sz="1050" b="1">
-                      <a:solidFill>
-                        <a:schemeClr val="accent3"/>
-                      </a:solidFill>
-                    </a:defRPr>
-                  </a:pPr>
-                  <a:endParaRPr lang="ru-RU"/>
-                </a:p>
-              </c:txPr>
               <c:dLblPos val="ctr"/>
               <c:showLegendKey val="0"/>
-              <c:showVal val="1"/>
+              <c:showVal val="0"/>
               <c:showCatName val="0"/>
               <c:showSerName val="0"/>
               <c:showPercent val="0"/>
               <c:showBubbleSize val="0"/>
+              <c:extLst>
+                <c:ext xmlns:c15="http://schemas.microsoft.com/office/drawing/2012/chart" uri="{CE6537A1-D6FC-4f65-9D91-7224C49458BB}">
+                  <c15:dlblFieldTable/>
+                  <c15:showDataLabelsRange val="1"/>
+                </c:ext>
+              </c:extLst>
             </c:dLbl>
             <c:dLbl>
               <c:idx val="2"/>
-              <c:layout/>
               <c:tx>
-                <c:strRef>
-                  <c:f>Лист1!$T$4</c:f>
-                  <c:strCache>
-                    <c:ptCount val="1"/>
-                    <c:pt idx="0">
-                      <c:v>29</c:v>
-                    </c:pt>
-                  </c:strCache>
-                </c:strRef>
+                <c:rich>
+                  <a:bodyPr wrap="none" lIns="0" tIns="0" rIns="0" bIns="0" anchor="ctr"/>
+                  <a:lstStyle/>
+                  <a:p>
+                    <a:fld id="{54F9BBA3-22CA-4D91-A878-486B18D59D48}" type="CELLRANGE">
+                      <a:rPr lang="ru-RU" sz="1050" b="1">
+                        <a:solidFill>
+                          <a:schemeClr val="accent3"/>
+                        </a:solidFill>
+                      </a:rPr>
+                      <a:pPr/>
+                      <a:t>[CELLRANGE]</a:t>
+                    </a:fld>
+                    <a:endParaRPr lang="ru-RU"/>
+                  </a:p>
+                </c:rich>
               </c:tx>
               <c:spPr>
                 <a:noFill/>
@@ -978,41 +980,39 @@
                   <a:noFill/>
                 </a:ln>
               </c:spPr>
-              <c:txPr>
-                <a:bodyPr wrap="none" lIns="0" tIns="0" rIns="0" bIns="0" anchor="ctr"/>
-                <a:lstStyle/>
-                <a:p>
-                  <a:pPr>
-                    <a:defRPr sz="1050" b="1">
-                      <a:solidFill>
-                        <a:schemeClr val="accent3"/>
-                      </a:solidFill>
-                    </a:defRPr>
-                  </a:pPr>
-                  <a:endParaRPr lang="ru-RU"/>
-                </a:p>
-              </c:txPr>
               <c:dLblPos val="ctr"/>
               <c:showLegendKey val="0"/>
-              <c:showVal val="1"/>
+              <c:showVal val="0"/>
               <c:showCatName val="0"/>
               <c:showSerName val="0"/>
               <c:showPercent val="0"/>
               <c:showBubbleSize val="0"/>
+              <c:extLst>
+                <c:ext xmlns:c15="http://schemas.microsoft.com/office/drawing/2012/chart" uri="{CE6537A1-D6FC-4f65-9D91-7224C49458BB}">
+                  <c15:dlblFieldTable/>
+                  <c15:showDataLabelsRange val="1"/>
+                </c:ext>
+              </c:extLst>
             </c:dLbl>
             <c:dLbl>
               <c:idx val="3"/>
-              <c:layout/>
               <c:tx>
-                <c:strRef>
-                  <c:f>Лист1!$T$5</c:f>
-                  <c:strCache>
-                    <c:ptCount val="1"/>
-                    <c:pt idx="0">
-                      <c:v>34</c:v>
-                    </c:pt>
-                  </c:strCache>
-                </c:strRef>
+                <c:rich>
+                  <a:bodyPr wrap="none" lIns="0" tIns="0" rIns="0" bIns="0" anchor="ctr"/>
+                  <a:lstStyle/>
+                  <a:p>
+                    <a:fld id="{85DDAEB5-9F75-4009-8333-E2EA4D42BB3F}" type="CELLRANGE">
+                      <a:rPr lang="ru-RU" sz="1050" b="1">
+                        <a:solidFill>
+                          <a:schemeClr val="accent3"/>
+                        </a:solidFill>
+                      </a:rPr>
+                      <a:pPr/>
+                      <a:t>[CELLRANGE]</a:t>
+                    </a:fld>
+                    <a:endParaRPr lang="ru-RU"/>
+                  </a:p>
+                </c:rich>
               </c:tx>
               <c:spPr>
                 <a:noFill/>
@@ -1020,41 +1020,39 @@
                   <a:noFill/>
                 </a:ln>
               </c:spPr>
-              <c:txPr>
-                <a:bodyPr wrap="none" lIns="0" tIns="0" rIns="0" bIns="0" anchor="ctr"/>
-                <a:lstStyle/>
-                <a:p>
-                  <a:pPr>
-                    <a:defRPr sz="1050" b="1">
-                      <a:solidFill>
-                        <a:schemeClr val="accent3"/>
-                      </a:solidFill>
-                    </a:defRPr>
-                  </a:pPr>
-                  <a:endParaRPr lang="ru-RU"/>
-                </a:p>
-              </c:txPr>
               <c:dLblPos val="ctr"/>
               <c:showLegendKey val="0"/>
-              <c:showVal val="1"/>
+              <c:showVal val="0"/>
               <c:showCatName val="0"/>
               <c:showSerName val="0"/>
               <c:showPercent val="0"/>
               <c:showBubbleSize val="0"/>
+              <c:extLst>
+                <c:ext xmlns:c15="http://schemas.microsoft.com/office/drawing/2012/chart" uri="{CE6537A1-D6FC-4f65-9D91-7224C49458BB}">
+                  <c15:dlblFieldTable/>
+                  <c15:showDataLabelsRange val="1"/>
+                </c:ext>
+              </c:extLst>
             </c:dLbl>
             <c:dLbl>
               <c:idx val="4"/>
-              <c:layout/>
               <c:tx>
-                <c:strRef>
-                  <c:f>Лист1!$T$6</c:f>
-                  <c:strCache>
-                    <c:ptCount val="1"/>
-                    <c:pt idx="0">
-                      <c:v>7</c:v>
-                    </c:pt>
-                  </c:strCache>
-                </c:strRef>
+                <c:rich>
+                  <a:bodyPr wrap="none" lIns="0" tIns="0" rIns="0" bIns="0" anchor="ctr"/>
+                  <a:lstStyle/>
+                  <a:p>
+                    <a:fld id="{DA956C07-9885-423E-82C6-7327601ADC22}" type="CELLRANGE">
+                      <a:rPr lang="ru-RU" sz="1050" b="1">
+                        <a:solidFill>
+                          <a:schemeClr val="accent3"/>
+                        </a:solidFill>
+                      </a:rPr>
+                      <a:pPr/>
+                      <a:t>[CELLRANGE]</a:t>
+                    </a:fld>
+                    <a:endParaRPr lang="ru-RU"/>
+                  </a:p>
+                </c:rich>
               </c:tx>
               <c:spPr>
                 <a:noFill/>
@@ -1062,41 +1060,39 @@
                   <a:noFill/>
                 </a:ln>
               </c:spPr>
-              <c:txPr>
-                <a:bodyPr wrap="none" lIns="0" tIns="0" rIns="0" bIns="0" anchor="ctr"/>
-                <a:lstStyle/>
-                <a:p>
-                  <a:pPr>
-                    <a:defRPr sz="1050" b="1">
-                      <a:solidFill>
-                        <a:schemeClr val="accent3"/>
-                      </a:solidFill>
-                    </a:defRPr>
-                  </a:pPr>
-                  <a:endParaRPr lang="ru-RU"/>
-                </a:p>
-              </c:txPr>
               <c:dLblPos val="ctr"/>
               <c:showLegendKey val="0"/>
-              <c:showVal val="1"/>
+              <c:showVal val="0"/>
               <c:showCatName val="0"/>
               <c:showSerName val="0"/>
               <c:showPercent val="0"/>
               <c:showBubbleSize val="0"/>
+              <c:extLst>
+                <c:ext xmlns:c15="http://schemas.microsoft.com/office/drawing/2012/chart" uri="{CE6537A1-D6FC-4f65-9D91-7224C49458BB}">
+                  <c15:dlblFieldTable/>
+                  <c15:showDataLabelsRange val="1"/>
+                </c:ext>
+              </c:extLst>
             </c:dLbl>
             <c:dLbl>
               <c:idx val="5"/>
-              <c:layout/>
               <c:tx>
-                <c:strRef>
-                  <c:f>Лист1!$T$7</c:f>
-                  <c:strCache>
-                    <c:ptCount val="1"/>
-                    <c:pt idx="0">
-                      <c:v>9</c:v>
-                    </c:pt>
-                  </c:strCache>
-                </c:strRef>
+                <c:rich>
+                  <a:bodyPr wrap="none" lIns="0" tIns="0" rIns="0" bIns="0" anchor="ctr"/>
+                  <a:lstStyle/>
+                  <a:p>
+                    <a:fld id="{892FE1D5-F252-4070-92B4-20A56C710C04}" type="CELLRANGE">
+                      <a:rPr lang="ru-RU" sz="1050" b="1">
+                        <a:solidFill>
+                          <a:schemeClr val="accent3"/>
+                        </a:solidFill>
+                      </a:rPr>
+                      <a:pPr/>
+                      <a:t>[CELLRANGE]</a:t>
+                    </a:fld>
+                    <a:endParaRPr lang="ru-RU"/>
+                  </a:p>
+                </c:rich>
               </c:tx>
               <c:spPr>
                 <a:noFill/>
@@ -1104,41 +1100,39 @@
                   <a:noFill/>
                 </a:ln>
               </c:spPr>
-              <c:txPr>
-                <a:bodyPr wrap="none" lIns="0" tIns="0" rIns="0" bIns="0" anchor="ctr"/>
-                <a:lstStyle/>
-                <a:p>
-                  <a:pPr>
-                    <a:defRPr sz="1050" b="1">
-                      <a:solidFill>
-                        <a:schemeClr val="accent3"/>
-                      </a:solidFill>
-                    </a:defRPr>
-                  </a:pPr>
-                  <a:endParaRPr lang="ru-RU"/>
-                </a:p>
-              </c:txPr>
               <c:dLblPos val="ctr"/>
               <c:showLegendKey val="0"/>
-              <c:showVal val="1"/>
+              <c:showVal val="0"/>
               <c:showCatName val="0"/>
               <c:showSerName val="0"/>
               <c:showPercent val="0"/>
               <c:showBubbleSize val="0"/>
+              <c:extLst>
+                <c:ext xmlns:c15="http://schemas.microsoft.com/office/drawing/2012/chart" uri="{CE6537A1-D6FC-4f65-9D91-7224C49458BB}">
+                  <c15:dlblFieldTable/>
+                  <c15:showDataLabelsRange val="1"/>
+                </c:ext>
+              </c:extLst>
             </c:dLbl>
             <c:dLbl>
               <c:idx val="6"/>
-              <c:layout/>
               <c:tx>
-                <c:strRef>
-                  <c:f>Лист1!$T$8</c:f>
-                  <c:strCache>
-                    <c:ptCount val="1"/>
-                    <c:pt idx="0">
-                      <c:v>16</c:v>
-                    </c:pt>
-                  </c:strCache>
-                </c:strRef>
+                <c:rich>
+                  <a:bodyPr wrap="none" lIns="0" tIns="0" rIns="0" bIns="0" anchor="ctr"/>
+                  <a:lstStyle/>
+                  <a:p>
+                    <a:fld id="{F03C4ADC-6BCF-4DCD-965E-7DF120AF4BE2}" type="CELLRANGE">
+                      <a:rPr lang="ru-RU" sz="1050" b="1">
+                        <a:solidFill>
+                          <a:schemeClr val="accent3"/>
+                        </a:solidFill>
+                      </a:rPr>
+                      <a:pPr/>
+                      <a:t>[CELLRANGE]</a:t>
+                    </a:fld>
+                    <a:endParaRPr lang="ru-RU"/>
+                  </a:p>
+                </c:rich>
               </c:tx>
               <c:spPr>
                 <a:noFill/>
@@ -1146,27 +1140,19 @@
                   <a:noFill/>
                 </a:ln>
               </c:spPr>
-              <c:txPr>
-                <a:bodyPr wrap="none" lIns="0" tIns="0" rIns="0" bIns="0" anchor="ctr"/>
-                <a:lstStyle/>
-                <a:p>
-                  <a:pPr>
-                    <a:defRPr sz="1050" b="1">
-                      <a:solidFill>
-                        <a:schemeClr val="accent3"/>
-                      </a:solidFill>
-                    </a:defRPr>
-                  </a:pPr>
-                  <a:endParaRPr lang="ru-RU"/>
-                </a:p>
-              </c:txPr>
               <c:dLblPos val="ctr"/>
               <c:showLegendKey val="0"/>
-              <c:showVal val="1"/>
+              <c:showVal val="0"/>
               <c:showCatName val="0"/>
               <c:showSerName val="0"/>
               <c:showPercent val="0"/>
               <c:showBubbleSize val="0"/>
+              <c:extLst>
+                <c:ext xmlns:c15="http://schemas.microsoft.com/office/drawing/2012/chart" uri="{CE6537A1-D6FC-4f65-9D91-7224C49458BB}">
+                  <c15:dlblFieldTable/>
+                  <c15:showDataLabelsRange val="1"/>
+                </c:ext>
+              </c:extLst>
             </c:dLbl>
             <c:spPr>
               <a:noFill/>
@@ -1190,11 +1176,17 @@
             </c:txPr>
             <c:dLblPos val="ctr"/>
             <c:showLegendKey val="0"/>
-            <c:showVal val="1"/>
+            <c:showVal val="0"/>
             <c:showCatName val="0"/>
             <c:showSerName val="0"/>
             <c:showPercent val="0"/>
             <c:showBubbleSize val="0"/>
+            <c:extLst>
+              <c:ext xmlns:c15="http://schemas.microsoft.com/office/drawing/2012/chart" uri="{CE6537A1-D6FC-4f65-9D91-7224C49458BB}">
+                <c15:showDataLabelsRange val="1"/>
+                <c15:showLeaderLines val="0"/>
+              </c:ext>
+            </c:extLst>
           </c:dLbls>
           <c:cat>
             <c:strRef>
@@ -1255,6 +1247,37 @@
               </c:numCache>
             </c:numRef>
           </c:val>
+          <c:extLst>
+            <c:ext xmlns:c15="http://schemas.microsoft.com/office/drawing/2012/chart" uri="{02D57815-91ED-43cb-92C2-25804820EDAC}">
+              <c15:datalabelsRange>
+                <c15:f>Лист1!$T$2:$T$8</c15:f>
+                <c15:dlblRangeCache>
+                  <c:ptCount val="7"/>
+                  <c:pt idx="0">
+                    <c:v>3</c:v>
+                  </c:pt>
+                  <c:pt idx="1">
+                    <c:v>20</c:v>
+                  </c:pt>
+                  <c:pt idx="2">
+                    <c:v>29</c:v>
+                  </c:pt>
+                  <c:pt idx="3">
+                    <c:v>34</c:v>
+                  </c:pt>
+                  <c:pt idx="4">
+                    <c:v>7</c:v>
+                  </c:pt>
+                  <c:pt idx="5">
+                    <c:v>9</c:v>
+                  </c:pt>
+                  <c:pt idx="6">
+                    <c:v>16</c:v>
+                  </c:pt>
+                </c15:dlblRangeCache>
+              </c15:datalabelsRange>
+            </c:ext>
+          </c:extLst>
         </c:ser>
         <c:ser>
           <c:idx val="4"/>
@@ -1280,17 +1303,23 @@
           <c:dLbls>
             <c:dLbl>
               <c:idx val="0"/>
-              <c:layout/>
               <c:tx>
-                <c:strRef>
-                  <c:f>Лист1!$V$2</c:f>
-                  <c:strCache>
-                    <c:ptCount val="1"/>
-                    <c:pt idx="0">
-                      <c:v>| 3</c:v>
-                    </c:pt>
-                  </c:strCache>
-                </c:strRef>
+                <c:rich>
+                  <a:bodyPr wrap="none" lIns="0" tIns="0" rIns="0" bIns="0" anchor="ctr"/>
+                  <a:lstStyle/>
+                  <a:p>
+                    <a:fld id="{37A7B07C-109B-404A-8108-E17694132615}" type="CELLRANGE">
+                      <a:rPr lang="ru-RU" sz="1050" b="1">
+                        <a:solidFill>
+                          <a:srgbClr val="7B8794"/>
+                        </a:solidFill>
+                      </a:rPr>
+                      <a:pPr/>
+                      <a:t>[CELLRANGE]</a:t>
+                    </a:fld>
+                    <a:endParaRPr lang="ru-RU"/>
+                  </a:p>
+                </c:rich>
               </c:tx>
               <c:spPr>
                 <a:noFill/>
@@ -1298,41 +1327,39 @@
                   <a:noFill/>
                 </a:ln>
               </c:spPr>
-              <c:txPr>
-                <a:bodyPr wrap="none" lIns="0" tIns="0" rIns="0" bIns="0" anchor="ctr"/>
-                <a:lstStyle/>
-                <a:p>
-                  <a:pPr>
-                    <a:defRPr sz="1050" b="1">
-                      <a:solidFill>
-                        <a:srgbClr val="7B8794"/>
-                      </a:solidFill>
-                    </a:defRPr>
-                  </a:pPr>
-                  <a:endParaRPr lang="ru-RU"/>
-                </a:p>
-              </c:txPr>
               <c:dLblPos val="ctr"/>
               <c:showLegendKey val="0"/>
-              <c:showVal val="1"/>
+              <c:showVal val="0"/>
               <c:showCatName val="0"/>
               <c:showSerName val="0"/>
               <c:showPercent val="0"/>
               <c:showBubbleSize val="0"/>
+              <c:extLst>
+                <c:ext xmlns:c15="http://schemas.microsoft.com/office/drawing/2012/chart" uri="{CE6537A1-D6FC-4f65-9D91-7224C49458BB}">
+                  <c15:dlblFieldTable/>
+                  <c15:showDataLabelsRange val="1"/>
+                </c:ext>
+              </c:extLst>
             </c:dLbl>
             <c:dLbl>
               <c:idx val="1"/>
-              <c:layout/>
               <c:tx>
-                <c:strRef>
-                  <c:f>Лист1!$V$3</c:f>
-                  <c:strCache>
-                    <c:ptCount val="1"/>
-                    <c:pt idx="0">
-                      <c:v>| 21</c:v>
-                    </c:pt>
-                  </c:strCache>
-                </c:strRef>
+                <c:rich>
+                  <a:bodyPr wrap="none" lIns="0" tIns="0" rIns="0" bIns="0" anchor="ctr"/>
+                  <a:lstStyle/>
+                  <a:p>
+                    <a:fld id="{7DD450E0-3832-44E4-BC7E-49FD218D483A}" type="CELLRANGE">
+                      <a:rPr lang="ru-RU" sz="1050" b="1">
+                        <a:solidFill>
+                          <a:srgbClr val="7B8794"/>
+                        </a:solidFill>
+                      </a:rPr>
+                      <a:pPr/>
+                      <a:t>[CELLRANGE]</a:t>
+                    </a:fld>
+                    <a:endParaRPr lang="ru-RU"/>
+                  </a:p>
+                </c:rich>
               </c:tx>
               <c:spPr>
                 <a:noFill/>
@@ -1340,41 +1367,39 @@
                   <a:noFill/>
                 </a:ln>
               </c:spPr>
-              <c:txPr>
-                <a:bodyPr wrap="none" lIns="0" tIns="0" rIns="0" bIns="0" anchor="ctr"/>
-                <a:lstStyle/>
-                <a:p>
-                  <a:pPr>
-                    <a:defRPr sz="1050" b="1">
-                      <a:solidFill>
-                        <a:srgbClr val="7B8794"/>
-                      </a:solidFill>
-                    </a:defRPr>
-                  </a:pPr>
-                  <a:endParaRPr lang="ru-RU"/>
-                </a:p>
-              </c:txPr>
               <c:dLblPos val="ctr"/>
               <c:showLegendKey val="0"/>
-              <c:showVal val="1"/>
+              <c:showVal val="0"/>
               <c:showCatName val="0"/>
               <c:showSerName val="0"/>
               <c:showPercent val="0"/>
               <c:showBubbleSize val="0"/>
+              <c:extLst>
+                <c:ext xmlns:c15="http://schemas.microsoft.com/office/drawing/2012/chart" uri="{CE6537A1-D6FC-4f65-9D91-7224C49458BB}">
+                  <c15:dlblFieldTable/>
+                  <c15:showDataLabelsRange val="1"/>
+                </c:ext>
+              </c:extLst>
             </c:dLbl>
             <c:dLbl>
               <c:idx val="2"/>
-              <c:layout/>
               <c:tx>
-                <c:strRef>
-                  <c:f>Лист1!$V$4</c:f>
-                  <c:strCache>
-                    <c:ptCount val="1"/>
-                    <c:pt idx="0">
-                      <c:v>| 31</c:v>
-                    </c:pt>
-                  </c:strCache>
-                </c:strRef>
+                <c:rich>
+                  <a:bodyPr wrap="none" lIns="0" tIns="0" rIns="0" bIns="0" anchor="ctr"/>
+                  <a:lstStyle/>
+                  <a:p>
+                    <a:fld id="{DE7EABEC-F4C6-4C01-A6DB-64C8FF5069FD}" type="CELLRANGE">
+                      <a:rPr lang="ru-RU" sz="1050" b="1">
+                        <a:solidFill>
+                          <a:srgbClr val="7B8794"/>
+                        </a:solidFill>
+                      </a:rPr>
+                      <a:pPr/>
+                      <a:t>[CELLRANGE]</a:t>
+                    </a:fld>
+                    <a:endParaRPr lang="ru-RU"/>
+                  </a:p>
+                </c:rich>
               </c:tx>
               <c:spPr>
                 <a:noFill/>
@@ -1382,41 +1407,39 @@
                   <a:noFill/>
                 </a:ln>
               </c:spPr>
-              <c:txPr>
-                <a:bodyPr wrap="none" lIns="0" tIns="0" rIns="0" bIns="0" anchor="ctr"/>
-                <a:lstStyle/>
-                <a:p>
-                  <a:pPr>
-                    <a:defRPr sz="1050" b="1">
-                      <a:solidFill>
-                        <a:srgbClr val="7B8794"/>
-                      </a:solidFill>
-                    </a:defRPr>
-                  </a:pPr>
-                  <a:endParaRPr lang="ru-RU"/>
-                </a:p>
-              </c:txPr>
               <c:dLblPos val="ctr"/>
               <c:showLegendKey val="0"/>
-              <c:showVal val="1"/>
+              <c:showVal val="0"/>
               <c:showCatName val="0"/>
               <c:showSerName val="0"/>
               <c:showPercent val="0"/>
               <c:showBubbleSize val="0"/>
+              <c:extLst>
+                <c:ext xmlns:c15="http://schemas.microsoft.com/office/drawing/2012/chart" uri="{CE6537A1-D6FC-4f65-9D91-7224C49458BB}">
+                  <c15:dlblFieldTable/>
+                  <c15:showDataLabelsRange val="1"/>
+                </c:ext>
+              </c:extLst>
             </c:dLbl>
             <c:dLbl>
               <c:idx val="3"/>
-              <c:layout/>
               <c:tx>
-                <c:strRef>
-                  <c:f>Лист1!$V$5</c:f>
-                  <c:strCache>
-                    <c:ptCount val="1"/>
-                    <c:pt idx="0">
-                      <c:v>| 37</c:v>
-                    </c:pt>
-                  </c:strCache>
-                </c:strRef>
+                <c:rich>
+                  <a:bodyPr wrap="none" lIns="0" tIns="0" rIns="0" bIns="0" anchor="ctr"/>
+                  <a:lstStyle/>
+                  <a:p>
+                    <a:fld id="{924E0DC7-3301-4DAE-9D6C-793DC52B6F3E}" type="CELLRANGE">
+                      <a:rPr lang="ru-RU" sz="1050" b="1">
+                        <a:solidFill>
+                          <a:srgbClr val="7B8794"/>
+                        </a:solidFill>
+                      </a:rPr>
+                      <a:pPr/>
+                      <a:t>[CELLRANGE]</a:t>
+                    </a:fld>
+                    <a:endParaRPr lang="ru-RU"/>
+                  </a:p>
+                </c:rich>
               </c:tx>
               <c:spPr>
                 <a:noFill/>
@@ -1424,41 +1447,39 @@
                   <a:noFill/>
                 </a:ln>
               </c:spPr>
-              <c:txPr>
-                <a:bodyPr wrap="none" lIns="0" tIns="0" rIns="0" bIns="0" anchor="ctr"/>
-                <a:lstStyle/>
-                <a:p>
-                  <a:pPr>
-                    <a:defRPr sz="1050" b="1">
-                      <a:solidFill>
-                        <a:srgbClr val="7B8794"/>
-                      </a:solidFill>
-                    </a:defRPr>
-                  </a:pPr>
-                  <a:endParaRPr lang="ru-RU"/>
-                </a:p>
-              </c:txPr>
               <c:dLblPos val="ctr"/>
               <c:showLegendKey val="0"/>
-              <c:showVal val="1"/>
+              <c:showVal val="0"/>
               <c:showCatName val="0"/>
               <c:showSerName val="0"/>
               <c:showPercent val="0"/>
               <c:showBubbleSize val="0"/>
+              <c:extLst>
+                <c:ext xmlns:c15="http://schemas.microsoft.com/office/drawing/2012/chart" uri="{CE6537A1-D6FC-4f65-9D91-7224C49458BB}">
+                  <c15:dlblFieldTable/>
+                  <c15:showDataLabelsRange val="1"/>
+                </c:ext>
+              </c:extLst>
             </c:dLbl>
             <c:dLbl>
               <c:idx val="4"/>
-              <c:layout/>
               <c:tx>
-                <c:strRef>
-                  <c:f>Лист1!$V$6</c:f>
-                  <c:strCache>
-                    <c:ptCount val="1"/>
-                    <c:pt idx="0">
-                      <c:v>| 8</c:v>
-                    </c:pt>
-                  </c:strCache>
-                </c:strRef>
+                <c:rich>
+                  <a:bodyPr wrap="none" lIns="0" tIns="0" rIns="0" bIns="0" anchor="ctr"/>
+                  <a:lstStyle/>
+                  <a:p>
+                    <a:fld id="{59B4845B-1770-4A50-AD7F-ADD5665249A8}" type="CELLRANGE">
+                      <a:rPr lang="ru-RU" sz="1050" b="1">
+                        <a:solidFill>
+                          <a:srgbClr val="7B8794"/>
+                        </a:solidFill>
+                      </a:rPr>
+                      <a:pPr/>
+                      <a:t>[CELLRANGE]</a:t>
+                    </a:fld>
+                    <a:endParaRPr lang="ru-RU"/>
+                  </a:p>
+                </c:rich>
               </c:tx>
               <c:spPr>
                 <a:noFill/>
@@ -1466,41 +1487,39 @@
                   <a:noFill/>
                 </a:ln>
               </c:spPr>
-              <c:txPr>
-                <a:bodyPr wrap="none" lIns="0" tIns="0" rIns="0" bIns="0" anchor="ctr"/>
-                <a:lstStyle/>
-                <a:p>
-                  <a:pPr>
-                    <a:defRPr sz="1050" b="1">
-                      <a:solidFill>
-                        <a:srgbClr val="7B8794"/>
-                      </a:solidFill>
-                    </a:defRPr>
-                  </a:pPr>
-                  <a:endParaRPr lang="ru-RU"/>
-                </a:p>
-              </c:txPr>
               <c:dLblPos val="ctr"/>
               <c:showLegendKey val="0"/>
-              <c:showVal val="1"/>
+              <c:showVal val="0"/>
               <c:showCatName val="0"/>
               <c:showSerName val="0"/>
               <c:showPercent val="0"/>
               <c:showBubbleSize val="0"/>
+              <c:extLst>
+                <c:ext xmlns:c15="http://schemas.microsoft.com/office/drawing/2012/chart" uri="{CE6537A1-D6FC-4f65-9D91-7224C49458BB}">
+                  <c15:dlblFieldTable/>
+                  <c15:showDataLabelsRange val="1"/>
+                </c:ext>
+              </c:extLst>
             </c:dLbl>
             <c:dLbl>
               <c:idx val="5"/>
-              <c:layout/>
               <c:tx>
-                <c:strRef>
-                  <c:f>Лист1!$V$7</c:f>
-                  <c:strCache>
-                    <c:ptCount val="1"/>
-                    <c:pt idx="0">
-                      <c:v>| 11</c:v>
-                    </c:pt>
-                  </c:strCache>
-                </c:strRef>
+                <c:rich>
+                  <a:bodyPr wrap="none" lIns="0" tIns="0" rIns="0" bIns="0" anchor="ctr"/>
+                  <a:lstStyle/>
+                  <a:p>
+                    <a:fld id="{D9CF3EA4-E5A3-40B3-8307-44FD83AADB22}" type="CELLRANGE">
+                      <a:rPr lang="ru-RU" sz="1050" b="1">
+                        <a:solidFill>
+                          <a:srgbClr val="7B8794"/>
+                        </a:solidFill>
+                      </a:rPr>
+                      <a:pPr/>
+                      <a:t>[CELLRANGE]</a:t>
+                    </a:fld>
+                    <a:endParaRPr lang="ru-RU"/>
+                  </a:p>
+                </c:rich>
               </c:tx>
               <c:spPr>
                 <a:noFill/>
@@ -1508,41 +1527,39 @@
                   <a:noFill/>
                 </a:ln>
               </c:spPr>
-              <c:txPr>
-                <a:bodyPr wrap="none" lIns="0" tIns="0" rIns="0" bIns="0" anchor="ctr"/>
-                <a:lstStyle/>
-                <a:p>
-                  <a:pPr>
-                    <a:defRPr sz="1050" b="1">
-                      <a:solidFill>
-                        <a:srgbClr val="7B8794"/>
-                      </a:solidFill>
-                    </a:defRPr>
-                  </a:pPr>
-                  <a:endParaRPr lang="ru-RU"/>
-                </a:p>
-              </c:txPr>
               <c:dLblPos val="ctr"/>
               <c:showLegendKey val="0"/>
-              <c:showVal val="1"/>
+              <c:showVal val="0"/>
               <c:showCatName val="0"/>
               <c:showSerName val="0"/>
               <c:showPercent val="0"/>
               <c:showBubbleSize val="0"/>
+              <c:extLst>
+                <c:ext xmlns:c15="http://schemas.microsoft.com/office/drawing/2012/chart" uri="{CE6537A1-D6FC-4f65-9D91-7224C49458BB}">
+                  <c15:dlblFieldTable/>
+                  <c15:showDataLabelsRange val="1"/>
+                </c:ext>
+              </c:extLst>
             </c:dLbl>
             <c:dLbl>
               <c:idx val="6"/>
-              <c:layout/>
               <c:tx>
-                <c:strRef>
-                  <c:f>Лист1!$V$8</c:f>
-                  <c:strCache>
-                    <c:ptCount val="1"/>
-                    <c:pt idx="0">
-                      <c:v>| 20</c:v>
-                    </c:pt>
-                  </c:strCache>
-                </c:strRef>
+                <c:rich>
+                  <a:bodyPr wrap="none" lIns="0" tIns="0" rIns="0" bIns="0" anchor="ctr"/>
+                  <a:lstStyle/>
+                  <a:p>
+                    <a:fld id="{69C75D70-B802-4A29-B4D5-D89EEAAB7BE2}" type="CELLRANGE">
+                      <a:rPr lang="ru-RU" sz="1050" b="1">
+                        <a:solidFill>
+                          <a:srgbClr val="7B8794"/>
+                        </a:solidFill>
+                      </a:rPr>
+                      <a:pPr/>
+                      <a:t>[CELLRANGE]</a:t>
+                    </a:fld>
+                    <a:endParaRPr lang="ru-RU"/>
+                  </a:p>
+                </c:rich>
               </c:tx>
               <c:spPr>
                 <a:noFill/>
@@ -1550,27 +1567,19 @@
                   <a:noFill/>
                 </a:ln>
               </c:spPr>
-              <c:txPr>
-                <a:bodyPr wrap="none" lIns="0" tIns="0" rIns="0" bIns="0" anchor="ctr"/>
-                <a:lstStyle/>
-                <a:p>
-                  <a:pPr>
-                    <a:defRPr sz="1050" b="1">
-                      <a:solidFill>
-                        <a:srgbClr val="7B8794"/>
-                      </a:solidFill>
-                    </a:defRPr>
-                  </a:pPr>
-                  <a:endParaRPr lang="ru-RU"/>
-                </a:p>
-              </c:txPr>
               <c:dLblPos val="ctr"/>
               <c:showLegendKey val="0"/>
-              <c:showVal val="1"/>
+              <c:showVal val="0"/>
               <c:showCatName val="0"/>
               <c:showSerName val="0"/>
               <c:showPercent val="0"/>
               <c:showBubbleSize val="0"/>
+              <c:extLst>
+                <c:ext xmlns:c15="http://schemas.microsoft.com/office/drawing/2012/chart" uri="{CE6537A1-D6FC-4f65-9D91-7224C49458BB}">
+                  <c15:dlblFieldTable/>
+                  <c15:showDataLabelsRange val="1"/>
+                </c:ext>
+              </c:extLst>
             </c:dLbl>
             <c:spPr>
               <a:noFill/>
@@ -1594,11 +1603,17 @@
             </c:txPr>
             <c:dLblPos val="ctr"/>
             <c:showLegendKey val="0"/>
-            <c:showVal val="1"/>
+            <c:showVal val="0"/>
             <c:showCatName val="0"/>
             <c:showSerName val="0"/>
             <c:showPercent val="0"/>
             <c:showBubbleSize val="0"/>
+            <c:extLst>
+              <c:ext xmlns:c15="http://schemas.microsoft.com/office/drawing/2012/chart" uri="{CE6537A1-D6FC-4f65-9D91-7224C49458BB}">
+                <c15:showDataLabelsRange val="1"/>
+                <c15:showLeaderLines val="0"/>
+              </c:ext>
+            </c:extLst>
           </c:dLbls>
           <c:cat>
             <c:strRef>
@@ -1659,6 +1674,37 @@
               </c:numCache>
             </c:numRef>
           </c:val>
+          <c:extLst>
+            <c:ext xmlns:c15="http://schemas.microsoft.com/office/drawing/2012/chart" uri="{02D57815-91ED-43cb-92C2-25804820EDAC}">
+              <c15:datalabelsRange>
+                <c15:f>Лист1!$V$2:$V$8</c15:f>
+                <c15:dlblRangeCache>
+                  <c:ptCount val="7"/>
+                  <c:pt idx="0">
+                    <c:v>| 3</c:v>
+                  </c:pt>
+                  <c:pt idx="1">
+                    <c:v>| 21</c:v>
+                  </c:pt>
+                  <c:pt idx="2">
+                    <c:v>| 31</c:v>
+                  </c:pt>
+                  <c:pt idx="3">
+                    <c:v>| 37</c:v>
+                  </c:pt>
+                  <c:pt idx="4">
+                    <c:v>| 8</c:v>
+                  </c:pt>
+                  <c:pt idx="5">
+                    <c:v>| 11</c:v>
+                  </c:pt>
+                  <c:pt idx="6">
+                    <c:v>| 20</c:v>
+                  </c:pt>
+                </c15:dlblRangeCache>
+              </c15:datalabelsRange>
+            </c:ext>
+          </c:extLst>
         </c:ser>
         <c:ser>
           <c:idx val="5"/>
@@ -1684,17 +1730,23 @@
           <c:dLbls>
             <c:dLbl>
               <c:idx val="0"/>
-              <c:layout/>
               <c:tx>
-                <c:strRef>
-                  <c:f>Лист1!$X$2</c:f>
-                  <c:strCache>
-                    <c:ptCount val="1"/>
-                    <c:pt idx="0">
-                      <c:v>| 100%</c:v>
-                    </c:pt>
-                  </c:strCache>
-                </c:strRef>
+                <c:rich>
+                  <a:bodyPr wrap="none" lIns="0" tIns="0" rIns="0" bIns="0" anchor="ctr"/>
+                  <a:lstStyle/>
+                  <a:p>
+                    <a:fld id="{407E76AF-CAB5-4083-BAE9-D02640933B3B}" type="CELLRANGE">
+                      <a:rPr lang="ru-RU" sz="1050" b="1">
+                        <a:solidFill>
+                          <a:schemeClr val="accent4"/>
+                        </a:solidFill>
+                      </a:rPr>
+                      <a:pPr/>
+                      <a:t>[CELLRANGE]</a:t>
+                    </a:fld>
+                    <a:endParaRPr lang="ru-RU"/>
+                  </a:p>
+                </c:rich>
               </c:tx>
               <c:spPr>
                 <a:noFill/>
@@ -1702,41 +1754,39 @@
                   <a:noFill/>
                 </a:ln>
               </c:spPr>
-              <c:txPr>
-                <a:bodyPr wrap="none" lIns="0" tIns="0" rIns="0" bIns="0" anchor="ctr"/>
-                <a:lstStyle/>
-                <a:p>
-                  <a:pPr>
-                    <a:defRPr sz="1050" b="1">
-                      <a:solidFill>
-                        <a:schemeClr val="accent4"/>
-                      </a:solidFill>
-                    </a:defRPr>
-                  </a:pPr>
-                  <a:endParaRPr lang="ru-RU"/>
-                </a:p>
-              </c:txPr>
               <c:dLblPos val="ctr"/>
               <c:showLegendKey val="0"/>
-              <c:showVal val="1"/>
+              <c:showVal val="0"/>
               <c:showCatName val="0"/>
               <c:showSerName val="0"/>
               <c:showPercent val="0"/>
               <c:showBubbleSize val="0"/>
+              <c:extLst>
+                <c:ext xmlns:c15="http://schemas.microsoft.com/office/drawing/2012/chart" uri="{CE6537A1-D6FC-4f65-9D91-7224C49458BB}">
+                  <c15:dlblFieldTable/>
+                  <c15:showDataLabelsRange val="1"/>
+                </c:ext>
+              </c:extLst>
             </c:dLbl>
             <c:dLbl>
               <c:idx val="1"/>
-              <c:layout/>
               <c:tx>
-                <c:strRef>
-                  <c:f>Лист1!$X$3</c:f>
-                  <c:strCache>
-                    <c:ptCount val="1"/>
-                    <c:pt idx="0">
-                      <c:v>| 95,2%</c:v>
-                    </c:pt>
-                  </c:strCache>
-                </c:strRef>
+                <c:rich>
+                  <a:bodyPr wrap="none" lIns="0" tIns="0" rIns="0" bIns="0" anchor="ctr"/>
+                  <a:lstStyle/>
+                  <a:p>
+                    <a:fld id="{F372DEAE-3162-4D89-8E0C-A1250E30B857}" type="CELLRANGE">
+                      <a:rPr lang="ru-RU" sz="1050" b="1">
+                        <a:solidFill>
+                          <a:schemeClr val="accent4"/>
+                        </a:solidFill>
+                      </a:rPr>
+                      <a:pPr/>
+                      <a:t>[CELLRANGE]</a:t>
+                    </a:fld>
+                    <a:endParaRPr lang="ru-RU"/>
+                  </a:p>
+                </c:rich>
               </c:tx>
               <c:spPr>
                 <a:noFill/>
@@ -1744,41 +1794,39 @@
                   <a:noFill/>
                 </a:ln>
               </c:spPr>
-              <c:txPr>
-                <a:bodyPr wrap="none" lIns="0" tIns="0" rIns="0" bIns="0" anchor="ctr"/>
-                <a:lstStyle/>
-                <a:p>
-                  <a:pPr>
-                    <a:defRPr sz="1050" b="1">
-                      <a:solidFill>
-                        <a:schemeClr val="accent4"/>
-                      </a:solidFill>
-                    </a:defRPr>
-                  </a:pPr>
-                  <a:endParaRPr lang="ru-RU"/>
-                </a:p>
-              </c:txPr>
               <c:dLblPos val="ctr"/>
               <c:showLegendKey val="0"/>
-              <c:showVal val="1"/>
+              <c:showVal val="0"/>
               <c:showCatName val="0"/>
               <c:showSerName val="0"/>
               <c:showPercent val="0"/>
               <c:showBubbleSize val="0"/>
+              <c:extLst>
+                <c:ext xmlns:c15="http://schemas.microsoft.com/office/drawing/2012/chart" uri="{CE6537A1-D6FC-4f65-9D91-7224C49458BB}">
+                  <c15:dlblFieldTable/>
+                  <c15:showDataLabelsRange val="1"/>
+                </c:ext>
+              </c:extLst>
             </c:dLbl>
             <c:dLbl>
               <c:idx val="2"/>
-              <c:layout/>
               <c:tx>
-                <c:strRef>
-                  <c:f>Лист1!$X$4</c:f>
-                  <c:strCache>
-                    <c:ptCount val="1"/>
-                    <c:pt idx="0">
-                      <c:v>| 93,5%</c:v>
-                    </c:pt>
-                  </c:strCache>
-                </c:strRef>
+                <c:rich>
+                  <a:bodyPr wrap="none" lIns="0" tIns="0" rIns="0" bIns="0" anchor="ctr"/>
+                  <a:lstStyle/>
+                  <a:p>
+                    <a:fld id="{D852E194-15B1-46CF-86DF-6AF5979CD8A7}" type="CELLRANGE">
+                      <a:rPr lang="ru-RU" sz="1050" b="1">
+                        <a:solidFill>
+                          <a:schemeClr val="accent4"/>
+                        </a:solidFill>
+                      </a:rPr>
+                      <a:pPr/>
+                      <a:t>[CELLRANGE]</a:t>
+                    </a:fld>
+                    <a:endParaRPr lang="ru-RU"/>
+                  </a:p>
+                </c:rich>
               </c:tx>
               <c:spPr>
                 <a:noFill/>
@@ -1786,41 +1834,39 @@
                   <a:noFill/>
                 </a:ln>
               </c:spPr>
-              <c:txPr>
-                <a:bodyPr wrap="none" lIns="0" tIns="0" rIns="0" bIns="0" anchor="ctr"/>
-                <a:lstStyle/>
-                <a:p>
-                  <a:pPr>
-                    <a:defRPr sz="1050" b="1">
-                      <a:solidFill>
-                        <a:schemeClr val="accent4"/>
-                      </a:solidFill>
-                    </a:defRPr>
-                  </a:pPr>
-                  <a:endParaRPr lang="ru-RU"/>
-                </a:p>
-              </c:txPr>
               <c:dLblPos val="ctr"/>
               <c:showLegendKey val="0"/>
-              <c:showVal val="1"/>
+              <c:showVal val="0"/>
               <c:showCatName val="0"/>
               <c:showSerName val="0"/>
               <c:showPercent val="0"/>
               <c:showBubbleSize val="0"/>
+              <c:extLst>
+                <c:ext xmlns:c15="http://schemas.microsoft.com/office/drawing/2012/chart" uri="{CE6537A1-D6FC-4f65-9D91-7224C49458BB}">
+                  <c15:dlblFieldTable/>
+                  <c15:showDataLabelsRange val="1"/>
+                </c:ext>
+              </c:extLst>
             </c:dLbl>
             <c:dLbl>
               <c:idx val="3"/>
-              <c:layout/>
               <c:tx>
-                <c:strRef>
-                  <c:f>Лист1!$X$5</c:f>
-                  <c:strCache>
-                    <c:ptCount val="1"/>
-                    <c:pt idx="0">
-                      <c:v>| 91,9%</c:v>
-                    </c:pt>
-                  </c:strCache>
-                </c:strRef>
+                <c:rich>
+                  <a:bodyPr wrap="none" lIns="0" tIns="0" rIns="0" bIns="0" anchor="ctr"/>
+                  <a:lstStyle/>
+                  <a:p>
+                    <a:fld id="{22D8DD44-C7F4-4586-8850-010F33E90C0C}" type="CELLRANGE">
+                      <a:rPr lang="ru-RU" sz="1050" b="1">
+                        <a:solidFill>
+                          <a:schemeClr val="accent4"/>
+                        </a:solidFill>
+                      </a:rPr>
+                      <a:pPr/>
+                      <a:t>[CELLRANGE]</a:t>
+                    </a:fld>
+                    <a:endParaRPr lang="ru-RU"/>
+                  </a:p>
+                </c:rich>
               </c:tx>
               <c:spPr>
                 <a:noFill/>
@@ -1828,41 +1874,39 @@
                   <a:noFill/>
                 </a:ln>
               </c:spPr>
-              <c:txPr>
-                <a:bodyPr wrap="none" lIns="0" tIns="0" rIns="0" bIns="0" anchor="ctr"/>
-                <a:lstStyle/>
-                <a:p>
-                  <a:pPr>
-                    <a:defRPr sz="1050" b="1">
-                      <a:solidFill>
-                        <a:schemeClr val="accent4"/>
-                      </a:solidFill>
-                    </a:defRPr>
-                  </a:pPr>
-                  <a:endParaRPr lang="ru-RU"/>
-                </a:p>
-              </c:txPr>
               <c:dLblPos val="ctr"/>
               <c:showLegendKey val="0"/>
-              <c:showVal val="1"/>
+              <c:showVal val="0"/>
               <c:showCatName val="0"/>
               <c:showSerName val="0"/>
               <c:showPercent val="0"/>
               <c:showBubbleSize val="0"/>
+              <c:extLst>
+                <c:ext xmlns:c15="http://schemas.microsoft.com/office/drawing/2012/chart" uri="{CE6537A1-D6FC-4f65-9D91-7224C49458BB}">
+                  <c15:dlblFieldTable/>
+                  <c15:showDataLabelsRange val="1"/>
+                </c:ext>
+              </c:extLst>
             </c:dLbl>
             <c:dLbl>
               <c:idx val="4"/>
-              <c:layout/>
               <c:tx>
-                <c:strRef>
-                  <c:f>Лист1!$X$6</c:f>
-                  <c:strCache>
-                    <c:ptCount val="1"/>
-                    <c:pt idx="0">
-                      <c:v> </c:v>
-                    </c:pt>
-                  </c:strCache>
-                </c:strRef>
+                <c:rich>
+                  <a:bodyPr wrap="none" lIns="0" tIns="0" rIns="0" bIns="0" anchor="ctr"/>
+                  <a:lstStyle/>
+                  <a:p>
+                    <a:fld id="{76965044-FA10-4F12-A09C-8086BF97FFCC}" type="CELLRANGE">
+                      <a:rPr lang="ru-RU" sz="1050" b="1">
+                        <a:solidFill>
+                          <a:schemeClr val="accent4"/>
+                        </a:solidFill>
+                      </a:rPr>
+                      <a:pPr/>
+                      <a:t>[CELLRANGE]</a:t>
+                    </a:fld>
+                    <a:endParaRPr lang="ru-RU"/>
+                  </a:p>
+                </c:rich>
               </c:tx>
               <c:spPr>
                 <a:noFill/>
@@ -1870,41 +1914,39 @@
                   <a:noFill/>
                 </a:ln>
               </c:spPr>
-              <c:txPr>
-                <a:bodyPr wrap="none" lIns="0" tIns="0" rIns="0" bIns="0" anchor="ctr"/>
-                <a:lstStyle/>
-                <a:p>
-                  <a:pPr>
-                    <a:defRPr sz="1050" b="1">
-                      <a:solidFill>
-                        <a:schemeClr val="accent4"/>
-                      </a:solidFill>
-                    </a:defRPr>
-                  </a:pPr>
-                  <a:endParaRPr lang="ru-RU"/>
-                </a:p>
-              </c:txPr>
               <c:dLblPos val="ctr"/>
               <c:showLegendKey val="0"/>
-              <c:showVal val="1"/>
+              <c:showVal val="0"/>
               <c:showCatName val="0"/>
               <c:showSerName val="0"/>
               <c:showPercent val="0"/>
               <c:showBubbleSize val="0"/>
+              <c:extLst>
+                <c:ext xmlns:c15="http://schemas.microsoft.com/office/drawing/2012/chart" uri="{CE6537A1-D6FC-4f65-9D91-7224C49458BB}">
+                  <c15:dlblFieldTable/>
+                  <c15:showDataLabelsRange val="1"/>
+                </c:ext>
+              </c:extLst>
             </c:dLbl>
             <c:dLbl>
               <c:idx val="5"/>
-              <c:layout/>
               <c:tx>
-                <c:strRef>
-                  <c:f>Лист1!$X$7</c:f>
-                  <c:strCache>
-                    <c:ptCount val="1"/>
-                    <c:pt idx="0">
-                      <c:v> </c:v>
-                    </c:pt>
-                  </c:strCache>
-                </c:strRef>
+                <c:rich>
+                  <a:bodyPr wrap="none" lIns="0" tIns="0" rIns="0" bIns="0" anchor="ctr"/>
+                  <a:lstStyle/>
+                  <a:p>
+                    <a:fld id="{5DA6358C-3755-4049-AC73-8CC873A6544C}" type="CELLRANGE">
+                      <a:rPr lang="ru-RU" sz="1050" b="1">
+                        <a:solidFill>
+                          <a:schemeClr val="accent4"/>
+                        </a:solidFill>
+                      </a:rPr>
+                      <a:pPr/>
+                      <a:t>[CELLRANGE]</a:t>
+                    </a:fld>
+                    <a:endParaRPr lang="ru-RU"/>
+                  </a:p>
+                </c:rich>
               </c:tx>
               <c:spPr>
                 <a:noFill/>
@@ -1912,41 +1954,39 @@
                   <a:noFill/>
                 </a:ln>
               </c:spPr>
-              <c:txPr>
-                <a:bodyPr wrap="none" lIns="0" tIns="0" rIns="0" bIns="0" anchor="ctr"/>
-                <a:lstStyle/>
-                <a:p>
-                  <a:pPr>
-                    <a:defRPr sz="1050" b="1">
-                      <a:solidFill>
-                        <a:schemeClr val="accent4"/>
-                      </a:solidFill>
-                    </a:defRPr>
-                  </a:pPr>
-                  <a:endParaRPr lang="ru-RU"/>
-                </a:p>
-              </c:txPr>
               <c:dLblPos val="ctr"/>
               <c:showLegendKey val="0"/>
-              <c:showVal val="1"/>
+              <c:showVal val="0"/>
               <c:showCatName val="0"/>
               <c:showSerName val="0"/>
               <c:showPercent val="0"/>
               <c:showBubbleSize val="0"/>
+              <c:extLst>
+                <c:ext xmlns:c15="http://schemas.microsoft.com/office/drawing/2012/chart" uri="{CE6537A1-D6FC-4f65-9D91-7224C49458BB}">
+                  <c15:dlblFieldTable/>
+                  <c15:showDataLabelsRange val="1"/>
+                </c:ext>
+              </c:extLst>
             </c:dLbl>
             <c:dLbl>
               <c:idx val="6"/>
-              <c:layout/>
               <c:tx>
-                <c:strRef>
-                  <c:f>Лист1!$X$8</c:f>
-                  <c:strCache>
-                    <c:ptCount val="1"/>
-                    <c:pt idx="0">
-                      <c:v> </c:v>
-                    </c:pt>
-                  </c:strCache>
-                </c:strRef>
+                <c:rich>
+                  <a:bodyPr wrap="none" lIns="0" tIns="0" rIns="0" bIns="0" anchor="ctr"/>
+                  <a:lstStyle/>
+                  <a:p>
+                    <a:fld id="{9AB295A8-95A2-4A08-8E27-FCDFE3073A53}" type="CELLRANGE">
+                      <a:rPr lang="ru-RU" sz="1050" b="1">
+                        <a:solidFill>
+                          <a:schemeClr val="accent4"/>
+                        </a:solidFill>
+                      </a:rPr>
+                      <a:pPr/>
+                      <a:t>[CELLRANGE]</a:t>
+                    </a:fld>
+                    <a:endParaRPr lang="ru-RU"/>
+                  </a:p>
+                </c:rich>
               </c:tx>
               <c:spPr>
                 <a:noFill/>
@@ -1954,27 +1994,19 @@
                   <a:noFill/>
                 </a:ln>
               </c:spPr>
-              <c:txPr>
-                <a:bodyPr wrap="none" lIns="0" tIns="0" rIns="0" bIns="0" anchor="ctr"/>
-                <a:lstStyle/>
-                <a:p>
-                  <a:pPr>
-                    <a:defRPr sz="1050" b="1">
-                      <a:solidFill>
-                        <a:schemeClr val="accent4"/>
-                      </a:solidFill>
-                    </a:defRPr>
-                  </a:pPr>
-                  <a:endParaRPr lang="ru-RU"/>
-                </a:p>
-              </c:txPr>
               <c:dLblPos val="ctr"/>
               <c:showLegendKey val="0"/>
-              <c:showVal val="1"/>
+              <c:showVal val="0"/>
               <c:showCatName val="0"/>
               <c:showSerName val="0"/>
               <c:showPercent val="0"/>
               <c:showBubbleSize val="0"/>
+              <c:extLst>
+                <c:ext xmlns:c15="http://schemas.microsoft.com/office/drawing/2012/chart" uri="{CE6537A1-D6FC-4f65-9D91-7224C49458BB}">
+                  <c15:dlblFieldTable/>
+                  <c15:showDataLabelsRange val="1"/>
+                </c:ext>
+              </c:extLst>
             </c:dLbl>
             <c:spPr>
               <a:noFill/>
@@ -1998,11 +2030,17 @@
             </c:txPr>
             <c:dLblPos val="ctr"/>
             <c:showLegendKey val="0"/>
-            <c:showVal val="1"/>
+            <c:showVal val="0"/>
             <c:showCatName val="0"/>
             <c:showSerName val="0"/>
             <c:showPercent val="0"/>
             <c:showBubbleSize val="0"/>
+            <c:extLst>
+              <c:ext xmlns:c15="http://schemas.microsoft.com/office/drawing/2012/chart" uri="{CE6537A1-D6FC-4f65-9D91-7224C49458BB}">
+                <c15:showDataLabelsRange val="1"/>
+                <c15:showLeaderLines val="0"/>
+              </c:ext>
+            </c:extLst>
           </c:dLbls>
           <c:cat>
             <c:strRef>
@@ -2063,6 +2101,37 @@
               </c:numCache>
             </c:numRef>
           </c:val>
+          <c:extLst>
+            <c:ext xmlns:c15="http://schemas.microsoft.com/office/drawing/2012/chart" uri="{02D57815-91ED-43cb-92C2-25804820EDAC}">
+              <c15:datalabelsRange>
+                <c15:f>Лист1!$X$2:$X$8</c15:f>
+                <c15:dlblRangeCache>
+                  <c:ptCount val="7"/>
+                  <c:pt idx="0">
+                    <c:v>| 100%</c:v>
+                  </c:pt>
+                  <c:pt idx="1">
+                    <c:v>| 95,2%</c:v>
+                  </c:pt>
+                  <c:pt idx="2">
+                    <c:v>| 93,5%</c:v>
+                  </c:pt>
+                  <c:pt idx="3">
+                    <c:v>| 91,9%</c:v>
+                  </c:pt>
+                  <c:pt idx="4">
+                    <c:v> </c:v>
+                  </c:pt>
+                  <c:pt idx="5">
+                    <c:v> </c:v>
+                  </c:pt>
+                  <c:pt idx="6">
+                    <c:v> </c:v>
+                  </c:pt>
+                </c15:dlblRangeCache>
+              </c15:datalabelsRange>
+            </c:ext>
+          </c:extLst>
         </c:ser>
         <c:ser>
           <c:idx val="6"/>
@@ -2088,17 +2157,23 @@
           <c:dLbls>
             <c:dLbl>
               <c:idx val="0"/>
-              <c:layout/>
               <c:tx>
-                <c:strRef>
-                  <c:f>Лист1!$Z$2</c:f>
-                  <c:strCache>
-                    <c:ptCount val="1"/>
-                    <c:pt idx="0">
-                      <c:v> </c:v>
-                    </c:pt>
-                  </c:strCache>
-                </c:strRef>
+                <c:rich>
+                  <a:bodyPr wrap="none" lIns="0" tIns="0" rIns="0" bIns="0" anchor="ctr"/>
+                  <a:lstStyle/>
+                  <a:p>
+                    <a:fld id="{69FB8892-93AA-4217-A96E-338D4C9BE708}" type="CELLRANGE">
+                      <a:rPr lang="ru-RU" sz="1050" b="1">
+                        <a:solidFill>
+                          <a:srgbClr val="B76E00"/>
+                        </a:solidFill>
+                      </a:rPr>
+                      <a:pPr/>
+                      <a:t>[CELLRANGE]</a:t>
+                    </a:fld>
+                    <a:endParaRPr lang="ru-RU"/>
+                  </a:p>
+                </c:rich>
               </c:tx>
               <c:spPr>
                 <a:noFill/>
@@ -2106,41 +2181,39 @@
                   <a:noFill/>
                 </a:ln>
               </c:spPr>
-              <c:txPr>
-                <a:bodyPr wrap="none" lIns="0" tIns="0" rIns="0" bIns="0" anchor="ctr"/>
-                <a:lstStyle/>
-                <a:p>
-                  <a:pPr>
-                    <a:defRPr sz="1050" b="1">
-                      <a:solidFill>
-                        <a:srgbClr val="B76E00"/>
-                      </a:solidFill>
-                    </a:defRPr>
-                  </a:pPr>
-                  <a:endParaRPr lang="ru-RU"/>
-                </a:p>
-              </c:txPr>
               <c:dLblPos val="ctr"/>
               <c:showLegendKey val="0"/>
-              <c:showVal val="1"/>
+              <c:showVal val="0"/>
               <c:showCatName val="0"/>
               <c:showSerName val="0"/>
               <c:showPercent val="0"/>
               <c:showBubbleSize val="0"/>
+              <c:extLst>
+                <c:ext xmlns:c15="http://schemas.microsoft.com/office/drawing/2012/chart" uri="{CE6537A1-D6FC-4f65-9D91-7224C49458BB}">
+                  <c15:dlblFieldTable/>
+                  <c15:showDataLabelsRange val="1"/>
+                </c:ext>
+              </c:extLst>
             </c:dLbl>
             <c:dLbl>
               <c:idx val="1"/>
-              <c:layout/>
               <c:tx>
-                <c:strRef>
-                  <c:f>Лист1!$Z$3</c:f>
-                  <c:strCache>
-                    <c:ptCount val="1"/>
-                    <c:pt idx="0">
-                      <c:v> </c:v>
-                    </c:pt>
-                  </c:strCache>
-                </c:strRef>
+                <c:rich>
+                  <a:bodyPr wrap="none" lIns="0" tIns="0" rIns="0" bIns="0" anchor="ctr"/>
+                  <a:lstStyle/>
+                  <a:p>
+                    <a:fld id="{A99902E4-7422-4654-A2D5-E0754C2B6560}" type="CELLRANGE">
+                      <a:rPr lang="ru-RU" sz="1050" b="1">
+                        <a:solidFill>
+                          <a:srgbClr val="B76E00"/>
+                        </a:solidFill>
+                      </a:rPr>
+                      <a:pPr/>
+                      <a:t>[CELLRANGE]</a:t>
+                    </a:fld>
+                    <a:endParaRPr lang="ru-RU"/>
+                  </a:p>
+                </c:rich>
               </c:tx>
               <c:spPr>
                 <a:noFill/>
@@ -2148,41 +2221,39 @@
                   <a:noFill/>
                 </a:ln>
               </c:spPr>
-              <c:txPr>
-                <a:bodyPr wrap="none" lIns="0" tIns="0" rIns="0" bIns="0" anchor="ctr"/>
-                <a:lstStyle/>
-                <a:p>
-                  <a:pPr>
-                    <a:defRPr sz="1050" b="1">
-                      <a:solidFill>
-                        <a:srgbClr val="B76E00"/>
-                      </a:solidFill>
-                    </a:defRPr>
-                  </a:pPr>
-                  <a:endParaRPr lang="ru-RU"/>
-                </a:p>
-              </c:txPr>
               <c:dLblPos val="ctr"/>
               <c:showLegendKey val="0"/>
-              <c:showVal val="1"/>
+              <c:showVal val="0"/>
               <c:showCatName val="0"/>
               <c:showSerName val="0"/>
               <c:showPercent val="0"/>
               <c:showBubbleSize val="0"/>
+              <c:extLst>
+                <c:ext xmlns:c15="http://schemas.microsoft.com/office/drawing/2012/chart" uri="{CE6537A1-D6FC-4f65-9D91-7224C49458BB}">
+                  <c15:dlblFieldTable/>
+                  <c15:showDataLabelsRange val="1"/>
+                </c:ext>
+              </c:extLst>
             </c:dLbl>
             <c:dLbl>
               <c:idx val="2"/>
-              <c:layout/>
               <c:tx>
-                <c:strRef>
-                  <c:f>Лист1!$Z$4</c:f>
-                  <c:strCache>
-                    <c:ptCount val="1"/>
-                    <c:pt idx="0">
-                      <c:v> </c:v>
-                    </c:pt>
-                  </c:strCache>
-                </c:strRef>
+                <c:rich>
+                  <a:bodyPr wrap="none" lIns="0" tIns="0" rIns="0" bIns="0" anchor="ctr"/>
+                  <a:lstStyle/>
+                  <a:p>
+                    <a:fld id="{06986935-3243-469D-9413-CBF413DE6A89}" type="CELLRANGE">
+                      <a:rPr lang="ru-RU" sz="1050" b="1">
+                        <a:solidFill>
+                          <a:srgbClr val="B76E00"/>
+                        </a:solidFill>
+                      </a:rPr>
+                      <a:pPr/>
+                      <a:t>[CELLRANGE]</a:t>
+                    </a:fld>
+                    <a:endParaRPr lang="ru-RU"/>
+                  </a:p>
+                </c:rich>
               </c:tx>
               <c:spPr>
                 <a:noFill/>
@@ -2190,41 +2261,39 @@
                   <a:noFill/>
                 </a:ln>
               </c:spPr>
-              <c:txPr>
-                <a:bodyPr wrap="none" lIns="0" tIns="0" rIns="0" bIns="0" anchor="ctr"/>
-                <a:lstStyle/>
-                <a:p>
-                  <a:pPr>
-                    <a:defRPr sz="1050" b="1">
-                      <a:solidFill>
-                        <a:srgbClr val="B76E00"/>
-                      </a:solidFill>
-                    </a:defRPr>
-                  </a:pPr>
-                  <a:endParaRPr lang="ru-RU"/>
-                </a:p>
-              </c:txPr>
               <c:dLblPos val="ctr"/>
               <c:showLegendKey val="0"/>
-              <c:showVal val="1"/>
+              <c:showVal val="0"/>
               <c:showCatName val="0"/>
               <c:showSerName val="0"/>
               <c:showPercent val="0"/>
               <c:showBubbleSize val="0"/>
+              <c:extLst>
+                <c:ext xmlns:c15="http://schemas.microsoft.com/office/drawing/2012/chart" uri="{CE6537A1-D6FC-4f65-9D91-7224C49458BB}">
+                  <c15:dlblFieldTable/>
+                  <c15:showDataLabelsRange val="1"/>
+                </c:ext>
+              </c:extLst>
             </c:dLbl>
             <c:dLbl>
               <c:idx val="3"/>
-              <c:layout/>
               <c:tx>
-                <c:strRef>
-                  <c:f>Лист1!$Z$5</c:f>
-                  <c:strCache>
-                    <c:ptCount val="1"/>
-                    <c:pt idx="0">
-                      <c:v> </c:v>
-                    </c:pt>
-                  </c:strCache>
-                </c:strRef>
+                <c:rich>
+                  <a:bodyPr wrap="none" lIns="0" tIns="0" rIns="0" bIns="0" anchor="ctr"/>
+                  <a:lstStyle/>
+                  <a:p>
+                    <a:fld id="{D1CDB90E-D7BD-48B8-9FB6-42D235BBCD41}" type="CELLRANGE">
+                      <a:rPr lang="ru-RU" sz="1050" b="1">
+                        <a:solidFill>
+                          <a:srgbClr val="B76E00"/>
+                        </a:solidFill>
+                      </a:rPr>
+                      <a:pPr/>
+                      <a:t>[CELLRANGE]</a:t>
+                    </a:fld>
+                    <a:endParaRPr lang="ru-RU"/>
+                  </a:p>
+                </c:rich>
               </c:tx>
               <c:spPr>
                 <a:noFill/>
@@ -2232,41 +2301,39 @@
                   <a:noFill/>
                 </a:ln>
               </c:spPr>
-              <c:txPr>
-                <a:bodyPr wrap="none" lIns="0" tIns="0" rIns="0" bIns="0" anchor="ctr"/>
-                <a:lstStyle/>
-                <a:p>
-                  <a:pPr>
-                    <a:defRPr sz="1050" b="1">
-                      <a:solidFill>
-                        <a:srgbClr val="B76E00"/>
-                      </a:solidFill>
-                    </a:defRPr>
-                  </a:pPr>
-                  <a:endParaRPr lang="ru-RU"/>
-                </a:p>
-              </c:txPr>
               <c:dLblPos val="ctr"/>
               <c:showLegendKey val="0"/>
-              <c:showVal val="1"/>
+              <c:showVal val="0"/>
               <c:showCatName val="0"/>
               <c:showSerName val="0"/>
               <c:showPercent val="0"/>
               <c:showBubbleSize val="0"/>
+              <c:extLst>
+                <c:ext xmlns:c15="http://schemas.microsoft.com/office/drawing/2012/chart" uri="{CE6537A1-D6FC-4f65-9D91-7224C49458BB}">
+                  <c15:dlblFieldTable/>
+                  <c15:showDataLabelsRange val="1"/>
+                </c:ext>
+              </c:extLst>
             </c:dLbl>
             <c:dLbl>
               <c:idx val="4"/>
-              <c:layout/>
               <c:tx>
-                <c:strRef>
-                  <c:f>Лист1!$Z$6</c:f>
-                  <c:strCache>
-                    <c:ptCount val="1"/>
-                    <c:pt idx="0">
-                      <c:v>| 87,5%</c:v>
-                    </c:pt>
-                  </c:strCache>
-                </c:strRef>
+                <c:rich>
+                  <a:bodyPr wrap="none" lIns="0" tIns="0" rIns="0" bIns="0" anchor="ctr"/>
+                  <a:lstStyle/>
+                  <a:p>
+                    <a:fld id="{217AB7B1-521B-4C60-AE8E-983B6B9D7832}" type="CELLRANGE">
+                      <a:rPr lang="ru-RU" sz="1050" b="1">
+                        <a:solidFill>
+                          <a:srgbClr val="B76E00"/>
+                        </a:solidFill>
+                      </a:rPr>
+                      <a:pPr/>
+                      <a:t>[CELLRANGE]</a:t>
+                    </a:fld>
+                    <a:endParaRPr lang="ru-RU"/>
+                  </a:p>
+                </c:rich>
               </c:tx>
               <c:spPr>
                 <a:noFill/>
@@ -2274,41 +2341,39 @@
                   <a:noFill/>
                 </a:ln>
               </c:spPr>
-              <c:txPr>
-                <a:bodyPr wrap="none" lIns="0" tIns="0" rIns="0" bIns="0" anchor="ctr"/>
-                <a:lstStyle/>
-                <a:p>
-                  <a:pPr>
-                    <a:defRPr sz="1050" b="1">
-                      <a:solidFill>
-                        <a:srgbClr val="B76E00"/>
-                      </a:solidFill>
-                    </a:defRPr>
-                  </a:pPr>
-                  <a:endParaRPr lang="ru-RU"/>
-                </a:p>
-              </c:txPr>
               <c:dLblPos val="ctr"/>
               <c:showLegendKey val="0"/>
-              <c:showVal val="1"/>
+              <c:showVal val="0"/>
               <c:showCatName val="0"/>
               <c:showSerName val="0"/>
               <c:showPercent val="0"/>
               <c:showBubbleSize val="0"/>
+              <c:extLst>
+                <c:ext xmlns:c15="http://schemas.microsoft.com/office/drawing/2012/chart" uri="{CE6537A1-D6FC-4f65-9D91-7224C49458BB}">
+                  <c15:dlblFieldTable/>
+                  <c15:showDataLabelsRange val="1"/>
+                </c:ext>
+              </c:extLst>
             </c:dLbl>
             <c:dLbl>
               <c:idx val="5"/>
-              <c:layout/>
               <c:tx>
-                <c:strRef>
-                  <c:f>Лист1!$Z$7</c:f>
-                  <c:strCache>
-                    <c:ptCount val="1"/>
-                    <c:pt idx="0">
-                      <c:v>| 81,8%</c:v>
-                    </c:pt>
-                  </c:strCache>
-                </c:strRef>
+                <c:rich>
+                  <a:bodyPr wrap="none" lIns="0" tIns="0" rIns="0" bIns="0" anchor="ctr"/>
+                  <a:lstStyle/>
+                  <a:p>
+                    <a:fld id="{E5C4A89B-962E-44A1-BA73-05D37DB6898D}" type="CELLRANGE">
+                      <a:rPr lang="ru-RU" sz="1050" b="1">
+                        <a:solidFill>
+                          <a:srgbClr val="B76E00"/>
+                        </a:solidFill>
+                      </a:rPr>
+                      <a:pPr/>
+                      <a:t>[CELLRANGE]</a:t>
+                    </a:fld>
+                    <a:endParaRPr lang="ru-RU"/>
+                  </a:p>
+                </c:rich>
               </c:tx>
               <c:spPr>
                 <a:noFill/>
@@ -2316,41 +2381,39 @@
                   <a:noFill/>
                 </a:ln>
               </c:spPr>
-              <c:txPr>
-                <a:bodyPr wrap="none" lIns="0" tIns="0" rIns="0" bIns="0" anchor="ctr"/>
-                <a:lstStyle/>
-                <a:p>
-                  <a:pPr>
-                    <a:defRPr sz="1050" b="1">
-                      <a:solidFill>
-                        <a:srgbClr val="B76E00"/>
-                      </a:solidFill>
-                    </a:defRPr>
-                  </a:pPr>
-                  <a:endParaRPr lang="ru-RU"/>
-                </a:p>
-              </c:txPr>
               <c:dLblPos val="ctr"/>
               <c:showLegendKey val="0"/>
-              <c:showVal val="1"/>
+              <c:showVal val="0"/>
               <c:showCatName val="0"/>
               <c:showSerName val="0"/>
               <c:showPercent val="0"/>
               <c:showBubbleSize val="0"/>
+              <c:extLst>
+                <c:ext xmlns:c15="http://schemas.microsoft.com/office/drawing/2012/chart" uri="{CE6537A1-D6FC-4f65-9D91-7224C49458BB}">
+                  <c15:dlblFieldTable/>
+                  <c15:showDataLabelsRange val="1"/>
+                </c:ext>
+              </c:extLst>
             </c:dLbl>
             <c:dLbl>
               <c:idx val="6"/>
-              <c:layout/>
               <c:tx>
-                <c:strRef>
-                  <c:f>Лист1!$Z$8</c:f>
-                  <c:strCache>
-                    <c:ptCount val="1"/>
-                    <c:pt idx="0">
-                      <c:v>| 80%</c:v>
-                    </c:pt>
-                  </c:strCache>
-                </c:strRef>
+                <c:rich>
+                  <a:bodyPr wrap="none" lIns="0" tIns="0" rIns="0" bIns="0" anchor="ctr"/>
+                  <a:lstStyle/>
+                  <a:p>
+                    <a:fld id="{5363328D-A78F-4709-8A20-4B9E8FA382DB}" type="CELLRANGE">
+                      <a:rPr lang="ru-RU" sz="1050" b="1">
+                        <a:solidFill>
+                          <a:srgbClr val="B76E00"/>
+                        </a:solidFill>
+                      </a:rPr>
+                      <a:pPr/>
+                      <a:t>[CELLRANGE]</a:t>
+                    </a:fld>
+                    <a:endParaRPr lang="ru-RU"/>
+                  </a:p>
+                </c:rich>
               </c:tx>
               <c:spPr>
                 <a:noFill/>
@@ -2358,27 +2421,19 @@
                   <a:noFill/>
                 </a:ln>
               </c:spPr>
-              <c:txPr>
-                <a:bodyPr wrap="none" lIns="0" tIns="0" rIns="0" bIns="0" anchor="ctr"/>
-                <a:lstStyle/>
-                <a:p>
-                  <a:pPr>
-                    <a:defRPr sz="1050" b="1">
-                      <a:solidFill>
-                        <a:srgbClr val="B76E00"/>
-                      </a:solidFill>
-                    </a:defRPr>
-                  </a:pPr>
-                  <a:endParaRPr lang="ru-RU"/>
-                </a:p>
-              </c:txPr>
               <c:dLblPos val="ctr"/>
               <c:showLegendKey val="0"/>
-              <c:showVal val="1"/>
+              <c:showVal val="0"/>
               <c:showCatName val="0"/>
               <c:showSerName val="0"/>
               <c:showPercent val="0"/>
               <c:showBubbleSize val="0"/>
+              <c:extLst>
+                <c:ext xmlns:c15="http://schemas.microsoft.com/office/drawing/2012/chart" uri="{CE6537A1-D6FC-4f65-9D91-7224C49458BB}">
+                  <c15:dlblFieldTable/>
+                  <c15:showDataLabelsRange val="1"/>
+                </c:ext>
+              </c:extLst>
             </c:dLbl>
             <c:spPr>
               <a:noFill/>
@@ -2402,11 +2457,17 @@
             </c:txPr>
             <c:dLblPos val="ctr"/>
             <c:showLegendKey val="0"/>
-            <c:showVal val="1"/>
+            <c:showVal val="0"/>
             <c:showCatName val="0"/>
             <c:showSerName val="0"/>
             <c:showPercent val="0"/>
             <c:showBubbleSize val="0"/>
+            <c:extLst>
+              <c:ext xmlns:c15="http://schemas.microsoft.com/office/drawing/2012/chart" uri="{CE6537A1-D6FC-4f65-9D91-7224C49458BB}">
+                <c15:showDataLabelsRange val="1"/>
+                <c15:showLeaderLines val="0"/>
+              </c:ext>
+            </c:extLst>
           </c:dLbls>
           <c:cat>
             <c:strRef>
@@ -2467,6 +2528,37 @@
               </c:numCache>
             </c:numRef>
           </c:val>
+          <c:extLst>
+            <c:ext xmlns:c15="http://schemas.microsoft.com/office/drawing/2012/chart" uri="{02D57815-91ED-43cb-92C2-25804820EDAC}">
+              <c15:datalabelsRange>
+                <c15:f>Лист1!$Z$2:$Z$8</c15:f>
+                <c15:dlblRangeCache>
+                  <c:ptCount val="7"/>
+                  <c:pt idx="0">
+                    <c:v> </c:v>
+                  </c:pt>
+                  <c:pt idx="1">
+                    <c:v> </c:v>
+                  </c:pt>
+                  <c:pt idx="2">
+                    <c:v> </c:v>
+                  </c:pt>
+                  <c:pt idx="3">
+                    <c:v> </c:v>
+                  </c:pt>
+                  <c:pt idx="4">
+                    <c:v>| 87,5%</c:v>
+                  </c:pt>
+                  <c:pt idx="5">
+                    <c:v>| 81,8%</c:v>
+                  </c:pt>
+                  <c:pt idx="6">
+                    <c:v>| 80%</c:v>
+                  </c:pt>
+                </c15:dlblRangeCache>
+              </c15:datalabelsRange>
+            </c:ext>
+          </c:extLst>
         </c:ser>
         <c:dLbls>
           <c:showLegendKey val="0"/>

</xml_diff>

<commit_message>
Drive donut chart legends and centre text from the chart data sheets
- legend text is built by formulas in the data sheet (native chart legend)
- centre numbers come from cells via Value From Cells
- structure chart data aligned with the printed numbers (27 and 6)

Co-Authored-By: Claude Sonnet 5.5 <noreply@anthropic.com>
Claude-Session: https://claude.ai/code/session_01NEsYnofsV4CojKrpDNMyGk
</commit_message>
<xml_diff>
--- a/digital_twin_resources.pptx
+++ b/digital_twin_resources.pptx
@@ -133,10 +133,10 @@
           <c:layoutTarget val="inner"/>
           <c:xMode val="edge"/>
           <c:yMode val="edge"/>
-          <c:x val="0.02"/>
-          <c:y val="0.02"/>
-          <c:w val="0.96"/>
-          <c:h val="0.96"/>
+          <c:x val="0"/>
+          <c:y val="0"/>
+          <c:w val="0.3934"/>
+          <c:h val="1"/>
         </c:manualLayout>
       </c:layout>
       <c:doughnutChart>
@@ -155,19 +155,6 @@
               </c:strCache>
             </c:strRef>
           </c:tx>
-          <c:spPr>
-            <a:solidFill>
-              <a:schemeClr val="accent1"/>
-            </a:solidFill>
-            <a:ln w="9525" cap="flat">
-              <a:solidFill>
-                <a:srgbClr val="F9F9F9"/>
-              </a:solidFill>
-              <a:prstDash val="solid"/>
-              <a:round/>
-            </a:ln>
-            <a:effectLst/>
-          </c:spPr>
           <c:dPt>
             <c:idx val="0"/>
             <c:bubble3D val="0"/>
@@ -181,11 +168,6 @@
                 </a:solidFill>
               </a:ln>
             </c:spPr>
-            <c:extLst>
-              <c:ext xmlns:c16="http://schemas.microsoft.com/office/drawing/2014/chart" uri="{C3380CC4-5D6E-409C-BE32-E72D297353CC}">
-                <c16:uniqueId val="{00000001-621B-DA4B-96CE-FEEB0051CCBF}"/>
-              </c:ext>
-            </c:extLst>
           </c:dPt>
           <c:dPt>
             <c:idx val="1"/>
@@ -200,56 +182,140 @@
                 </a:solidFill>
               </a:ln>
             </c:spPr>
+          </c:dPt>
+          <c:dPt>
+            <c:idx val="2"/>
+            <c:bubble3D val="0"/>
+            <c:spPr>
+              <a:noFill/>
+              <a:ln>
+                <a:noFill/>
+              </a:ln>
+            </c:spPr>
+          </c:dPt>
+          <c:dLbls>
+            <c:dLbl>
+              <c:idx val="0"/>
+              <c:delete val="1"/>
+            </c:dLbl>
+            <c:dLbl>
+              <c:idx val="1"/>
+              <c:delete val="1"/>
+            </c:dLbl>
+            <c:dLbl>
+              <c:idx val="2"/>
+              <c:layout>
+                <c:manualLayout>
+                  <c:x val="0"/>
+                  <c:y val="0.4375"/>
+                </c:manualLayout>
+              </c:layout>
+              <c:tx>
+                <c:rich>
+                  <a:bodyPr wrap="none" lIns="0" tIns="0" rIns="0" bIns="0" anchor="ctr"/>
+                  <a:lstStyle/>
+                  <a:p>
+                    <a:fld id="{51BB1ED7-14B8-4BFC-9360-5D2268B37F48}" type="CELLRANGE">
+                      <a:rPr lang="ru-RU" sz="1200" b="1">
+                        <a:solidFill>
+                          <a:schemeClr val="accent4"/>
+                        </a:solidFill>
+                      </a:rPr>
+                      <a:pPr/>
+                      <a:t>[CELLRANGE]</a:t>
+                    </a:fld>
+                    <a:endParaRPr lang="ru-RU"/>
+                  </a:p>
+                </c:rich>
+              </c:tx>
+              <c:spPr>
+                <a:noFill/>
+                <a:ln>
+                  <a:noFill/>
+                </a:ln>
+              </c:spPr>
+              <c:showLegendKey val="0"/>
+              <c:showVal val="0"/>
+              <c:showCatName val="0"/>
+              <c:showSerName val="0"/>
+              <c:showPercent val="0"/>
+              <c:showBubbleSize val="0"/>
+              <c:extLst>
+                <c:ext xmlns:c15="http://schemas.microsoft.com/office/drawing/2012/chart" uri="{CE6537A1-D6FC-4f65-9D91-7224C49458BB}">
+                  <c15:dlblFieldTable/>
+                  <c15:showDataLabelsRange val="1"/>
+                </c:ext>
+              </c:extLst>
+            </c:dLbl>
+            <c:spPr>
+              <a:noFill/>
+              <a:ln>
+                <a:noFill/>
+              </a:ln>
+            </c:spPr>
+            <c:showLegendKey val="0"/>
+            <c:showVal val="0"/>
+            <c:showCatName val="0"/>
+            <c:showSerName val="0"/>
+            <c:showPercent val="0"/>
+            <c:showBubbleSize val="0"/>
+            <c:showLeaderLines val="0"/>
             <c:extLst>
-              <c:ext xmlns:c16="http://schemas.microsoft.com/office/drawing/2014/chart" uri="{C3380CC4-5D6E-409C-BE32-E72D297353CC}">
-                <c16:uniqueId val="{00000003-621B-DA4B-96CE-FEEB0051CCBF}"/>
+              <c:ext xmlns:c15="http://schemas.microsoft.com/office/drawing/2012/chart" uri="{CE6537A1-D6FC-4f65-9D91-7224C49458BB}">
+                <c15:showDataLabelsRange val="1"/>
+                <c15:showLeaderLines val="0"/>
               </c:ext>
             </c:extLst>
-          </c:dPt>
+          </c:dLbls>
           <c:cat>
             <c:strRef>
-              <c:f>Sheet1!$A$2:$A$3</c:f>
+              <c:f>Sheet1!$A$2:$A$4</c:f>
               <c:strCache>
-                <c:ptCount val="2"/>
+                <c:ptCount val="3"/>
                 <c:pt idx="0">
-                  <c:v>Занято</c:v>
+                  <c:v>117 ПШЕ занято</c:v>
                 </c:pt>
                 <c:pt idx="1">
-                  <c:v>Дефицит</c:v>
+                  <c:v>14 ПШЕ в подборе</c:v>
+                </c:pt>
+                <c:pt idx="2">
+                  <c:v>Служебная строка (подпись в центре)</c:v>
                 </c:pt>
               </c:strCache>
             </c:strRef>
           </c:cat>
           <c:val>
             <c:numRef>
-              <c:f>Sheet1!$B$2:$B$3</c:f>
+              <c:f>Sheet1!$B$2:$B$4</c:f>
               <c:numCache>
                 <c:formatCode>General</c:formatCode>
-                <c:ptCount val="2"/>
+                <c:ptCount val="3"/>
                 <c:pt idx="0">
                   <c:v>117</c:v>
                 </c:pt>
                 <c:pt idx="1">
                   <c:v>14</c:v>
+                </c:pt>
+                <c:pt idx="2">
+                  <c:v>0.00131</c:v>
                 </c:pt>
               </c:numCache>
             </c:numRef>
           </c:val>
           <c:extLst>
-            <c:ext xmlns:c16="http://schemas.microsoft.com/office/drawing/2014/chart" uri="{C3380CC4-5D6E-409C-BE32-E72D297353CC}">
-              <c16:uniqueId val="{00000004-621B-DA4B-96CE-FEEB0051CCBF}"/>
+            <c:ext xmlns:c15="http://schemas.microsoft.com/office/drawing/2012/chart" uri="{02D57815-91ED-43cb-92C2-25804820EDAC}">
+              <c15:datalabelsRange>
+                <c15:f>Sheet1!$C$2:$C$4</c15:f>
+                <c15:dlblRangeCache>
+                  <c:ptCount val="3"/>
+                  <c:pt idx="2">
+                    <c:v>89,3%</c:v>
+                  </c:pt>
+                </c15:dlblRangeCache>
+              </c15:datalabelsRange>
             </c:ext>
           </c:extLst>
         </c:ser>
-        <c:dLbls>
-          <c:showLegendKey val="0"/>
-          <c:showVal val="0"/>
-          <c:showCatName val="0"/>
-          <c:showSerName val="0"/>
-          <c:showPercent val="0"/>
-          <c:showBubbleSize val="0"/>
-          <c:showLeaderLines val="0"/>
-        </c:dLbls>
         <c:firstSliceAng val="0"/>
         <c:holeSize val="75"/>
       </c:doughnutChart>
@@ -261,6 +327,44 @@
         <a:effectLst/>
       </c:spPr>
     </c:plotArea>
+    <c:legend>
+      <c:legendPos val="r"/>
+      <c:legendEntry>
+        <c:idx val="2"/>
+        <c:delete val="1"/>
+      </c:legendEntry>
+      <c:layout>
+        <c:manualLayout>
+          <c:xMode val="edge"/>
+          <c:yMode val="edge"/>
+          <c:x val="0.4590"/>
+          <c:y val="0.300"/>
+          <c:w val="0.5310"/>
+          <c:h val="0.400"/>
+        </c:manualLayout>
+      </c:layout>
+      <c:overlay val="0"/>
+      <c:spPr>
+        <a:noFill/>
+        <a:ln>
+          <a:noFill/>
+        </a:ln>
+      </c:spPr>
+      <c:txPr>
+        <a:bodyPr/>
+        <a:lstStyle/>
+        <a:p>
+          <a:pPr>
+            <a:defRPr sz="1000" b="0">
+              <a:solidFill>
+                <a:schemeClr val="tx1"/>
+              </a:solidFill>
+            </a:defRPr>
+          </a:pPr>
+          <a:endParaRPr lang="ru-RU"/>
+        </a:p>
+      </c:txPr>
+    </c:legend>
     <c:plotVisOnly val="1"/>
     <c:dispBlanksAs val="span"/>
     <c:showDLblsOverMax val="1"/>
@@ -299,10 +403,10 @@
           <c:layoutTarget val="inner"/>
           <c:xMode val="edge"/>
           <c:yMode val="edge"/>
-          <c:x val="0.02"/>
-          <c:y val="0.02"/>
-          <c:w val="0.96"/>
-          <c:h val="0.96"/>
+          <c:x val="0"/>
+          <c:y val="0"/>
+          <c:w val="0.3478"/>
+          <c:h val="1"/>
         </c:manualLayout>
       </c:layout>
       <c:doughnutChart>
@@ -321,19 +425,6 @@
               </c:strCache>
             </c:strRef>
           </c:tx>
-          <c:spPr>
-            <a:solidFill>
-              <a:schemeClr val="accent1"/>
-            </a:solidFill>
-            <a:ln w="6350" cap="flat">
-              <a:solidFill>
-                <a:srgbClr val="F9F9F9"/>
-              </a:solidFill>
-              <a:prstDash val="solid"/>
-              <a:round/>
-            </a:ln>
-            <a:effectLst/>
-          </c:spPr>
           <c:dPt>
             <c:idx val="0"/>
             <c:bubble3D val="0"/>
@@ -347,11 +438,6 @@
                 </a:solidFill>
               </a:ln>
             </c:spPr>
-            <c:extLst>
-              <c:ext xmlns:c16="http://schemas.microsoft.com/office/drawing/2014/chart" uri="{C3380CC4-5D6E-409C-BE32-E72D297353CC}">
-                <c16:uniqueId val="{00000001-2267-E44C-A186-F7ABC248C36F}"/>
-              </c:ext>
-            </c:extLst>
           </c:dPt>
           <c:dPt>
             <c:idx val="1"/>
@@ -366,11 +452,6 @@
                 </a:solidFill>
               </a:ln>
             </c:spPr>
-            <c:extLst>
-              <c:ext xmlns:c16="http://schemas.microsoft.com/office/drawing/2014/chart" uri="{C3380CC4-5D6E-409C-BE32-E72D297353CC}">
-                <c16:uniqueId val="{00000003-2267-E44C-A186-F7ABC248C36F}"/>
-              </c:ext>
-            </c:extLst>
           </c:dPt>
           <c:dPt>
             <c:idx val="2"/>
@@ -385,11 +466,6 @@
                 </a:solidFill>
               </a:ln>
             </c:spPr>
-            <c:extLst>
-              <c:ext xmlns:c16="http://schemas.microsoft.com/office/drawing/2014/chart" uri="{C3380CC4-5D6E-409C-BE32-E72D297353CC}">
-                <c16:uniqueId val="{00000005-2267-E44C-A186-F7ABC248C36F}"/>
-              </c:ext>
-            </c:extLst>
           </c:dPt>
           <c:dPt>
             <c:idx val="3"/>
@@ -404,11 +480,6 @@
                 </a:solidFill>
               </a:ln>
             </c:spPr>
-            <c:extLst>
-              <c:ext xmlns:c16="http://schemas.microsoft.com/office/drawing/2014/chart" uri="{C3380CC4-5D6E-409C-BE32-E72D297353CC}">
-                <c16:uniqueId val="{00000007-2267-E44C-A186-F7ABC248C36F}"/>
-              </c:ext>
-            </c:extLst>
           </c:dPt>
           <c:dPt>
             <c:idx val="4"/>
@@ -423,11 +494,6 @@
                 </a:solidFill>
               </a:ln>
             </c:spPr>
-            <c:extLst>
-              <c:ext xmlns:c16="http://schemas.microsoft.com/office/drawing/2014/chart" uri="{C3380CC4-5D6E-409C-BE32-E72D297353CC}">
-                <c16:uniqueId val="{00000009-2267-E44C-A186-F7ABC248C36F}"/>
-              </c:ext>
-            </c:extLst>
           </c:dPt>
           <c:dPt>
             <c:idx val="5"/>
@@ -442,11 +508,6 @@
                 </a:solidFill>
               </a:ln>
             </c:spPr>
-            <c:extLst>
-              <c:ext xmlns:c16="http://schemas.microsoft.com/office/drawing/2014/chart" uri="{C3380CC4-5D6E-409C-BE32-E72D297353CC}">
-                <c16:uniqueId val="{0000000B-2267-E44C-A186-F7ABC248C36F}"/>
-              </c:ext>
-            </c:extLst>
           </c:dPt>
           <c:dPt>
             <c:idx val="6"/>
@@ -461,52 +522,154 @@
                 </a:solidFill>
               </a:ln>
             </c:spPr>
+          </c:dPt>
+          <c:dPt>
+            <c:idx val="7"/>
+            <c:bubble3D val="0"/>
+            <c:spPr>
+              <a:noFill/>
+              <a:ln>
+                <a:noFill/>
+              </a:ln>
+            </c:spPr>
+          </c:dPt>
+          <c:dLbls>
+            <c:dLbl>
+              <c:idx val="0"/>
+              <c:delete val="1"/>
+            </c:dLbl>
+            <c:dLbl>
+              <c:idx val="1"/>
+              <c:delete val="1"/>
+            </c:dLbl>
+            <c:dLbl>
+              <c:idx val="2"/>
+              <c:delete val="1"/>
+            </c:dLbl>
+            <c:dLbl>
+              <c:idx val="3"/>
+              <c:delete val="1"/>
+            </c:dLbl>
+            <c:dLbl>
+              <c:idx val="4"/>
+              <c:delete val="1"/>
+            </c:dLbl>
+            <c:dLbl>
+              <c:idx val="5"/>
+              <c:delete val="1"/>
+            </c:dLbl>
+            <c:dLbl>
+              <c:idx val="6"/>
+              <c:delete val="1"/>
+            </c:dLbl>
+            <c:dLbl>
+              <c:idx val="7"/>
+              <c:layout>
+                <c:manualLayout>
+                  <c:x val="0"/>
+                  <c:y val="0.4375"/>
+                </c:manualLayout>
+              </c:layout>
+              <c:tx>
+                <c:rich>
+                  <a:bodyPr wrap="none" lIns="0" tIns="0" rIns="0" bIns="0" anchor="ctr"/>
+                  <a:lstStyle/>
+                  <a:p>
+                    <a:fld id="{E57686D2-17AB-4B70-8D85-78CA0FFE44FF}" type="CELLRANGE">
+                      <a:rPr lang="ru-RU" sz="1050" b="1">
+                        <a:solidFill>
+                          <a:schemeClr val="accent4"/>
+                        </a:solidFill>
+                      </a:rPr>
+                      <a:pPr/>
+                      <a:t>[CELLRANGE]</a:t>
+                    </a:fld>
+                    <a:endParaRPr lang="ru-RU"/>
+                  </a:p>
+                </c:rich>
+              </c:tx>
+              <c:spPr>
+                <a:noFill/>
+                <a:ln>
+                  <a:noFill/>
+                </a:ln>
+              </c:spPr>
+              <c:showLegendKey val="0"/>
+              <c:showVal val="0"/>
+              <c:showCatName val="0"/>
+              <c:showSerName val="0"/>
+              <c:showPercent val="0"/>
+              <c:showBubbleSize val="0"/>
+              <c:extLst>
+                <c:ext xmlns:c15="http://schemas.microsoft.com/office/drawing/2012/chart" uri="{CE6537A1-D6FC-4f65-9D91-7224C49458BB}">
+                  <c15:dlblFieldTable/>
+                  <c15:showDataLabelsRange val="1"/>
+                </c:ext>
+              </c:extLst>
+            </c:dLbl>
+            <c:spPr>
+              <a:noFill/>
+              <a:ln>
+                <a:noFill/>
+              </a:ln>
+            </c:spPr>
+            <c:showLegendKey val="0"/>
+            <c:showVal val="0"/>
+            <c:showCatName val="0"/>
+            <c:showSerName val="0"/>
+            <c:showPercent val="0"/>
+            <c:showBubbleSize val="0"/>
+            <c:showLeaderLines val="0"/>
             <c:extLst>
-              <c:ext xmlns:c16="http://schemas.microsoft.com/office/drawing/2014/chart" uri="{C3380CC4-5D6E-409C-BE32-E72D297353CC}">
-                <c16:uniqueId val="{0000000D-2267-E44C-A186-F7ABC248C36F}"/>
+              <c:ext xmlns:c15="http://schemas.microsoft.com/office/drawing/2012/chart" uri="{CE6537A1-D6FC-4f65-9D91-7224C49458BB}">
+                <c15:showDataLabelsRange val="1"/>
+                <c15:showLeaderLines val="0"/>
               </c:ext>
             </c:extLst>
-          </c:dPt>
+          </c:dLbls>
           <c:cat>
             <c:strRef>
-              <c:f>Sheet1!$A$2:$A$8</c:f>
+              <c:f>Sheet1!$C$2:$C$9</c:f>
               <c:strCache>
-                <c:ptCount val="7"/>
+                <c:ptCount val="8"/>
                 <c:pt idx="0">
-                  <c:v>Data Science</c:v>
+                  <c:v>Data Science  71 (55%)</c:v>
                 </c:pt>
                 <c:pt idx="1">
-                  <c:v>Аналитика</c:v>
+                  <c:v>Аналитика  27 (21%)</c:v>
                 </c:pt>
                 <c:pt idx="2">
-                  <c:v>Управление</c:v>
+                  <c:v>Управление  9 (7%)</c:v>
                 </c:pt>
                 <c:pt idx="3">
-                  <c:v>Разработка</c:v>
+                  <c:v>Разработка  11 (9%)</c:v>
                 </c:pt>
                 <c:pt idx="4">
-                  <c:v>Методология, CX</c:v>
+                  <c:v>Методология, CX  6 (5%)</c:v>
                 </c:pt>
                 <c:pt idx="5">
-                  <c:v>Support</c:v>
+                  <c:v>Support  3 (2%)</c:v>
                 </c:pt>
                 <c:pt idx="6">
-                  <c:v>QA</c:v>
+                  <c:v>QA  2 (2%)</c:v>
+                </c:pt>
+                <c:pt idx="7">
+                  <c:v>Служебная строка (подпись в центре)</c:v>
                 </c:pt>
               </c:strCache>
             </c:strRef>
           </c:cat>
           <c:val>
             <c:numRef>
-              <c:f>Sheet1!$B$2:$B$8</c:f>
+              <c:f>Sheet1!$B$2:$B$9</c:f>
               <c:numCache>
                 <c:formatCode>General</c:formatCode>
-                <c:ptCount val="7"/>
+                <c:ptCount val="8"/>
                 <c:pt idx="0">
                   <c:v>71</c:v>
                 </c:pt>
                 <c:pt idx="1">
-                  <c:v>29</c:v>
+                  <c:v>27</c:v>
                 </c:pt>
                 <c:pt idx="2">
                   <c:v>9</c:v>
@@ -515,32 +678,34 @@
                   <c:v>11</c:v>
                 </c:pt>
                 <c:pt idx="4">
-                  <c:v>7</c:v>
+                  <c:v>6</c:v>
                 </c:pt>
                 <c:pt idx="5">
                   <c:v>3</c:v>
                 </c:pt>
                 <c:pt idx="6">
                   <c:v>2</c:v>
+                </c:pt>
+                <c:pt idx="7">
+                  <c:v>0.00129</c:v>
                 </c:pt>
               </c:numCache>
             </c:numRef>
           </c:val>
           <c:extLst>
-            <c:ext xmlns:c16="http://schemas.microsoft.com/office/drawing/2014/chart" uri="{C3380CC4-5D6E-409C-BE32-E72D297353CC}">
-              <c16:uniqueId val="{0000000E-2267-E44C-A186-F7ABC248C36F}"/>
+            <c:ext xmlns:c15="http://schemas.microsoft.com/office/drawing/2012/chart" uri="{02D57815-91ED-43cb-92C2-25804820EDAC}">
+              <c15:datalabelsRange>
+                <c15:f>Sheet1!$D$2:$D$9</c15:f>
+                <c15:dlblRangeCache>
+                  <c:ptCount val="8"/>
+                  <c:pt idx="7">
+                    <c:v>131 ПШЕ</c:v>
+                  </c:pt>
+                </c15:dlblRangeCache>
+              </c15:datalabelsRange>
             </c:ext>
           </c:extLst>
         </c:ser>
-        <c:dLbls>
-          <c:showLegendKey val="0"/>
-          <c:showVal val="0"/>
-          <c:showCatName val="0"/>
-          <c:showSerName val="0"/>
-          <c:showPercent val="0"/>
-          <c:showBubbleSize val="0"/>
-          <c:showLeaderLines val="0"/>
-        </c:dLbls>
         <c:firstSliceAng val="0"/>
         <c:holeSize val="75"/>
       </c:doughnutChart>
@@ -552,6 +717,44 @@
         <a:effectLst/>
       </c:spPr>
     </c:plotArea>
+    <c:legend>
+      <c:legendPos val="r"/>
+      <c:legendEntry>
+        <c:idx val="7"/>
+        <c:delete val="1"/>
+      </c:legendEntry>
+      <c:layout>
+        <c:manualLayout>
+          <c:xMode val="edge"/>
+          <c:yMode val="edge"/>
+          <c:x val="0.4058"/>
+          <c:y val="0.000"/>
+          <c:w val="0.5842"/>
+          <c:h val="1.000"/>
+        </c:manualLayout>
+      </c:layout>
+      <c:overlay val="0"/>
+      <c:spPr>
+        <a:noFill/>
+        <a:ln>
+          <a:noFill/>
+        </a:ln>
+      </c:spPr>
+      <c:txPr>
+        <a:bodyPr/>
+        <a:lstStyle/>
+        <a:p>
+          <a:pPr>
+            <a:defRPr sz="1000" b="0">
+              <a:solidFill>
+                <a:schemeClr val="tx1"/>
+              </a:solidFill>
+            </a:defRPr>
+          </a:pPr>
+          <a:endParaRPr lang="ru-RU"/>
+        </a:p>
+      </c:txPr>
+    </c:legend>
     <c:plotVisOnly val="1"/>
     <c:dispBlanksAs val="span"/>
     <c:showDLblsOverMax val="1"/>
@@ -881,7 +1084,7 @@
                   <a:bodyPr wrap="none" lIns="0" tIns="0" rIns="0" bIns="0" anchor="ctr"/>
                   <a:lstStyle/>
                   <a:p>
-                    <a:fld id="{9B5E3B61-41DD-402F-8057-79B0D7EB43A9}" type="CELLRANGE">
+                    <a:fld id="{1B42A5B2-A3C5-4B97-A299-7282A0BC7F45}" type="CELLRANGE">
                       <a:rPr lang="ru-RU" sz="1050" b="1">
                         <a:solidFill>
                           <a:schemeClr val="accent3"/>
@@ -921,7 +1124,7 @@
                   <a:bodyPr wrap="none" lIns="0" tIns="0" rIns="0" bIns="0" anchor="ctr"/>
                   <a:lstStyle/>
                   <a:p>
-                    <a:fld id="{D52364A3-85AC-4454-BDFA-BADDCC64101D}" type="CELLRANGE">
+                    <a:fld id="{543853D3-BD97-4AD1-BB99-A5429F47292C}" type="CELLRANGE">
                       <a:rPr lang="ru-RU" sz="1050" b="1">
                         <a:solidFill>
                           <a:schemeClr val="accent3"/>
@@ -961,7 +1164,7 @@
                   <a:bodyPr wrap="none" lIns="0" tIns="0" rIns="0" bIns="0" anchor="ctr"/>
                   <a:lstStyle/>
                   <a:p>
-                    <a:fld id="{54F9BBA3-22CA-4D91-A878-486B18D59D48}" type="CELLRANGE">
+                    <a:fld id="{1FB6CB5F-6349-4CB2-A1C1-8FBBE7175E5E}" type="CELLRANGE">
                       <a:rPr lang="ru-RU" sz="1050" b="1">
                         <a:solidFill>
                           <a:schemeClr val="accent3"/>
@@ -1001,7 +1204,7 @@
                   <a:bodyPr wrap="none" lIns="0" tIns="0" rIns="0" bIns="0" anchor="ctr"/>
                   <a:lstStyle/>
                   <a:p>
-                    <a:fld id="{85DDAEB5-9F75-4009-8333-E2EA4D42BB3F}" type="CELLRANGE">
+                    <a:fld id="{C985B3A8-7182-4C66-93D2-C7BAD2EAA9AA}" type="CELLRANGE">
                       <a:rPr lang="ru-RU" sz="1050" b="1">
                         <a:solidFill>
                           <a:schemeClr val="accent3"/>
@@ -1041,7 +1244,7 @@
                   <a:bodyPr wrap="none" lIns="0" tIns="0" rIns="0" bIns="0" anchor="ctr"/>
                   <a:lstStyle/>
                   <a:p>
-                    <a:fld id="{DA956C07-9885-423E-82C6-7327601ADC22}" type="CELLRANGE">
+                    <a:fld id="{3E02252C-2F33-427A-AD85-42176D05F6F9}" type="CELLRANGE">
                       <a:rPr lang="ru-RU" sz="1050" b="1">
                         <a:solidFill>
                           <a:schemeClr val="accent3"/>
@@ -1081,7 +1284,7 @@
                   <a:bodyPr wrap="none" lIns="0" tIns="0" rIns="0" bIns="0" anchor="ctr"/>
                   <a:lstStyle/>
                   <a:p>
-                    <a:fld id="{892FE1D5-F252-4070-92B4-20A56C710C04}" type="CELLRANGE">
+                    <a:fld id="{C8235472-65CB-469D-94E4-1BC4DF2EAA44}" type="CELLRANGE">
                       <a:rPr lang="ru-RU" sz="1050" b="1">
                         <a:solidFill>
                           <a:schemeClr val="accent3"/>
@@ -1121,7 +1324,7 @@
                   <a:bodyPr wrap="none" lIns="0" tIns="0" rIns="0" bIns="0" anchor="ctr"/>
                   <a:lstStyle/>
                   <a:p>
-                    <a:fld id="{F03C4ADC-6BCF-4DCD-965E-7DF120AF4BE2}" type="CELLRANGE">
+                    <a:fld id="{37D2D1EA-DFA3-488F-A2E9-EC6E95ECE65B}" type="CELLRANGE">
                       <a:rPr lang="ru-RU" sz="1050" b="1">
                         <a:solidFill>
                           <a:schemeClr val="accent3"/>
@@ -1308,7 +1511,7 @@
                   <a:bodyPr wrap="none" lIns="0" tIns="0" rIns="0" bIns="0" anchor="ctr"/>
                   <a:lstStyle/>
                   <a:p>
-                    <a:fld id="{37A7B07C-109B-404A-8108-E17694132615}" type="CELLRANGE">
+                    <a:fld id="{9806E867-DC6B-4AA1-A15F-FB080E90FF3F}" type="CELLRANGE">
                       <a:rPr lang="ru-RU" sz="1050" b="1">
                         <a:solidFill>
                           <a:srgbClr val="7B8794"/>
@@ -1348,7 +1551,7 @@
                   <a:bodyPr wrap="none" lIns="0" tIns="0" rIns="0" bIns="0" anchor="ctr"/>
                   <a:lstStyle/>
                   <a:p>
-                    <a:fld id="{7DD450E0-3832-44E4-BC7E-49FD218D483A}" type="CELLRANGE">
+                    <a:fld id="{246B0C11-6C91-414F-A41C-B40131D11843}" type="CELLRANGE">
                       <a:rPr lang="ru-RU" sz="1050" b="1">
                         <a:solidFill>
                           <a:srgbClr val="7B8794"/>
@@ -1388,7 +1591,7 @@
                   <a:bodyPr wrap="none" lIns="0" tIns="0" rIns="0" bIns="0" anchor="ctr"/>
                   <a:lstStyle/>
                   <a:p>
-                    <a:fld id="{DE7EABEC-F4C6-4C01-A6DB-64C8FF5069FD}" type="CELLRANGE">
+                    <a:fld id="{6354182C-5259-4229-8C8E-0AB5A2AB1619}" type="CELLRANGE">
                       <a:rPr lang="ru-RU" sz="1050" b="1">
                         <a:solidFill>
                           <a:srgbClr val="7B8794"/>
@@ -1428,7 +1631,7 @@
                   <a:bodyPr wrap="none" lIns="0" tIns="0" rIns="0" bIns="0" anchor="ctr"/>
                   <a:lstStyle/>
                   <a:p>
-                    <a:fld id="{924E0DC7-3301-4DAE-9D6C-793DC52B6F3E}" type="CELLRANGE">
+                    <a:fld id="{E7622934-B3A0-479E-A4E3-08BF3146FB40}" type="CELLRANGE">
                       <a:rPr lang="ru-RU" sz="1050" b="1">
                         <a:solidFill>
                           <a:srgbClr val="7B8794"/>
@@ -1468,7 +1671,7 @@
                   <a:bodyPr wrap="none" lIns="0" tIns="0" rIns="0" bIns="0" anchor="ctr"/>
                   <a:lstStyle/>
                   <a:p>
-                    <a:fld id="{59B4845B-1770-4A50-AD7F-ADD5665249A8}" type="CELLRANGE">
+                    <a:fld id="{1EC2C86D-3004-4D21-86EB-F09A4FD3BA8E}" type="CELLRANGE">
                       <a:rPr lang="ru-RU" sz="1050" b="1">
                         <a:solidFill>
                           <a:srgbClr val="7B8794"/>
@@ -1508,7 +1711,7 @@
                   <a:bodyPr wrap="none" lIns="0" tIns="0" rIns="0" bIns="0" anchor="ctr"/>
                   <a:lstStyle/>
                   <a:p>
-                    <a:fld id="{D9CF3EA4-E5A3-40B3-8307-44FD83AADB22}" type="CELLRANGE">
+                    <a:fld id="{402B9B2C-FEC2-4609-8605-80DD1E81C4F1}" type="CELLRANGE">
                       <a:rPr lang="ru-RU" sz="1050" b="1">
                         <a:solidFill>
                           <a:srgbClr val="7B8794"/>
@@ -1548,7 +1751,7 @@
                   <a:bodyPr wrap="none" lIns="0" tIns="0" rIns="0" bIns="0" anchor="ctr"/>
                   <a:lstStyle/>
                   <a:p>
-                    <a:fld id="{69C75D70-B802-4A29-B4D5-D89EEAAB7BE2}" type="CELLRANGE">
+                    <a:fld id="{0AB607A4-BBE2-4854-A45F-4F2B4A87EB54}" type="CELLRANGE">
                       <a:rPr lang="ru-RU" sz="1050" b="1">
                         <a:solidFill>
                           <a:srgbClr val="7B8794"/>
@@ -1735,7 +1938,7 @@
                   <a:bodyPr wrap="none" lIns="0" tIns="0" rIns="0" bIns="0" anchor="ctr"/>
                   <a:lstStyle/>
                   <a:p>
-                    <a:fld id="{407E76AF-CAB5-4083-BAE9-D02640933B3B}" type="CELLRANGE">
+                    <a:fld id="{188F8680-45A1-497E-99DC-55FA2B275D20}" type="CELLRANGE">
                       <a:rPr lang="ru-RU" sz="1050" b="1">
                         <a:solidFill>
                           <a:schemeClr val="accent4"/>
@@ -1775,7 +1978,7 @@
                   <a:bodyPr wrap="none" lIns="0" tIns="0" rIns="0" bIns="0" anchor="ctr"/>
                   <a:lstStyle/>
                   <a:p>
-                    <a:fld id="{F372DEAE-3162-4D89-8E0C-A1250E30B857}" type="CELLRANGE">
+                    <a:fld id="{12AF55C1-6133-4E9C-946D-888BFF6AA3C5}" type="CELLRANGE">
                       <a:rPr lang="ru-RU" sz="1050" b="1">
                         <a:solidFill>
                           <a:schemeClr val="accent4"/>
@@ -1815,7 +2018,7 @@
                   <a:bodyPr wrap="none" lIns="0" tIns="0" rIns="0" bIns="0" anchor="ctr"/>
                   <a:lstStyle/>
                   <a:p>
-                    <a:fld id="{D852E194-15B1-46CF-86DF-6AF5979CD8A7}" type="CELLRANGE">
+                    <a:fld id="{C54CCB43-3961-45D8-A2E9-633B66906B2B}" type="CELLRANGE">
                       <a:rPr lang="ru-RU" sz="1050" b="1">
                         <a:solidFill>
                           <a:schemeClr val="accent4"/>
@@ -1855,7 +2058,7 @@
                   <a:bodyPr wrap="none" lIns="0" tIns="0" rIns="0" bIns="0" anchor="ctr"/>
                   <a:lstStyle/>
                   <a:p>
-                    <a:fld id="{22D8DD44-C7F4-4586-8850-010F33E90C0C}" type="CELLRANGE">
+                    <a:fld id="{CD23A225-38D4-42EA-AF66-FE1C34E3079C}" type="CELLRANGE">
                       <a:rPr lang="ru-RU" sz="1050" b="1">
                         <a:solidFill>
                           <a:schemeClr val="accent4"/>
@@ -1895,7 +2098,7 @@
                   <a:bodyPr wrap="none" lIns="0" tIns="0" rIns="0" bIns="0" anchor="ctr"/>
                   <a:lstStyle/>
                   <a:p>
-                    <a:fld id="{76965044-FA10-4F12-A09C-8086BF97FFCC}" type="CELLRANGE">
+                    <a:fld id="{E18F13CA-5A86-47AB-A0CC-902C2421432A}" type="CELLRANGE">
                       <a:rPr lang="ru-RU" sz="1050" b="1">
                         <a:solidFill>
                           <a:schemeClr val="accent4"/>
@@ -1935,7 +2138,7 @@
                   <a:bodyPr wrap="none" lIns="0" tIns="0" rIns="0" bIns="0" anchor="ctr"/>
                   <a:lstStyle/>
                   <a:p>
-                    <a:fld id="{5DA6358C-3755-4049-AC73-8CC873A6544C}" type="CELLRANGE">
+                    <a:fld id="{8248C5B8-FAB5-485A-93A3-52526C0EE8BA}" type="CELLRANGE">
                       <a:rPr lang="ru-RU" sz="1050" b="1">
                         <a:solidFill>
                           <a:schemeClr val="accent4"/>
@@ -1975,7 +2178,7 @@
                   <a:bodyPr wrap="none" lIns="0" tIns="0" rIns="0" bIns="0" anchor="ctr"/>
                   <a:lstStyle/>
                   <a:p>
-                    <a:fld id="{9AB295A8-95A2-4A08-8E27-FCDFE3073A53}" type="CELLRANGE">
+                    <a:fld id="{BD2610B9-AB17-44F1-8DE5-237975F32050}" type="CELLRANGE">
                       <a:rPr lang="ru-RU" sz="1050" b="1">
                         <a:solidFill>
                           <a:schemeClr val="accent4"/>
@@ -2162,7 +2365,7 @@
                   <a:bodyPr wrap="none" lIns="0" tIns="0" rIns="0" bIns="0" anchor="ctr"/>
                   <a:lstStyle/>
                   <a:p>
-                    <a:fld id="{69FB8892-93AA-4217-A96E-338D4C9BE708}" type="CELLRANGE">
+                    <a:fld id="{18DFCEBA-6F21-4945-A276-B7FC8C00D260}" type="CELLRANGE">
                       <a:rPr lang="ru-RU" sz="1050" b="1">
                         <a:solidFill>
                           <a:srgbClr val="B76E00"/>
@@ -2202,7 +2405,7 @@
                   <a:bodyPr wrap="none" lIns="0" tIns="0" rIns="0" bIns="0" anchor="ctr"/>
                   <a:lstStyle/>
                   <a:p>
-                    <a:fld id="{A99902E4-7422-4654-A2D5-E0754C2B6560}" type="CELLRANGE">
+                    <a:fld id="{6501EDA4-051B-4E2C-84E2-7EADB36F6229}" type="CELLRANGE">
                       <a:rPr lang="ru-RU" sz="1050" b="1">
                         <a:solidFill>
                           <a:srgbClr val="B76E00"/>
@@ -2242,7 +2445,7 @@
                   <a:bodyPr wrap="none" lIns="0" tIns="0" rIns="0" bIns="0" anchor="ctr"/>
                   <a:lstStyle/>
                   <a:p>
-                    <a:fld id="{06986935-3243-469D-9413-CBF413DE6A89}" type="CELLRANGE">
+                    <a:fld id="{BC42367A-D7E1-4341-9079-1B9A1E70812D}" type="CELLRANGE">
                       <a:rPr lang="ru-RU" sz="1050" b="1">
                         <a:solidFill>
                           <a:srgbClr val="B76E00"/>
@@ -2282,7 +2485,7 @@
                   <a:bodyPr wrap="none" lIns="0" tIns="0" rIns="0" bIns="0" anchor="ctr"/>
                   <a:lstStyle/>
                   <a:p>
-                    <a:fld id="{D1CDB90E-D7BD-48B8-9FB6-42D235BBCD41}" type="CELLRANGE">
+                    <a:fld id="{2D241027-59A4-420F-B619-6903FD47A360}" type="CELLRANGE">
                       <a:rPr lang="ru-RU" sz="1050" b="1">
                         <a:solidFill>
                           <a:srgbClr val="B76E00"/>
@@ -2322,7 +2525,7 @@
                   <a:bodyPr wrap="none" lIns="0" tIns="0" rIns="0" bIns="0" anchor="ctr"/>
                   <a:lstStyle/>
                   <a:p>
-                    <a:fld id="{217AB7B1-521B-4C60-AE8E-983B6B9D7832}" type="CELLRANGE">
+                    <a:fld id="{8820F9C5-F5D0-4C52-89F6-DAEE9C2CC90F}" type="CELLRANGE">
                       <a:rPr lang="ru-RU" sz="1050" b="1">
                         <a:solidFill>
                           <a:srgbClr val="B76E00"/>
@@ -2362,7 +2565,7 @@
                   <a:bodyPr wrap="none" lIns="0" tIns="0" rIns="0" bIns="0" anchor="ctr"/>
                   <a:lstStyle/>
                   <a:p>
-                    <a:fld id="{E5C4A89B-962E-44A1-BA73-05D37DB6898D}" type="CELLRANGE">
+                    <a:fld id="{EAEA9291-1B0C-403B-A232-CAA41427FBEE}" type="CELLRANGE">
                       <a:rPr lang="ru-RU" sz="1050" b="1">
                         <a:solidFill>
                           <a:srgbClr val="B76E00"/>
@@ -2402,7 +2605,7 @@
                   <a:bodyPr wrap="none" lIns="0" tIns="0" rIns="0" bIns="0" anchor="ctr"/>
                   <a:lstStyle/>
                   <a:p>
-                    <a:fld id="{5363328D-A78F-4709-8A20-4B9E8FA382DB}" type="CELLRANGE">
+                    <a:fld id="{989DCA6B-76D2-4B5A-98AE-957C29C14955}" type="CELLRANGE">
                       <a:rPr lang="ru-RU" sz="1050" b="1">
                         <a:solidFill>
                           <a:srgbClr val="B76E00"/>
@@ -6591,8 +6794,8 @@
             </p:nvPr>
           </p:nvGraphicFramePr>
           <p:xfrm>
-            <a:off x="594360" y="1810512"/>
-            <a:ext cx="1097280" cy="1097280"/>
+            <a:off x="548640" y="1810512"/>
+            <a:ext cx="2788920" cy="1097280"/>
           </p:xfrm>
           <a:graphic>
             <a:graphicData uri="http://schemas.openxmlformats.org/drawingml/2006/chart">
@@ -6600,182 +6803,6 @@
             </a:graphicData>
           </a:graphic>
         </p:graphicFrame>
-        <p:sp>
-          <p:nvSpPr>
-            <p:cNvPr id="13" name="Центр кольца: 89,3%">
-              <a:extLst>
-                <a:ext uri="{FF2B5EF4-FFF2-40B4-BE49-F238E27FC236}">
-                  <a16:creationId xmlns:a16="http://schemas.microsoft.com/office/drawing/2014/main" id="{72CFB3D4-E6DA-5620-F73E-63E447AAF573}"/>
-                </a:ext>
-              </a:extLst>
-            </p:cNvPr>
-            <p:cNvSpPr/>
-            <p:nvPr/>
-          </p:nvSpPr>
-          <p:spPr>
-            <a:xfrm>
-              <a:off x="722376" y="2130552"/>
-              <a:ext cx="841248" cy="457200"/>
-            </a:xfrm>
-            <a:prstGeom prst="rect">
-              <a:avLst/>
-            </a:prstGeom>
-            <a:noFill/>
-            <a:ln/>
-          </p:spPr>
-          <p:txBody>
-            <a:bodyPr wrap="square" rtlCol="0" anchor="ctr" lIns="0" tIns="0" rIns="0" bIns="0">
-              <a:noAutofit/>
-            </a:bodyPr>
-            <a:lstStyle/>
-            <a:p>
-              <a:pPr algn="ctr">
-                <a:defRPr/>
-              </a:pPr>
-              <a:r>
-                <a:rPr lang="en-US" sz="1400" b="1" dirty="0" i="0">
-                  <a:solidFill>
-                    <a:schemeClr val="accent4"/>
-                  </a:solidFill>
-                </a:rPr>
-                <a:t>89,3</a:t>
-              </a:r>
-              <a:r>
-                <a:rPr lang="en-US" sz="900" b="1" dirty="0" i="0">
-                  <a:solidFill>
-                    <a:schemeClr val="accent4"/>
-                  </a:solidFill>
-                </a:rPr>
-                <a:t>%</a:t>
-              </a:r>
-              <a:endParaRPr lang="en-US" sz="1400" b="1" dirty="0" i="0">
-                <a:solidFill>
-                  <a:schemeClr val="accent4"/>
-                </a:solidFill>
-              </a:endParaRPr>
-            </a:p>
-          </p:txBody>
-        </p:sp>
-        <p:sp>
-          <p:nvSpPr>
-            <p:cNvPr id="15" name="Легенда: Укомплектованность">
-              <a:extLst>
-                <a:ext uri="{FF2B5EF4-FFF2-40B4-BE49-F238E27FC236}">
-                  <a16:creationId xmlns:a16="http://schemas.microsoft.com/office/drawing/2014/main" id="{F632EFDA-ADD2-548B-5787-F6DDA0A7A5DA}"/>
-                </a:ext>
-              </a:extLst>
-            </p:cNvPr>
-            <p:cNvSpPr/>
-            <p:nvPr/>
-          </p:nvSpPr>
-          <p:spPr>
-            <a:xfrm>
-              <a:off x="1874520" y="1810512"/>
-              <a:ext cx="1463040" cy="1097280"/>
-            </a:xfrm>
-            <a:prstGeom prst="rect">
-              <a:avLst/>
-            </a:prstGeom>
-            <a:noFill/>
-            <a:ln/>
-          </p:spPr>
-          <p:txBody>
-            <a:bodyPr wrap="square" rtlCol="0" anchor="ctr" lIns="0" tIns="0" rIns="0" bIns="0">
-              <a:noAutofit/>
-            </a:bodyPr>
-            <a:lstStyle/>
-            <a:p>
-              <a:pPr>
-                <a:spcAft>
-                  <a:spcPts val="600"/>
-                </a:spcAft>
-                <a:defRPr/>
-              </a:pPr>
-              <a:r>
-                <a:rPr lang="en-US" sz="1000" dirty="0" b="0" i="0">
-                  <a:solidFill>
-                    <a:schemeClr val="accent4"/>
-                  </a:solidFill>
-                </a:rPr>
-                <a:t>● </a:t>
-              </a:r>
-              <a:r>
-                <a:rPr lang="en-US" sz="1000" b="1" dirty="0" i="0">
-                  <a:solidFill>
-                    <a:schemeClr val="tx1"/>
-                  </a:solidFill>
-                </a:rPr>
-                <a:t>117 ПШЕ </a:t>
-              </a:r>
-              <a:r>
-                <a:rPr lang="en-US" sz="1000" dirty="0" i="0">
-                  <a:solidFill>
-                    <a:schemeClr val="tx1"/>
-                  </a:solidFill>
-                </a:rPr>
-                <a:t>занято</a:t>
-              </a:r>
-              <a:endParaRPr lang="en-US" sz="1000" dirty="0" i="0">
-                <a:solidFill>
-                  <a:schemeClr val="tx1"/>
-                </a:solidFill>
-              </a:endParaRPr>
-            </a:p>
-            <a:p>
-              <a:pPr>
-                <a:spcAft>
-                  <a:spcPts val="600"/>
-                </a:spcAft>
-                <a:defRPr/>
-              </a:pPr>
-              <a:r>
-                <a:rPr lang="en-US" sz="1000" dirty="0" b="0" i="0">
-                  <a:solidFill>
-                    <a:srgbClr val="E23B2E"/>
-                  </a:solidFill>
-                </a:rPr>
-                <a:t>● </a:t>
-              </a:r>
-              <a:r>
-                <a:rPr lang="en-US" sz="1000" b="1" dirty="0" i="0">
-                  <a:solidFill>
-                    <a:schemeClr val="tx1"/>
-                  </a:solidFill>
-                </a:rPr>
-                <a:t>14 ПШЕ </a:t>
-              </a:r>
-              <a:r>
-                <a:rPr lang="en-US" sz="1000" dirty="0" err="1" i="0">
-                  <a:solidFill>
-                    <a:schemeClr val="tx1"/>
-                  </a:solidFill>
-                </a:rPr>
-                <a:t>в</a:t>
-              </a:r>
-              <a:r>
-                <a:rPr lang="en-US" sz="1000" dirty="0" i="0">
-                  <a:solidFill>
-                    <a:schemeClr val="tx1"/>
-                  </a:solidFill>
-                </a:rPr>
-                <a:t> </a:t>
-              </a:r>
-              <a:r>
-                <a:rPr lang="ru-RU" sz="1000" dirty="0" i="0">
-                  <a:solidFill>
-                    <a:schemeClr val="tx1"/>
-                  </a:solidFill>
-                </a:rPr>
-                <a:t>подборе</a:t>
-              </a:r>
-              <a:endParaRPr lang="en-US" sz="1000" dirty="0" i="0">
-                <a:solidFill>
-                  <a:schemeClr val="tx1"/>
-                </a:solidFill>
-              </a:endParaRPr>
-            </a:p>
-          </p:txBody>
-        </p:sp>
       </p:grpSp>
       <p:grpSp>
         <p:nvGrpSpPr>
@@ -6893,8 +6920,8 @@
             </p:nvPr>
           </p:nvGraphicFramePr>
           <p:xfrm>
-            <a:off x="3703320" y="1810512"/>
-            <a:ext cx="1097280" cy="1097280"/>
+            <a:off x="3657600" y="1810512"/>
+            <a:ext cx="3154680" cy="1097280"/>
           </p:xfrm>
           <a:graphic>
             <a:graphicData uri="http://schemas.openxmlformats.org/drawingml/2006/chart">
@@ -6902,420 +6929,6 @@
             </a:graphicData>
           </a:graphic>
         </p:graphicFrame>
-        <p:sp>
-          <p:nvSpPr>
-            <p:cNvPr id="2" name="Центр кольца: 131 ПШЕ">
-              <a:extLst>
-                <a:ext uri="{FF2B5EF4-FFF2-40B4-BE49-F238E27FC236}">
-                  <a16:creationId xmlns:a16="http://schemas.microsoft.com/office/drawing/2014/main" id="{79ED5D29-49CC-1880-E0A4-DFB3839B4BAF}"/>
-                </a:ext>
-              </a:extLst>
-            </p:cNvPr>
-            <p:cNvSpPr/>
-            <p:nvPr/>
-          </p:nvSpPr>
-          <p:spPr>
-            <a:xfrm>
-              <a:off x="3831336" y="2130552"/>
-              <a:ext cx="841248" cy="457200"/>
-            </a:xfrm>
-            <a:prstGeom prst="rect">
-              <a:avLst/>
-            </a:prstGeom>
-            <a:noFill/>
-            <a:ln/>
-          </p:spPr>
-          <p:txBody>
-            <a:bodyPr wrap="square" rtlCol="0" anchor="ctr" lIns="0" tIns="0" rIns="0" bIns="0">
-              <a:noAutofit/>
-            </a:bodyPr>
-            <a:lstStyle/>
-            <a:p>
-              <a:pPr algn="ctr">
-                <a:defRPr/>
-              </a:pPr>
-              <a:r>
-                <a:rPr lang="en-US" sz="1400" b="1" dirty="0" i="0">
-                  <a:solidFill>
-                    <a:schemeClr val="accent4"/>
-                  </a:solidFill>
-                </a:rPr>
-                <a:t>131</a:t>
-              </a:r>
-              <a:br>
-                <a:rPr lang="ru-RU" sz="1400" b="1" dirty="0" i="0">
-                  <a:solidFill>
-                    <a:schemeClr val="accent4"/>
-                  </a:solidFill>
-                </a:rPr>
-              </a:br>
-              <a:r>
-                <a:rPr lang="en-US" sz="850" b="1" dirty="0" i="0">
-                  <a:solidFill>
-                    <a:schemeClr val="tx1"/>
-                  </a:solidFill>
-                </a:rPr>
-                <a:t>ПШЕ</a:t>
-              </a:r>
-            </a:p>
-          </p:txBody>
-        </p:sp>
-        <p:sp>
-          <p:nvSpPr>
-            <p:cNvPr id="18" name="Легенда: Структура компетенций">
-              <a:extLst>
-                <a:ext uri="{FF2B5EF4-FFF2-40B4-BE49-F238E27FC236}">
-                  <a16:creationId xmlns:a16="http://schemas.microsoft.com/office/drawing/2014/main" id="{B028CEBB-3A42-EE35-01E8-F57B638A63E1}"/>
-                </a:ext>
-              </a:extLst>
-            </p:cNvPr>
-            <p:cNvSpPr/>
-            <p:nvPr/>
-          </p:nvSpPr>
-          <p:spPr>
-            <a:xfrm>
-              <a:off x="4937760" y="1755648"/>
-              <a:ext cx="1911096" cy="1207008"/>
-            </a:xfrm>
-            <a:prstGeom prst="rect">
-              <a:avLst/>
-            </a:prstGeom>
-            <a:noFill/>
-            <a:ln/>
-          </p:spPr>
-          <p:txBody>
-            <a:bodyPr wrap="square" rtlCol="0" anchor="ctr" lIns="0" tIns="0" rIns="0" bIns="0">
-              <a:noAutofit/>
-            </a:bodyPr>
-            <a:lstStyle/>
-            <a:p>
-              <a:pPr>
-                <a:lnSpc>
-                  <a:spcPct val="100000"/>
-                </a:lnSpc>
-                <a:spcAft>
-                  <a:spcPts val="170"/>
-                </a:spcAft>
-                <a:tabLst>
-                  <a:tab pos="1325880" algn="l"/>
-                </a:tabLst>
-              </a:pPr>
-              <a:r>
-                <a:rPr lang="en-US" sz="1000" dirty="0" b="0" i="0">
-                  <a:solidFill>
-                    <a:schemeClr val="accent6"/>
-                  </a:solidFill>
-                </a:rPr>
-                <a:t>●</a:t>
-              </a:r>
-              <a:r>
-                <a:rPr lang="en-US" sz="1000" dirty="0" b="0" i="0">
-                  <a:solidFill>
-                    <a:schemeClr val="tx1"/>
-                  </a:solidFill>
-                </a:rPr>
-                <a:t> </a:t>
-              </a:r>
-              <a:r>
-                <a:rPr lang="en-US" sz="1000" dirty="0" b="0" i="0">
-                  <a:solidFill>
-                    <a:schemeClr val="tx1"/>
-                  </a:solidFill>
-                </a:rPr>
-                <a:t>Data Science	71</a:t>
-              </a:r>
-              <a:r>
-                <a:rPr lang="en-US" sz="1000" dirty="0" b="0" i="0">
-                  <a:solidFill>
-                    <a:srgbClr val="6B7785"/>
-                  </a:solidFill>
-                </a:rPr>
-                <a:t> (55%)</a:t>
-              </a:r>
-              <a:endParaRPr lang="en-US" sz="1000" dirty="0" b="0" i="0">
-                <a:solidFill>
-                  <a:schemeClr val="tx1"/>
-                </a:solidFill>
-              </a:endParaRPr>
-            </a:p>
-            <a:p>
-              <a:pPr>
-                <a:lnSpc>
-                  <a:spcPct val="100000"/>
-                </a:lnSpc>
-                <a:spcAft>
-                  <a:spcPts val="170"/>
-                </a:spcAft>
-                <a:tabLst>
-                  <a:tab pos="1325880" algn="l"/>
-                </a:tabLst>
-              </a:pPr>
-              <a:r>
-                <a:rPr lang="en-US" sz="1000" dirty="0" b="0" i="0">
-                  <a:solidFill>
-                    <a:schemeClr val="accent5"/>
-                  </a:solidFill>
-                </a:rPr>
-                <a:t>●</a:t>
-              </a:r>
-              <a:r>
-                <a:rPr lang="en-US" sz="1000" dirty="0" b="0" i="0">
-                  <a:solidFill>
-                    <a:schemeClr val="tx1"/>
-                  </a:solidFill>
-                </a:rPr>
-                <a:t> </a:t>
-              </a:r>
-              <a:r>
-                <a:rPr lang="en-US" sz="1000" dirty="0" b="0" i="0">
-                  <a:solidFill>
-                    <a:schemeClr val="tx1"/>
-                  </a:solidFill>
-                </a:rPr>
-                <a:t>Аналитика	27</a:t>
-              </a:r>
-              <a:r>
-                <a:rPr lang="en-US" sz="1000" dirty="0" b="0" i="0">
-                  <a:solidFill>
-                    <a:srgbClr val="6B7785"/>
-                  </a:solidFill>
-                </a:rPr>
-                <a:t> (21%)</a:t>
-              </a:r>
-              <a:endParaRPr lang="en-US" sz="1000" dirty="0" b="0" i="0">
-                <a:solidFill>
-                  <a:schemeClr val="tx1"/>
-                </a:solidFill>
-              </a:endParaRPr>
-            </a:p>
-            <a:p>
-              <a:pPr>
-                <a:lnSpc>
-                  <a:spcPct val="100000"/>
-                </a:lnSpc>
-                <a:spcAft>
-                  <a:spcPts val="170"/>
-                </a:spcAft>
-                <a:tabLst>
-                  <a:tab pos="1325880" algn="l"/>
-                </a:tabLst>
-              </a:pPr>
-              <a:r>
-                <a:rPr lang="en-US" sz="1000" dirty="0" b="0" i="0">
-                  <a:solidFill>
-                    <a:schemeClr val="accent4"/>
-                  </a:solidFill>
-                </a:rPr>
-                <a:t>● </a:t>
-              </a:r>
-              <a:r>
-                <a:rPr lang="en-US" sz="1000" dirty="0" err="1" b="0" i="0">
-                  <a:solidFill>
-                    <a:schemeClr val="tx1"/>
-                  </a:solidFill>
-                </a:rPr>
-                <a:t>Управление</a:t>
-              </a:r>
-              <a:r>
-                <a:rPr lang="en-US" sz="1000" dirty="0" b="0" i="0">
-                  <a:solidFill>
-                    <a:schemeClr val="tx1"/>
-                  </a:solidFill>
-                </a:rPr>
-                <a:t>	</a:t>
-              </a:r>
-              <a:r>
-                <a:rPr lang="ru-RU" sz="1000" dirty="0" b="0" i="0">
-                  <a:solidFill>
-                    <a:schemeClr val="tx1"/>
-                  </a:solidFill>
-                </a:rPr>
-                <a:t>9</a:t>
-              </a:r>
-              <a:r>
-                <a:rPr lang="en-US" sz="1000" dirty="0" b="0" i="0">
-                  <a:solidFill>
-                    <a:srgbClr val="6B7785"/>
-                  </a:solidFill>
-                </a:rPr>
-                <a:t> (8%)</a:t>
-              </a:r>
-              <a:endParaRPr lang="en-US" sz="1000" dirty="0" b="0" i="0">
-                <a:solidFill>
-                  <a:schemeClr val="tx1"/>
-                </a:solidFill>
-              </a:endParaRPr>
-            </a:p>
-            <a:p>
-              <a:pPr>
-                <a:lnSpc>
-                  <a:spcPct val="100000"/>
-                </a:lnSpc>
-                <a:spcAft>
-                  <a:spcPts val="170"/>
-                </a:spcAft>
-                <a:tabLst>
-                  <a:tab pos="1325880" algn="l"/>
-                </a:tabLst>
-              </a:pPr>
-              <a:r>
-                <a:rPr lang="en-US" sz="1000" dirty="0" b="0" i="0">
-                  <a:solidFill>
-                    <a:srgbClr val="A7C74A"/>
-                  </a:solidFill>
-                </a:rPr>
-                <a:t>● </a:t>
-              </a:r>
-              <a:r>
-                <a:rPr lang="en-US" sz="1000" dirty="0" b="0" i="0">
-                  <a:solidFill>
-                    <a:schemeClr val="tx1"/>
-                  </a:solidFill>
-                </a:rPr>
-                <a:t>Разработка	11</a:t>
-              </a:r>
-              <a:r>
-                <a:rPr lang="en-US" sz="1000" dirty="0" b="0" i="0">
-                  <a:solidFill>
-                    <a:srgbClr val="6B7785"/>
-                  </a:solidFill>
-                </a:rPr>
-                <a:t> (8%)</a:t>
-              </a:r>
-              <a:endParaRPr lang="en-US" sz="1000" dirty="0" b="0" i="0">
-                <a:solidFill>
-                  <a:schemeClr val="tx1"/>
-                </a:solidFill>
-              </a:endParaRPr>
-            </a:p>
-            <a:p>
-              <a:pPr>
-                <a:lnSpc>
-                  <a:spcPct val="100000"/>
-                </a:lnSpc>
-                <a:spcAft>
-                  <a:spcPts val="170"/>
-                </a:spcAft>
-                <a:tabLst>
-                  <a:tab pos="1325880" algn="l"/>
-                </a:tabLst>
-              </a:pPr>
-              <a:r>
-                <a:rPr lang="en-US" sz="1000" dirty="0" b="0" i="0">
-                  <a:solidFill>
-                    <a:srgbClr val="F5A623"/>
-                  </a:solidFill>
-                </a:rPr>
-                <a:t>● </a:t>
-              </a:r>
-              <a:r>
-                <a:rPr lang="en-US" sz="1000" dirty="0" b="0" i="0">
-                  <a:solidFill>
-                    <a:schemeClr val="tx1"/>
-                  </a:solidFill>
-                </a:rPr>
-                <a:t>Методология, CX	6</a:t>
-              </a:r>
-              <a:r>
-                <a:rPr lang="en-US" sz="1000" dirty="0" b="0" i="0">
-                  <a:solidFill>
-                    <a:srgbClr val="6B7785"/>
-                  </a:solidFill>
-                </a:rPr>
-                <a:t> (5%)</a:t>
-              </a:r>
-              <a:endParaRPr lang="en-US" sz="1000" dirty="0" b="0" i="0">
-                <a:solidFill>
-                  <a:schemeClr val="tx1"/>
-                </a:solidFill>
-              </a:endParaRPr>
-            </a:p>
-            <a:p>
-              <a:pPr>
-                <a:lnSpc>
-                  <a:spcPct val="100000"/>
-                </a:lnSpc>
-                <a:spcAft>
-                  <a:spcPts val="170"/>
-                </a:spcAft>
-                <a:tabLst>
-                  <a:tab pos="1325880" algn="l"/>
-                </a:tabLst>
-              </a:pPr>
-              <a:r>
-                <a:rPr lang="en-US" sz="1000" dirty="0" b="0" i="0">
-                  <a:solidFill>
-                    <a:srgbClr val="8E6FC9"/>
-                  </a:solidFill>
-                </a:rPr>
-                <a:t>● </a:t>
-              </a:r>
-              <a:r>
-                <a:rPr lang="en-US" sz="1000" dirty="0" b="0" i="0">
-                  <a:solidFill>
-                    <a:schemeClr val="tx1"/>
-                  </a:solidFill>
-                </a:rPr>
-                <a:t>Support	3</a:t>
-              </a:r>
-              <a:r>
-                <a:rPr lang="en-US" sz="1000" dirty="0" b="0" i="0">
-                  <a:solidFill>
-                    <a:srgbClr val="6B7785"/>
-                  </a:solidFill>
-                </a:rPr>
-                <a:t> (2%)</a:t>
-              </a:r>
-              <a:endParaRPr lang="en-US" sz="1000" dirty="0" b="0" i="0">
-                <a:solidFill>
-                  <a:schemeClr val="tx1"/>
-                </a:solidFill>
-              </a:endParaRPr>
-            </a:p>
-            <a:p>
-              <a:pPr>
-                <a:lnSpc>
-                  <a:spcPct val="100000"/>
-                </a:lnSpc>
-                <a:spcAft>
-                  <a:spcPts val="170"/>
-                </a:spcAft>
-                <a:tabLst>
-                  <a:tab pos="1325880" algn="l"/>
-                </a:tabLst>
-              </a:pPr>
-              <a:r>
-                <a:rPr lang="en-US" sz="1000" dirty="0" b="0" i="0">
-                  <a:solidFill>
-                    <a:srgbClr val="2C3E6B"/>
-                  </a:solidFill>
-                </a:rPr>
-                <a:t>● </a:t>
-              </a:r>
-              <a:r>
-                <a:rPr lang="en-US" sz="1000" dirty="0" b="0" i="0">
-                  <a:solidFill>
-                    <a:schemeClr val="tx1"/>
-                  </a:solidFill>
-                </a:rPr>
-                <a:t>QA	2</a:t>
-              </a:r>
-              <a:r>
-                <a:rPr lang="en-US" sz="1000" dirty="0" b="0" i="0">
-                  <a:solidFill>
-                    <a:srgbClr val="6B7785"/>
-                  </a:solidFill>
-                </a:rPr>
-                <a:t> (1%)</a:t>
-              </a:r>
-              <a:endParaRPr lang="en-US" sz="1000" dirty="0" b="0" i="0">
-                <a:solidFill>
-                  <a:schemeClr val="tx1"/>
-                </a:solidFill>
-              </a:endParaRPr>
-            </a:p>
-          </p:txBody>
-        </p:sp>
       </p:grpSp>
       <p:grpSp>
         <p:nvGrpSpPr>

</xml_diff>